<commit_message>
Complétion de la partie A (unum)
</commit_message>
<xml_diff>
--- a/MEC8211-Devoir3.pptx
+++ b/MEC8211-Devoir3.pptx
@@ -7,12 +7,13 @@
   <p:sldIdLst>
     <p:sldId id="257" r:id="rId2"/>
     <p:sldId id="258" r:id="rId3"/>
-    <p:sldId id="264" r:id="rId4"/>
-    <p:sldId id="260" r:id="rId5"/>
-    <p:sldId id="261" r:id="rId6"/>
-    <p:sldId id="262" r:id="rId7"/>
-    <p:sldId id="263" r:id="rId8"/>
-    <p:sldId id="265" r:id="rId9"/>
+    <p:sldId id="266" r:id="rId4"/>
+    <p:sldId id="264" r:id="rId5"/>
+    <p:sldId id="260" r:id="rId6"/>
+    <p:sldId id="261" r:id="rId7"/>
+    <p:sldId id="262" r:id="rId8"/>
+    <p:sldId id="263" r:id="rId9"/>
+    <p:sldId id="265" r:id="rId10"/>
   </p:sldIdLst>
   <p:sldSz cx="12192000" cy="6858000"/>
   <p:notesSz cx="6858000" cy="9144000"/>
@@ -3612,48 +3613,748 @@
           </p:sp>
         </mc:Fallback>
       </mc:AlternateContent>
-      <p:sp>
-        <p:nvSpPr>
-          <p:cNvPr id="3" name="Espace réservé du contenu 2">
-            <a:extLst>
-              <a:ext uri="{FF2B5EF4-FFF2-40B4-BE49-F238E27FC236}">
-                <a16:creationId xmlns:a16="http://schemas.microsoft.com/office/drawing/2014/main" id="{22E80974-09C0-B5E5-C74A-D5162AC8CD95}"/>
-              </a:ext>
-            </a:extLst>
-          </p:cNvPr>
-          <p:cNvSpPr>
-            <a:spLocks noGrp="1"/>
-          </p:cNvSpPr>
-          <p:nvPr>
-            <p:ph idx="1"/>
-          </p:nvPr>
-        </p:nvSpPr>
-        <p:spPr/>
-        <p:txBody>
-          <a:bodyPr/>
-          <a:lstStyle/>
-          <a:p>
-            <a:r>
-              <a:rPr lang="fr-FR" dirty="0"/>
-              <a:t>Mesure de l’ordre de convergence observé </a:t>
-            </a:r>
-          </a:p>
-          <a:p>
-            <a:r>
-              <a:rPr lang="fr-FR" dirty="0"/>
-              <a:t>Calcul du </a:t>
-            </a:r>
-            <a:r>
-              <a:rPr lang="fr-FR" dirty="0" err="1"/>
-              <a:t>Grid</a:t>
-            </a:r>
-            <a:r>
-              <a:rPr lang="fr-FR" dirty="0"/>
-              <a:t> Convergence Index (p=2)</a:t>
-            </a:r>
-          </a:p>
-        </p:txBody>
-      </p:sp>
+      <mc:AlternateContent xmlns:mc="http://schemas.openxmlformats.org/markup-compatibility/2006">
+        <mc:Choice xmlns:a14="http://schemas.microsoft.com/office/drawing/2010/main" Requires="a14">
+          <p:sp>
+            <p:nvSpPr>
+              <p:cNvPr id="3" name="Espace réservé du contenu 2">
+                <a:extLst>
+                  <a:ext uri="{FF2B5EF4-FFF2-40B4-BE49-F238E27FC236}">
+                    <a16:creationId xmlns:a16="http://schemas.microsoft.com/office/drawing/2014/main" id="{22E80974-09C0-B5E5-C74A-D5162AC8CD95}"/>
+                  </a:ext>
+                </a:extLst>
+              </p:cNvPr>
+              <p:cNvSpPr>
+                <a:spLocks noGrp="1"/>
+              </p:cNvSpPr>
+              <p:nvPr>
+                <p:ph idx="1"/>
+              </p:nvPr>
+            </p:nvSpPr>
+            <p:spPr>
+              <a:xfrm>
+                <a:off x="838200" y="1013988"/>
+                <a:ext cx="10515600" cy="5939074"/>
+              </a:xfrm>
+            </p:spPr>
+            <p:txBody>
+              <a:bodyPr>
+                <a:normAutofit/>
+              </a:bodyPr>
+              <a:lstStyle/>
+              <a:p>
+                <a14:m>
+                  <m:oMath xmlns:m="http://schemas.openxmlformats.org/officeDocument/2006/math">
+                    <m:sSub>
+                      <m:sSubPr>
+                        <m:ctrlPr>
+                          <a:rPr lang="fr-FR" sz="2000" i="1" smtClean="0">
+                            <a:latin typeface="Cambria Math" panose="02040503050406030204" pitchFamily="18" charset="0"/>
+                          </a:rPr>
+                        </m:ctrlPr>
+                      </m:sSubPr>
+                      <m:e>
+                        <m:r>
+                          <a:rPr lang="fr-FR" sz="2000" i="1">
+                            <a:latin typeface="Cambria Math" panose="02040503050406030204" pitchFamily="18" charset="0"/>
+                          </a:rPr>
+                          <m:t>𝑢</m:t>
+                        </m:r>
+                      </m:e>
+                      <m:sub>
+                        <m:r>
+                          <a:rPr lang="fr-FR" sz="2000" i="1">
+                            <a:latin typeface="Cambria Math" panose="02040503050406030204" pitchFamily="18" charset="0"/>
+                          </a:rPr>
+                          <m:t>𝑛𝑢𝑚</m:t>
+                        </m:r>
+                      </m:sub>
+                    </m:sSub>
+                  </m:oMath>
+                </a14:m>
+                <a:r>
+                  <a:rPr lang="fr-FR" sz="2000" dirty="0"/>
+                  <a:t> peut être calculé à l’aide du GCI (</a:t>
+                </a:r>
+                <a:r>
+                  <a:rPr lang="fr-FR" sz="2000" i="1" dirty="0" err="1"/>
+                  <a:t>Grid</a:t>
+                </a:r>
+                <a:r>
+                  <a:rPr lang="fr-FR" sz="2000" i="1" dirty="0"/>
+                  <a:t> Convergence Index</a:t>
+                </a:r>
+                <a:r>
+                  <a:rPr lang="fr-FR" sz="2000" dirty="0"/>
+                  <a:t>)</a:t>
+                </a:r>
+              </a:p>
+              <a:p>
+                <a:r>
+                  <a:rPr lang="fr-FR" sz="2000" dirty="0"/>
+                  <a:t>GCI donne une évaluation conservative de l’incertitude à 95% de fiabilité. On conclu donc que </a:t>
+                </a:r>
+                <a14:m>
+                  <m:oMath xmlns:m="http://schemas.openxmlformats.org/officeDocument/2006/math">
+                    <m:sSub>
+                      <m:sSubPr>
+                        <m:ctrlPr>
+                          <a:rPr lang="fr-CA" sz="2000" b="0" i="1" smtClean="0">
+                            <a:latin typeface="Cambria Math" panose="02040503050406030204" pitchFamily="18" charset="0"/>
+                          </a:rPr>
+                        </m:ctrlPr>
+                      </m:sSubPr>
+                      <m:e>
+                        <m:r>
+                          <a:rPr lang="fr-CA" sz="2000" b="0" i="1" smtClean="0">
+                            <a:latin typeface="Cambria Math" panose="02040503050406030204" pitchFamily="18" charset="0"/>
+                          </a:rPr>
+                          <m:t>𝑢</m:t>
+                        </m:r>
+                      </m:e>
+                      <m:sub>
+                        <m:r>
+                          <a:rPr lang="fr-CA" sz="2000" b="0" i="1" smtClean="0">
+                            <a:latin typeface="Cambria Math" panose="02040503050406030204" pitchFamily="18" charset="0"/>
+                          </a:rPr>
+                          <m:t>𝑛𝑢𝑚</m:t>
+                        </m:r>
+                      </m:sub>
+                    </m:sSub>
+                    <m:r>
+                      <a:rPr lang="fr-CA" sz="2000" b="0" i="1" smtClean="0">
+                        <a:latin typeface="Cambria Math" panose="02040503050406030204" pitchFamily="18" charset="0"/>
+                      </a:rPr>
+                      <m:t>=</m:t>
+                    </m:r>
+                    <m:f>
+                      <m:fPr>
+                        <m:ctrlPr>
+                          <a:rPr lang="fr-CA" sz="2000" b="0" i="1" smtClean="0">
+                            <a:latin typeface="Cambria Math" panose="02040503050406030204" pitchFamily="18" charset="0"/>
+                          </a:rPr>
+                        </m:ctrlPr>
+                      </m:fPr>
+                      <m:num>
+                        <m:r>
+                          <a:rPr lang="fr-CA" sz="2000" b="0" i="1" smtClean="0">
+                            <a:latin typeface="Cambria Math" panose="02040503050406030204" pitchFamily="18" charset="0"/>
+                          </a:rPr>
+                          <m:t>𝐺𝐶𝐼</m:t>
+                        </m:r>
+                      </m:num>
+                      <m:den>
+                        <m:r>
+                          <a:rPr lang="fr-CA" sz="2000" b="0" i="1" smtClean="0">
+                            <a:latin typeface="Cambria Math" panose="02040503050406030204" pitchFamily="18" charset="0"/>
+                          </a:rPr>
+                          <m:t>2</m:t>
+                        </m:r>
+                      </m:den>
+                    </m:f>
+                  </m:oMath>
+                </a14:m>
+                <a:r>
+                  <a:rPr lang="fr-FR" sz="2000" dirty="0"/>
+                  <a:t>, pour rester cohérent avec le facteur de couverture, </a:t>
+                </a:r>
+                <a14:m>
+                  <m:oMath xmlns:m="http://schemas.openxmlformats.org/officeDocument/2006/math">
+                    <m:r>
+                      <a:rPr lang="fr-CA" sz="2000" b="0" i="1" smtClean="0">
+                        <a:latin typeface="Cambria Math" panose="02040503050406030204" pitchFamily="18" charset="0"/>
+                      </a:rPr>
+                      <m:t>𝑘</m:t>
+                    </m:r>
+                    <m:r>
+                      <a:rPr lang="fr-CA" sz="2000" b="0" i="1" smtClean="0">
+                        <a:latin typeface="Cambria Math" panose="02040503050406030204" pitchFamily="18" charset="0"/>
+                      </a:rPr>
+                      <m:t>=2</m:t>
+                    </m:r>
+                  </m:oMath>
+                </a14:m>
+                <a:r>
+                  <a:rPr lang="fr-FR" sz="2000" dirty="0"/>
+                  <a:t>.</a:t>
+                </a:r>
+              </a:p>
+              <a:p>
+                <a:r>
+                  <a:rPr lang="fr-FR" sz="2000" dirty="0"/>
+                  <a:t>GCI est calculé de la manière suivante (</a:t>
+                </a:r>
+                <a:r>
+                  <a:rPr lang="fr-FR" sz="2000" i="1" dirty="0"/>
+                  <a:t>Figure 1</a:t>
+                </a:r>
+                <a:r>
+                  <a:rPr lang="fr-FR" sz="2000" dirty="0"/>
+                  <a:t>) : </a:t>
+                </a:r>
+                <a:br>
+                  <a:rPr lang="fr-FR" sz="2000" dirty="0"/>
+                </a:br>
+                <a:r>
+                  <a:rPr lang="fr-FR" sz="2000" dirty="0"/>
+                  <a:t>	où </a:t>
+                </a:r>
+                <a14:m>
+                  <m:oMath xmlns:m="http://schemas.openxmlformats.org/officeDocument/2006/math">
+                    <m:sSub>
+                      <m:sSubPr>
+                        <m:ctrlPr>
+                          <a:rPr lang="fr-CA" sz="2000" b="0" i="1" smtClean="0">
+                            <a:latin typeface="Cambria Math" panose="02040503050406030204" pitchFamily="18" charset="0"/>
+                          </a:rPr>
+                        </m:ctrlPr>
+                      </m:sSubPr>
+                      <m:e>
+                        <m:r>
+                          <a:rPr lang="fr-CA" sz="2000" b="0" i="1" smtClean="0">
+                            <a:latin typeface="Cambria Math" panose="02040503050406030204" pitchFamily="18" charset="0"/>
+                          </a:rPr>
+                          <m:t>𝑝</m:t>
+                        </m:r>
+                      </m:e>
+                      <m:sub>
+                        <m:r>
+                          <a:rPr lang="fr-CA" sz="2000" b="0" i="1" smtClean="0">
+                            <a:latin typeface="Cambria Math" panose="02040503050406030204" pitchFamily="18" charset="0"/>
+                          </a:rPr>
+                          <m:t>𝑓</m:t>
+                        </m:r>
+                      </m:sub>
+                    </m:sSub>
+                  </m:oMath>
+                </a14:m>
+                <a:r>
+                  <a:rPr lang="fr-FR" sz="2000" dirty="0"/>
+                  <a:t> est l’ordre théorique en espace, soit 2,</a:t>
+                </a:r>
+                <a:br>
+                  <a:rPr lang="fr-FR" sz="2000" dirty="0"/>
+                </a:br>
+                <a:r>
+                  <a:rPr lang="fr-FR" sz="2000" dirty="0"/>
+                  <a:t>	et </a:t>
+                </a:r>
+                <a14:m>
+                  <m:oMath xmlns:m="http://schemas.openxmlformats.org/officeDocument/2006/math">
+                    <m:acc>
+                      <m:accPr>
+                        <m:chr m:val="̂"/>
+                        <m:ctrlPr>
+                          <a:rPr lang="fr-CA" sz="2000" b="0" i="1" smtClean="0">
+                            <a:latin typeface="Cambria Math" panose="02040503050406030204" pitchFamily="18" charset="0"/>
+                          </a:rPr>
+                        </m:ctrlPr>
+                      </m:accPr>
+                      <m:e>
+                        <m:r>
+                          <a:rPr lang="fr-CA" sz="2000" b="0" i="1" smtClean="0">
+                            <a:latin typeface="Cambria Math" panose="02040503050406030204" pitchFamily="18" charset="0"/>
+                          </a:rPr>
+                          <m:t>𝑝</m:t>
+                        </m:r>
+                      </m:e>
+                    </m:acc>
+                  </m:oMath>
+                </a14:m>
+                <a:r>
+                  <a:rPr lang="fr-FR" sz="2000" dirty="0"/>
+                  <a:t> est l’ordre observé.</a:t>
+                </a:r>
+              </a:p>
+              <a:p>
+                <a:r>
+                  <a:rPr lang="fr-FR" sz="2000" dirty="0"/>
+                  <a:t>Pour mesurer l’ordre </a:t>
+                </a:r>
+                <a14:m>
+                  <m:oMath xmlns:m="http://schemas.openxmlformats.org/officeDocument/2006/math">
+                    <m:acc>
+                      <m:accPr>
+                        <m:chr m:val="̂"/>
+                        <m:ctrlPr>
+                          <a:rPr lang="fr-FR" sz="2000" i="1" smtClean="0">
+                            <a:latin typeface="Cambria Math" panose="02040503050406030204" pitchFamily="18" charset="0"/>
+                          </a:rPr>
+                        </m:ctrlPr>
+                      </m:accPr>
+                      <m:e>
+                        <m:r>
+                          <a:rPr lang="fr-CA" sz="2000" b="0" i="1" smtClean="0">
+                            <a:latin typeface="Cambria Math" panose="02040503050406030204" pitchFamily="18" charset="0"/>
+                          </a:rPr>
+                          <m:t>𝑝</m:t>
+                        </m:r>
+                      </m:e>
+                    </m:acc>
+                  </m:oMath>
+                </a14:m>
+                <a:r>
+                  <a:rPr lang="fr-FR" sz="2000" dirty="0"/>
+                  <a:t>, comme on travaille avec des</a:t>
+                </a:r>
+                <a:br>
+                  <a:rPr lang="fr-FR" sz="2000" dirty="0"/>
+                </a:br>
+                <a:r>
+                  <a:rPr lang="fr-FR" sz="2000" dirty="0"/>
+                  <a:t>données stochastiques, on propose la méthodologie</a:t>
+                </a:r>
+                <a:br>
+                  <a:rPr lang="fr-FR" sz="2000" dirty="0"/>
+                </a:br>
+                <a:r>
+                  <a:rPr lang="fr-FR" sz="2000" dirty="0"/>
+                  <a:t>suivante :</a:t>
+                </a:r>
+              </a:p>
+              <a:p>
+                <a:pPr marL="800100" lvl="1" indent="-342900">
+                  <a:buFont typeface="+mj-lt"/>
+                  <a:buAutoNum type="arabicPeriod"/>
+                </a:pPr>
+                <a:r>
+                  <a:rPr lang="fr-FR" sz="1600" dirty="0"/>
+                  <a:t>Générer un nombre aléatoire avec un </a:t>
+                </a:r>
+                <a:r>
+                  <a:rPr lang="fr-FR" sz="1600" i="1" dirty="0" err="1"/>
+                  <a:t>seed</a:t>
+                </a:r>
+                <a:r>
+                  <a:rPr lang="fr-FR" sz="1600" dirty="0"/>
+                  <a:t> précis pour générer</a:t>
+                </a:r>
+                <a:br>
+                  <a:rPr lang="fr-FR" sz="1600" dirty="0"/>
+                </a:br>
+                <a:r>
+                  <a:rPr lang="fr-FR" sz="1600" dirty="0"/>
+                  <a:t>une simulation du matériau du filtre.</a:t>
+                </a:r>
+              </a:p>
+              <a:p>
+                <a:pPr marL="800100" lvl="1" indent="-342900">
+                  <a:buFont typeface="+mj-lt"/>
+                  <a:buAutoNum type="arabicPeriod"/>
+                </a:pPr>
+                <a:r>
+                  <a:rPr lang="fr-FR" sz="1600" dirty="0"/>
+                  <a:t>Simuler l’écoulement pour le </a:t>
+                </a:r>
+                <a:r>
+                  <a:rPr lang="fr-FR" sz="1600" i="1" dirty="0" err="1"/>
+                  <a:t>seed</a:t>
+                </a:r>
+                <a:r>
+                  <a:rPr lang="fr-FR" sz="1600" dirty="0"/>
+                  <a:t> choisi pour un ensemble de maillages raffinés, en gardant une épaisseur constante (</a:t>
+                </a:r>
+                <a14:m>
+                  <m:oMath xmlns:m="http://schemas.openxmlformats.org/officeDocument/2006/math">
+                    <m:r>
+                      <a:rPr lang="fr-FR" sz="1600" i="1" smtClean="0">
+                        <a:latin typeface="Cambria Math" panose="02040503050406030204" pitchFamily="18" charset="0"/>
+                        <a:ea typeface="Cambria Math" panose="02040503050406030204" pitchFamily="18" charset="0"/>
+                      </a:rPr>
+                      <m:t>∆</m:t>
+                    </m:r>
+                    <m:r>
+                      <a:rPr lang="fr-CA" sz="1600" b="0" i="1" smtClean="0">
+                        <a:latin typeface="Cambria Math" panose="02040503050406030204" pitchFamily="18" charset="0"/>
+                        <a:ea typeface="Cambria Math" panose="02040503050406030204" pitchFamily="18" charset="0"/>
+                      </a:rPr>
+                      <m:t>𝑥</m:t>
+                    </m:r>
+                    <m:r>
+                      <a:rPr lang="fr-CA" sz="1600" b="0" i="1" smtClean="0">
+                        <a:latin typeface="Cambria Math" panose="02040503050406030204" pitchFamily="18" charset="0"/>
+                        <a:ea typeface="Cambria Math" panose="02040503050406030204" pitchFamily="18" charset="0"/>
+                      </a:rPr>
+                      <m:t> </m:t>
+                    </m:r>
+                    <m:sSub>
+                      <m:sSubPr>
+                        <m:ctrlPr>
+                          <a:rPr lang="fr-CA" sz="1600" b="0" i="1" smtClean="0">
+                            <a:latin typeface="Cambria Math" panose="02040503050406030204" pitchFamily="18" charset="0"/>
+                            <a:ea typeface="Cambria Math" panose="02040503050406030204" pitchFamily="18" charset="0"/>
+                          </a:rPr>
+                        </m:ctrlPr>
+                      </m:sSubPr>
+                      <m:e>
+                        <m:r>
+                          <a:rPr lang="fr-CA" sz="1600" b="0" i="1" smtClean="0">
+                            <a:latin typeface="Cambria Math" panose="02040503050406030204" pitchFamily="18" charset="0"/>
+                            <a:ea typeface="Cambria Math" panose="02040503050406030204" pitchFamily="18" charset="0"/>
+                          </a:rPr>
+                          <m:t>𝑁</m:t>
+                        </m:r>
+                      </m:e>
+                      <m:sub>
+                        <m:r>
+                          <a:rPr lang="fr-CA" sz="1600" b="0" i="1" smtClean="0">
+                            <a:latin typeface="Cambria Math" panose="02040503050406030204" pitchFamily="18" charset="0"/>
+                            <a:ea typeface="Cambria Math" panose="02040503050406030204" pitchFamily="18" charset="0"/>
+                          </a:rPr>
+                          <m:t>𝑥</m:t>
+                        </m:r>
+                      </m:sub>
+                    </m:sSub>
+                    <m:r>
+                      <a:rPr lang="fr-CA" sz="1600" b="0" i="1" smtClean="0">
+                        <a:latin typeface="Cambria Math" panose="02040503050406030204" pitchFamily="18" charset="0"/>
+                        <a:ea typeface="Cambria Math" panose="02040503050406030204" pitchFamily="18" charset="0"/>
+                      </a:rPr>
+                      <m:t>=</m:t>
+                    </m:r>
+                    <m:sSub>
+                      <m:sSubPr>
+                        <m:ctrlPr>
+                          <a:rPr lang="fr-CA" sz="1600" b="0" i="1" smtClean="0">
+                            <a:latin typeface="Cambria Math" panose="02040503050406030204" pitchFamily="18" charset="0"/>
+                            <a:ea typeface="Cambria Math" panose="02040503050406030204" pitchFamily="18" charset="0"/>
+                          </a:rPr>
+                        </m:ctrlPr>
+                      </m:sSubPr>
+                      <m:e>
+                        <m:r>
+                          <a:rPr lang="fr-CA" sz="1600" b="0" i="1" smtClean="0">
+                            <a:latin typeface="Cambria Math" panose="02040503050406030204" pitchFamily="18" charset="0"/>
+                            <a:ea typeface="Cambria Math" panose="02040503050406030204" pitchFamily="18" charset="0"/>
+                          </a:rPr>
+                          <m:t>h</m:t>
+                        </m:r>
+                      </m:e>
+                      <m:sub>
+                        <m:r>
+                          <a:rPr lang="fr-CA" sz="1600" b="0" i="1" smtClean="0">
+                            <a:latin typeface="Cambria Math" panose="02040503050406030204" pitchFamily="18" charset="0"/>
+                            <a:ea typeface="Cambria Math" panose="02040503050406030204" pitchFamily="18" charset="0"/>
+                          </a:rPr>
+                          <m:t>𝑐𝑠𝑡</m:t>
+                        </m:r>
+                      </m:sub>
+                    </m:sSub>
+                    <m:r>
+                      <a:rPr lang="fr-CA" sz="1600" b="0" i="1" smtClean="0">
+                        <a:latin typeface="Cambria Math" panose="02040503050406030204" pitchFamily="18" charset="0"/>
+                        <a:ea typeface="Cambria Math" panose="02040503050406030204" pitchFamily="18" charset="0"/>
+                      </a:rPr>
+                      <m:t>)</m:t>
+                    </m:r>
+                  </m:oMath>
+                </a14:m>
+                <a:r>
+                  <a:rPr lang="fr-FR" sz="1600" dirty="0"/>
+                  <a:t>.</a:t>
+                </a:r>
+              </a:p>
+              <a:p>
+                <a:pPr marL="800100" lvl="1" indent="-342900">
+                  <a:buFont typeface="+mj-lt"/>
+                  <a:buAutoNum type="arabicPeriod"/>
+                </a:pPr>
+                <a:r>
+                  <a:rPr lang="fr-FR" sz="1600" dirty="0"/>
+                  <a:t>Répéter les étapes 1 et 2 pour plusieurs </a:t>
+                </a:r>
+                <a:r>
+                  <a:rPr lang="fr-FR" sz="1600" i="1" dirty="0" err="1"/>
+                  <a:t>seeds</a:t>
+                </a:r>
+                <a:r>
+                  <a:rPr lang="fr-FR" sz="1600" i="1" dirty="0"/>
+                  <a:t> </a:t>
+                </a:r>
+                <a:r>
+                  <a:rPr lang="fr-FR" sz="1600" dirty="0"/>
+                  <a:t>différents (dans ce cas, 3)</a:t>
+                </a:r>
+              </a:p>
+              <a:p>
+                <a:pPr marL="800100" lvl="1" indent="-342900">
+                  <a:buFont typeface="+mj-lt"/>
+                  <a:buAutoNum type="arabicPeriod"/>
+                </a:pPr>
+                <a:r>
+                  <a:rPr lang="fr-FR" sz="1600" dirty="0"/>
+                  <a:t>Évaluer la convergence de l’erreur relative par rapport à la solution fine (</a:t>
+                </a:r>
+                <a14:m>
+                  <m:oMath xmlns:m="http://schemas.openxmlformats.org/officeDocument/2006/math">
+                    <m:r>
+                      <a:rPr lang="fr-CA" sz="1600" b="0" i="1" smtClean="0">
+                        <a:latin typeface="Cambria Math" panose="02040503050406030204" pitchFamily="18" charset="0"/>
+                      </a:rPr>
+                      <m:t>𝑁𝑥</m:t>
+                    </m:r>
+                    <m:r>
+                      <a:rPr lang="fr-CA" sz="1600" b="0" i="1" smtClean="0">
+                        <a:latin typeface="Cambria Math" panose="02040503050406030204" pitchFamily="18" charset="0"/>
+                      </a:rPr>
+                      <m:t>=400</m:t>
+                    </m:r>
+                  </m:oMath>
+                </a14:m>
+                <a:r>
+                  <a:rPr lang="fr-FR" sz="1600" dirty="0"/>
+                  <a:t>) de la </a:t>
+                </a:r>
+                <a:r>
+                  <a:rPr lang="fr-FR" sz="1600" b="1" dirty="0"/>
+                  <a:t>moyenne</a:t>
+                </a:r>
+                <a:r>
+                  <a:rPr lang="fr-FR" sz="1600" dirty="0"/>
+                  <a:t> des valeurs de k obtenues à chaque maillage.</a:t>
+                </a:r>
+              </a:p>
+              <a:p>
+                <a:r>
+                  <a:rPr lang="fr-FR" sz="2000" dirty="0"/>
+                  <a:t>Les différentes simulations proposées ci-dessus ont été générés à l’aide du script </a:t>
+                </a:r>
+                <a:r>
+                  <a:rPr lang="fr-FR" sz="2000" i="1" dirty="0"/>
+                  <a:t>convergence_ devoir_3.bs</a:t>
+                </a:r>
+                <a:r>
+                  <a:rPr lang="fr-FR" sz="2000" dirty="0"/>
+                  <a:t>, qui lance aussi le fichier </a:t>
+                </a:r>
+                <a:r>
+                  <a:rPr lang="fr-FR" sz="2000" i="1" dirty="0"/>
+                  <a:t>GCI.py</a:t>
+                </a:r>
+                <a:r>
+                  <a:rPr lang="fr-FR" sz="2000" dirty="0"/>
+                  <a:t> afin de traiter les données et de calculer l’incertitude </a:t>
+                </a:r>
+                <a14:m>
+                  <m:oMath xmlns:m="http://schemas.openxmlformats.org/officeDocument/2006/math">
+                    <m:sSub>
+                      <m:sSubPr>
+                        <m:ctrlPr>
+                          <a:rPr lang="fr-CA" sz="2000" b="0" i="1" smtClean="0">
+                            <a:latin typeface="Cambria Math" panose="02040503050406030204" pitchFamily="18" charset="0"/>
+                          </a:rPr>
+                        </m:ctrlPr>
+                      </m:sSubPr>
+                      <m:e>
+                        <m:r>
+                          <a:rPr lang="fr-CA" sz="2000" b="0" i="1" smtClean="0">
+                            <a:latin typeface="Cambria Math" panose="02040503050406030204" pitchFamily="18" charset="0"/>
+                          </a:rPr>
+                          <m:t>𝑢</m:t>
+                        </m:r>
+                      </m:e>
+                      <m:sub>
+                        <m:r>
+                          <a:rPr lang="fr-CA" sz="2000" b="0" i="1" smtClean="0">
+                            <a:latin typeface="Cambria Math" panose="02040503050406030204" pitchFamily="18" charset="0"/>
+                          </a:rPr>
+                          <m:t>𝑛𝑢𝑚</m:t>
+                        </m:r>
+                      </m:sub>
+                    </m:sSub>
+                  </m:oMath>
+                </a14:m>
+                <a:r>
+                  <a:rPr lang="fr-FR" sz="2000" i="1" dirty="0"/>
+                  <a:t>.</a:t>
+                </a:r>
+              </a:p>
+            </p:txBody>
+          </p:sp>
+        </mc:Choice>
+        <mc:Fallback>
+          <p:sp>
+            <p:nvSpPr>
+              <p:cNvPr id="3" name="Espace réservé du contenu 2">
+                <a:extLst>
+                  <a:ext uri="{FF2B5EF4-FFF2-40B4-BE49-F238E27FC236}">
+                    <a16:creationId xmlns:a16="http://schemas.microsoft.com/office/drawing/2014/main" id="{22E80974-09C0-B5E5-C74A-D5162AC8CD95}"/>
+                  </a:ext>
+                </a:extLst>
+              </p:cNvPr>
+              <p:cNvSpPr>
+                <a:spLocks noGrp="1" noRot="1" noChangeAspect="1" noMove="1" noResize="1" noEditPoints="1" noAdjustHandles="1" noChangeArrowheads="1" noChangeShapeType="1" noTextEdit="1"/>
+              </p:cNvSpPr>
+              <p:nvPr>
+                <p:ph idx="1"/>
+              </p:nvPr>
+            </p:nvSpPr>
+            <p:spPr>
+              <a:xfrm>
+                <a:off x="838200" y="1013988"/>
+                <a:ext cx="10515600" cy="5939074"/>
+              </a:xfrm>
+              <a:blipFill>
+                <a:blip r:embed="rId3"/>
+                <a:stretch>
+                  <a:fillRect l="-522" t="-923"/>
+                </a:stretch>
+              </a:blipFill>
+            </p:spPr>
+            <p:txBody>
+              <a:bodyPr/>
+              <a:lstStyle/>
+              <a:p>
+                <a:r>
+                  <a:rPr lang="fr-CA">
+                    <a:noFill/>
+                  </a:rPr>
+                  <a:t> </a:t>
+                </a:r>
+              </a:p>
+            </p:txBody>
+          </p:sp>
+        </mc:Fallback>
+      </mc:AlternateContent>
+      <p:grpSp>
+        <p:nvGrpSpPr>
+          <p:cNvPr id="10" name="Groupe 9">
+            <a:extLst>
+              <a:ext uri="{FF2B5EF4-FFF2-40B4-BE49-F238E27FC236}">
+                <a16:creationId xmlns:a16="http://schemas.microsoft.com/office/drawing/2014/main" id="{C818C4AC-8626-2E5D-6FED-B13F5EE24EE3}"/>
+              </a:ext>
+            </a:extLst>
+          </p:cNvPr>
+          <p:cNvGrpSpPr/>
+          <p:nvPr/>
+        </p:nvGrpSpPr>
+        <p:grpSpPr>
+          <a:xfrm>
+            <a:off x="7756401" y="2230909"/>
+            <a:ext cx="2467451" cy="2159060"/>
+            <a:chOff x="7756401" y="2339551"/>
+            <a:chExt cx="2467451" cy="2159060"/>
+          </a:xfrm>
+        </p:grpSpPr>
+        <p:grpSp>
+          <p:nvGrpSpPr>
+            <p:cNvPr id="8" name="Groupe 7">
+              <a:extLst>
+                <a:ext uri="{FF2B5EF4-FFF2-40B4-BE49-F238E27FC236}">
+                  <a16:creationId xmlns:a16="http://schemas.microsoft.com/office/drawing/2014/main" id="{EE74B48D-2513-0199-37D8-0FC3A518E2C0}"/>
+                </a:ext>
+              </a:extLst>
+            </p:cNvPr>
+            <p:cNvGrpSpPr/>
+            <p:nvPr/>
+          </p:nvGrpSpPr>
+          <p:grpSpPr>
+            <a:xfrm>
+              <a:off x="7756401" y="2339551"/>
+              <a:ext cx="2467451" cy="1631805"/>
+              <a:chOff x="5541169" y="2940195"/>
+              <a:chExt cx="3005875" cy="2225722"/>
+            </a:xfrm>
+          </p:grpSpPr>
+          <p:pic>
+            <p:nvPicPr>
+              <p:cNvPr id="5" name="Image 4">
+                <a:extLst>
+                  <a:ext uri="{FF2B5EF4-FFF2-40B4-BE49-F238E27FC236}">
+                    <a16:creationId xmlns:a16="http://schemas.microsoft.com/office/drawing/2014/main" id="{2331C906-EF82-6CDB-6CA7-2BC81AC0AF48}"/>
+                  </a:ext>
+                </a:extLst>
+              </p:cNvPr>
+              <p:cNvPicPr>
+                <a:picLocks noChangeAspect="1"/>
+              </p:cNvPicPr>
+              <p:nvPr/>
+            </p:nvPicPr>
+            <p:blipFill>
+              <a:blip r:embed="rId4"/>
+              <a:srcRect l="910"/>
+              <a:stretch>
+                <a:fillRect/>
+              </a:stretch>
+            </p:blipFill>
+            <p:spPr>
+              <a:xfrm>
+                <a:off x="5541169" y="2940195"/>
+                <a:ext cx="3005875" cy="552179"/>
+              </a:xfrm>
+              <a:prstGeom prst="rect">
+                <a:avLst/>
+              </a:prstGeom>
+            </p:spPr>
+          </p:pic>
+          <p:pic>
+            <p:nvPicPr>
+              <p:cNvPr id="7" name="Image 6">
+                <a:extLst>
+                  <a:ext uri="{FF2B5EF4-FFF2-40B4-BE49-F238E27FC236}">
+                    <a16:creationId xmlns:a16="http://schemas.microsoft.com/office/drawing/2014/main" id="{90B22E26-E316-4E03-D3FF-4DA9AE7C745C}"/>
+                  </a:ext>
+                </a:extLst>
+              </p:cNvPr>
+              <p:cNvPicPr>
+                <a:picLocks noChangeAspect="1"/>
+              </p:cNvPicPr>
+              <p:nvPr/>
+            </p:nvPicPr>
+            <p:blipFill>
+              <a:blip r:embed="rId5"/>
+              <a:stretch>
+                <a:fillRect/>
+              </a:stretch>
+            </p:blipFill>
+            <p:spPr>
+              <a:xfrm>
+                <a:off x="5541169" y="3492375"/>
+                <a:ext cx="3005875" cy="1673542"/>
+              </a:xfrm>
+              <a:prstGeom prst="rect">
+                <a:avLst/>
+              </a:prstGeom>
+            </p:spPr>
+          </p:pic>
+        </p:grpSp>
+        <p:sp>
+          <p:nvSpPr>
+            <p:cNvPr id="9" name="ZoneTexte 8">
+              <a:extLst>
+                <a:ext uri="{FF2B5EF4-FFF2-40B4-BE49-F238E27FC236}">
+                  <a16:creationId xmlns:a16="http://schemas.microsoft.com/office/drawing/2014/main" id="{F622CA0B-9153-A67C-34BC-994D0DC1A366}"/>
+                </a:ext>
+              </a:extLst>
+            </p:cNvPr>
+            <p:cNvSpPr txBox="1"/>
+            <p:nvPr/>
+          </p:nvSpPr>
+          <p:spPr>
+            <a:xfrm>
+              <a:off x="7756401" y="4083113"/>
+              <a:ext cx="2467451" cy="415498"/>
+            </a:xfrm>
+            <a:prstGeom prst="rect">
+              <a:avLst/>
+            </a:prstGeom>
+            <a:noFill/>
+          </p:spPr>
+          <p:txBody>
+            <a:bodyPr wrap="square" rtlCol="0">
+              <a:spAutoFit/>
+            </a:bodyPr>
+            <a:lstStyle/>
+            <a:p>
+              <a:pPr algn="ctr"/>
+              <a:r>
+                <a:rPr lang="fr-CA" sz="1050" i="1" dirty="0"/>
+                <a:t>Figure 1: Méthodologie de calcul du GCI.</a:t>
+              </a:r>
+            </a:p>
+          </p:txBody>
+        </p:sp>
+      </p:grpSp>
     </p:spTree>
     <p:extLst>
       <p:ext uri="{BB962C8B-B14F-4D97-AF65-F5344CB8AC3E}">
@@ -3672,6 +4373,766 @@
   <p:cSld>
     <p:spTree>
       <p:nvGrpSpPr>
+        <p:cNvPr id="1" name="">
+          <a:extLst>
+            <a:ext uri="{FF2B5EF4-FFF2-40B4-BE49-F238E27FC236}">
+              <a16:creationId xmlns:a16="http://schemas.microsoft.com/office/drawing/2014/main" id="{42540B2C-51A7-2196-FA74-78EBBE4CA85C}"/>
+            </a:ext>
+          </a:extLst>
+        </p:cNvPr>
+        <p:cNvGrpSpPr/>
+        <p:nvPr/>
+      </p:nvGrpSpPr>
+      <p:grpSpPr>
+        <a:xfrm>
+          <a:off x="0" y="0"/>
+          <a:ext cx="0" cy="0"/>
+          <a:chOff x="0" y="0"/>
+          <a:chExt cx="0" cy="0"/>
+        </a:xfrm>
+      </p:grpSpPr>
+      <mc:AlternateContent xmlns:mc="http://schemas.openxmlformats.org/markup-compatibility/2006" xmlns:a14="http://schemas.microsoft.com/office/drawing/2010/main">
+        <mc:Choice Requires="a14">
+          <p:sp>
+            <p:nvSpPr>
+              <p:cNvPr id="2" name="Titre 1">
+                <a:extLst>
+                  <a:ext uri="{FF2B5EF4-FFF2-40B4-BE49-F238E27FC236}">
+                    <a16:creationId xmlns:a16="http://schemas.microsoft.com/office/drawing/2014/main" id="{ACD25E7A-0970-4CEE-B873-7AE5FFC4807E}"/>
+                  </a:ext>
+                </a:extLst>
+              </p:cNvPr>
+              <p:cNvSpPr>
+                <a:spLocks noGrp="1"/>
+              </p:cNvSpPr>
+              <p:nvPr>
+                <p:ph type="title"/>
+              </p:nvPr>
+            </p:nvSpPr>
+            <p:spPr>
+              <a:xfrm>
+                <a:off x="838200" y="255321"/>
+                <a:ext cx="10515600" cy="1325563"/>
+              </a:xfrm>
+            </p:spPr>
+            <p:txBody>
+              <a:bodyPr>
+                <a:normAutofit/>
+              </a:bodyPr>
+              <a:lstStyle/>
+              <a:p>
+                <a:r>
+                  <a:rPr lang="fr-FR" dirty="0"/>
+                  <a:t>A) Incertitude numérique </a:t>
+                </a:r>
+                <a14:m>
+                  <m:oMath xmlns:m="http://schemas.openxmlformats.org/officeDocument/2006/math">
+                    <m:sSub>
+                      <m:sSubPr>
+                        <m:ctrlPr>
+                          <a:rPr lang="fr-FR" b="0" i="1" smtClean="0">
+                            <a:latin typeface="Cambria Math" panose="02040503050406030204" pitchFamily="18" charset="0"/>
+                          </a:rPr>
+                        </m:ctrlPr>
+                      </m:sSubPr>
+                      <m:e>
+                        <m:r>
+                          <a:rPr lang="fr-FR" b="0" i="1" smtClean="0">
+                            <a:latin typeface="Cambria Math" panose="02040503050406030204" pitchFamily="18" charset="0"/>
+                          </a:rPr>
+                          <m:t>𝑢</m:t>
+                        </m:r>
+                      </m:e>
+                      <m:sub>
+                        <m:r>
+                          <a:rPr lang="fr-FR" b="0" i="1" smtClean="0">
+                            <a:latin typeface="Cambria Math" panose="02040503050406030204" pitchFamily="18" charset="0"/>
+                          </a:rPr>
+                          <m:t>𝑛𝑢𝑚</m:t>
+                        </m:r>
+                      </m:sub>
+                    </m:sSub>
+                  </m:oMath>
+                </a14:m>
+                <a:br>
+                  <a:rPr lang="fr-FR" b="0" dirty="0"/>
+                </a:br>
+                <a:endParaRPr lang="fr-FR" dirty="0"/>
+              </a:p>
+            </p:txBody>
+          </p:sp>
+        </mc:Choice>
+        <mc:Fallback xmlns="">
+          <p:sp>
+            <p:nvSpPr>
+              <p:cNvPr id="2" name="Titre 1">
+                <a:extLst>
+                  <a:ext uri="{FF2B5EF4-FFF2-40B4-BE49-F238E27FC236}">
+                    <a16:creationId xmlns:a16="http://schemas.microsoft.com/office/drawing/2014/main" id="{E7D87B06-2293-46A9-1B49-5FA555DC4644}"/>
+                  </a:ext>
+                </a:extLst>
+              </p:cNvPr>
+              <p:cNvSpPr>
+                <a:spLocks noGrp="1" noRot="1" noChangeAspect="1" noMove="1" noResize="1" noEditPoints="1" noAdjustHandles="1" noChangeArrowheads="1" noChangeShapeType="1" noTextEdit="1"/>
+              </p:cNvSpPr>
+              <p:nvPr>
+                <p:ph type="title"/>
+              </p:nvPr>
+            </p:nvSpPr>
+            <p:spPr>
+              <a:xfrm>
+                <a:off x="838200" y="255321"/>
+                <a:ext cx="10515600" cy="1325563"/>
+              </a:xfrm>
+              <a:blipFill>
+                <a:blip r:embed="rId2"/>
+                <a:stretch>
+                  <a:fillRect l="-2377" t="-13364"/>
+                </a:stretch>
+              </a:blipFill>
+            </p:spPr>
+            <p:txBody>
+              <a:bodyPr/>
+              <a:lstStyle/>
+              <a:p>
+                <a:r>
+                  <a:rPr lang="fr-FR">
+                    <a:noFill/>
+                  </a:rPr>
+                  <a:t> </a:t>
+                </a:r>
+              </a:p>
+            </p:txBody>
+          </p:sp>
+        </mc:Fallback>
+      </mc:AlternateContent>
+      <p:pic>
+        <p:nvPicPr>
+          <p:cNvPr id="6" name="Espace réservé du contenu 5">
+            <a:extLst>
+              <a:ext uri="{FF2B5EF4-FFF2-40B4-BE49-F238E27FC236}">
+                <a16:creationId xmlns:a16="http://schemas.microsoft.com/office/drawing/2014/main" id="{C483BD03-40A8-C47C-6338-F4F32665B22D}"/>
+              </a:ext>
+            </a:extLst>
+          </p:cNvPr>
+          <p:cNvPicPr>
+            <a:picLocks noGrp="1" noChangeAspect="1"/>
+          </p:cNvPicPr>
+          <p:nvPr>
+            <p:ph idx="1"/>
+          </p:nvPr>
+        </p:nvPicPr>
+        <p:blipFill>
+          <a:blip r:embed="rId3">
+            <a:extLst>
+              <a:ext uri="{28A0092B-C50C-407E-A947-70E740481C1C}">
+                <a14:useLocalDpi xmlns:a14="http://schemas.microsoft.com/office/drawing/2010/main" val="0"/>
+              </a:ext>
+            </a:extLst>
+          </a:blip>
+          <a:stretch>
+            <a:fillRect/>
+          </a:stretch>
+        </p:blipFill>
+        <p:spPr>
+          <a:xfrm>
+            <a:off x="5576663" y="1180652"/>
+            <a:ext cx="5777137" cy="4070810"/>
+          </a:xfrm>
+          <a:prstGeom prst="rect">
+            <a:avLst/>
+          </a:prstGeom>
+        </p:spPr>
+      </p:pic>
+      <p:sp>
+        <p:nvSpPr>
+          <p:cNvPr id="11" name="ZoneTexte 10">
+            <a:extLst>
+              <a:ext uri="{FF2B5EF4-FFF2-40B4-BE49-F238E27FC236}">
+                <a16:creationId xmlns:a16="http://schemas.microsoft.com/office/drawing/2014/main" id="{47B6169A-A823-A626-B784-DFB66C1E8F5A}"/>
+              </a:ext>
+            </a:extLst>
+          </p:cNvPr>
+          <p:cNvSpPr txBox="1"/>
+          <p:nvPr/>
+        </p:nvSpPr>
+        <p:spPr>
+          <a:xfrm>
+            <a:off x="5576663" y="5251462"/>
+            <a:ext cx="5763849" cy="461665"/>
+          </a:xfrm>
+          <a:prstGeom prst="rect">
+            <a:avLst/>
+          </a:prstGeom>
+          <a:noFill/>
+        </p:spPr>
+        <p:txBody>
+          <a:bodyPr wrap="square" rtlCol="0">
+            <a:spAutoFit/>
+          </a:bodyPr>
+          <a:lstStyle/>
+          <a:p>
+            <a:pPr algn="ctr"/>
+            <a:r>
+              <a:rPr lang="fr-CA" sz="1200" i="1" dirty="0"/>
+              <a:t>Figure 2: Graphique de l’erreur relative de la perméabilité en fonction de la taille des cellules.</a:t>
+            </a:r>
+          </a:p>
+        </p:txBody>
+      </p:sp>
+      <mc:AlternateContent xmlns:mc="http://schemas.openxmlformats.org/markup-compatibility/2006">
+        <mc:Choice xmlns:a14="http://schemas.microsoft.com/office/drawing/2010/main" Requires="a14">
+          <p:sp>
+            <p:nvSpPr>
+              <p:cNvPr id="12" name="ZoneTexte 11">
+                <a:extLst>
+                  <a:ext uri="{FF2B5EF4-FFF2-40B4-BE49-F238E27FC236}">
+                    <a16:creationId xmlns:a16="http://schemas.microsoft.com/office/drawing/2014/main" id="{8AC6D6EA-7E9F-E1BB-3FC8-5AC2858539BB}"/>
+                  </a:ext>
+                </a:extLst>
+              </p:cNvPr>
+              <p:cNvSpPr txBox="1"/>
+              <p:nvPr/>
+            </p:nvSpPr>
+            <p:spPr>
+              <a:xfrm>
+                <a:off x="742384" y="1580884"/>
+                <a:ext cx="4001632" cy="4278094"/>
+              </a:xfrm>
+              <a:prstGeom prst="rect">
+                <a:avLst/>
+              </a:prstGeom>
+              <a:noFill/>
+            </p:spPr>
+            <p:txBody>
+              <a:bodyPr wrap="square" rtlCol="0">
+                <a:spAutoFit/>
+              </a:bodyPr>
+              <a:lstStyle/>
+              <a:p>
+                <a:pPr marL="285750" indent="-285750">
+                  <a:buFont typeface="Arial" panose="020B0604020202020204" pitchFamily="34" charset="0"/>
+                  <a:buChar char="•"/>
+                </a:pPr>
+                <a:r>
+                  <a:rPr lang="fr-CA" sz="1600" dirty="0"/>
+                  <a:t>Ce graphique est le résultat de l’analyse de convergence pour 3 </a:t>
+                </a:r>
+                <a:r>
+                  <a:rPr lang="fr-CA" sz="1600" i="1" dirty="0" err="1"/>
+                  <a:t>seeds</a:t>
+                </a:r>
+                <a:r>
+                  <a:rPr lang="fr-CA" sz="1600" i="1" dirty="0"/>
+                  <a:t> </a:t>
+                </a:r>
+                <a:r>
+                  <a:rPr lang="fr-CA" sz="1600" dirty="0"/>
+                  <a:t>(101, 202, 303).</a:t>
+                </a:r>
+              </a:p>
+              <a:p>
+                <a:pPr marL="285750" indent="-285750">
+                  <a:buFont typeface="Arial" panose="020B0604020202020204" pitchFamily="34" charset="0"/>
+                  <a:buChar char="•"/>
+                </a:pPr>
+                <a:r>
+                  <a:rPr lang="fr-CA" sz="1600" dirty="0"/>
+                  <a:t>La valeur la plus fine n’est pas dans la région asymptotique et donc n’est pas considérée dans le calcul de l’ordre observé.</a:t>
+                </a:r>
+              </a:p>
+              <a:p>
+                <a:pPr marL="285750" indent="-285750">
+                  <a:buFont typeface="Arial" panose="020B0604020202020204" pitchFamily="34" charset="0"/>
+                  <a:buChar char="•"/>
+                </a:pPr>
+                <a:r>
+                  <a:rPr lang="fr-CA" sz="1600" dirty="0"/>
+                  <a:t>L’ordre observé est de </a:t>
+                </a:r>
+                <a14:m>
+                  <m:oMath xmlns:m="http://schemas.openxmlformats.org/officeDocument/2006/math">
+                    <m:acc>
+                      <m:accPr>
+                        <m:chr m:val="̂"/>
+                        <m:ctrlPr>
+                          <a:rPr lang="fr-CA" sz="1600" i="1" smtClean="0">
+                            <a:latin typeface="Cambria Math" panose="02040503050406030204" pitchFamily="18" charset="0"/>
+                          </a:rPr>
+                        </m:ctrlPr>
+                      </m:accPr>
+                      <m:e>
+                        <m:r>
+                          <a:rPr lang="fr-CA" sz="1600" b="0" i="1" smtClean="0">
+                            <a:latin typeface="Cambria Math" panose="02040503050406030204" pitchFamily="18" charset="0"/>
+                          </a:rPr>
+                          <m:t>𝑝</m:t>
+                        </m:r>
+                      </m:e>
+                    </m:acc>
+                    <m:r>
+                      <a:rPr lang="fr-CA" sz="1600" b="0" i="1" smtClean="0">
+                        <a:latin typeface="Cambria Math" panose="02040503050406030204" pitchFamily="18" charset="0"/>
+                      </a:rPr>
+                      <m:t>=2.34</m:t>
+                    </m:r>
+                  </m:oMath>
+                </a14:m>
+                <a:endParaRPr lang="fr-CA" sz="1600" dirty="0"/>
+              </a:p>
+              <a:p>
+                <a:pPr marL="285750" indent="-285750">
+                  <a:buFont typeface="Arial" panose="020B0604020202020204" pitchFamily="34" charset="0"/>
+                  <a:buChar char="•"/>
+                </a:pPr>
+                <a:r>
+                  <a:rPr lang="fr-CA" sz="1600" dirty="0"/>
+                  <a:t>On peut ainsi calculer le GCI :</a:t>
+                </a:r>
+                <a:br>
+                  <a:rPr lang="fr-CA" sz="1600" dirty="0"/>
+                </a:br>
+                <a14:m>
+                  <m:oMath xmlns:m="http://schemas.openxmlformats.org/officeDocument/2006/math">
+                    <m:r>
+                      <a:rPr lang="fr-CA" sz="1600" i="1">
+                        <a:latin typeface="Cambria Math" panose="02040503050406030204" pitchFamily="18" charset="0"/>
+                      </a:rPr>
+                      <m:t>𝐺𝐶𝐼</m:t>
+                    </m:r>
+                    <m:r>
+                      <a:rPr lang="fr-CA" sz="1600" i="1">
+                        <a:latin typeface="Cambria Math" panose="02040503050406030204" pitchFamily="18" charset="0"/>
+                      </a:rPr>
+                      <m:t>=1.086767</m:t>
+                    </m:r>
+                    <m:r>
+                      <a:rPr lang="fr-CA" sz="1600" i="1">
+                        <a:latin typeface="Cambria Math" panose="02040503050406030204" pitchFamily="18" charset="0"/>
+                      </a:rPr>
+                      <m:t>𝑒</m:t>
+                    </m:r>
+                    <m:r>
+                      <a:rPr lang="fr-CA" sz="1600" i="1">
+                        <a:latin typeface="Cambria Math" panose="02040503050406030204" pitchFamily="18" charset="0"/>
+                      </a:rPr>
+                      <m:t>-02 µ</m:t>
+                    </m:r>
+                    <m:r>
+                      <a:rPr lang="fr-CA" sz="1600" i="1">
+                        <a:latin typeface="Cambria Math" panose="02040503050406030204" pitchFamily="18" charset="0"/>
+                      </a:rPr>
+                      <m:t>𝑚</m:t>
+                    </m:r>
+                    <m:r>
+                      <a:rPr lang="fr-CA" sz="1600" i="1">
+                        <a:latin typeface="Cambria Math" panose="02040503050406030204" pitchFamily="18" charset="0"/>
+                      </a:rPr>
+                      <m:t>²</m:t>
+                    </m:r>
+                  </m:oMath>
+                </a14:m>
+                <a:endParaRPr lang="fr-CA" sz="1600" dirty="0"/>
+              </a:p>
+              <a:p>
+                <a:pPr marL="285750" indent="-285750">
+                  <a:buFont typeface="Arial" panose="020B0604020202020204" pitchFamily="34" charset="0"/>
+                  <a:buChar char="•"/>
+                </a:pPr>
+                <a:r>
+                  <a:rPr lang="fr-CA" sz="1600" dirty="0"/>
+                  <a:t>Et donc l’incertitude numérique¹ :</a:t>
+                </a:r>
+                <a:br>
+                  <a:rPr lang="fr-CA" sz="1600" dirty="0"/>
+                </a:br>
+                <a14:m>
+                  <m:oMath xmlns:m="http://schemas.openxmlformats.org/officeDocument/2006/math">
+                    <m:sSub>
+                      <m:sSubPr>
+                        <m:ctrlPr>
+                          <a:rPr lang="fr-CA" sz="1600" b="1" i="1" smtClean="0">
+                            <a:latin typeface="Cambria Math" panose="02040503050406030204" pitchFamily="18" charset="0"/>
+                          </a:rPr>
+                        </m:ctrlPr>
+                      </m:sSubPr>
+                      <m:e>
+                        <m:r>
+                          <a:rPr lang="fr-CA" sz="1600" b="1" i="1" smtClean="0">
+                            <a:latin typeface="Cambria Math" panose="02040503050406030204" pitchFamily="18" charset="0"/>
+                          </a:rPr>
+                          <m:t>𝒖</m:t>
+                        </m:r>
+                      </m:e>
+                      <m:sub>
+                        <m:r>
+                          <a:rPr lang="fr-CA" sz="1600" b="1" i="1" smtClean="0">
+                            <a:latin typeface="Cambria Math" panose="02040503050406030204" pitchFamily="18" charset="0"/>
+                          </a:rPr>
+                          <m:t>𝒏𝒖𝒎</m:t>
+                        </m:r>
+                      </m:sub>
+                    </m:sSub>
+                    <m:r>
+                      <a:rPr lang="fr-CA" sz="1600" b="1" i="1">
+                        <a:latin typeface="Cambria Math" panose="02040503050406030204" pitchFamily="18" charset="0"/>
+                      </a:rPr>
+                      <m:t>=</m:t>
+                    </m:r>
+                    <m:r>
+                      <a:rPr lang="fr-CA" sz="1600" b="1" i="1">
+                        <a:latin typeface="Cambria Math" panose="02040503050406030204" pitchFamily="18" charset="0"/>
+                      </a:rPr>
+                      <m:t>𝟓</m:t>
+                    </m:r>
+                    <m:r>
+                      <a:rPr lang="fr-CA" sz="1600" b="1" i="1">
+                        <a:latin typeface="Cambria Math" panose="02040503050406030204" pitchFamily="18" charset="0"/>
+                      </a:rPr>
+                      <m:t>.</m:t>
+                    </m:r>
+                    <m:r>
+                      <a:rPr lang="fr-CA" sz="1600" b="1" i="1">
+                        <a:latin typeface="Cambria Math" panose="02040503050406030204" pitchFamily="18" charset="0"/>
+                      </a:rPr>
+                      <m:t>𝟒𝟑𝟑𝟖𝟑𝟑</m:t>
+                    </m:r>
+                    <m:r>
+                      <a:rPr lang="fr-CA" sz="1600" b="1" i="1">
+                        <a:latin typeface="Cambria Math" panose="02040503050406030204" pitchFamily="18" charset="0"/>
+                      </a:rPr>
+                      <m:t>𝒆</m:t>
+                    </m:r>
+                    <m:r>
+                      <a:rPr lang="fr-CA" sz="1600" b="1" i="1">
+                        <a:latin typeface="Cambria Math" panose="02040503050406030204" pitchFamily="18" charset="0"/>
+                      </a:rPr>
+                      <m:t>-</m:t>
+                    </m:r>
+                    <m:r>
+                      <a:rPr lang="fr-CA" sz="1600" b="1" i="1">
+                        <a:latin typeface="Cambria Math" panose="02040503050406030204" pitchFamily="18" charset="0"/>
+                      </a:rPr>
+                      <m:t>𝟎𝟑</m:t>
+                    </m:r>
+                    <m:r>
+                      <a:rPr lang="fr-CA" sz="1600" b="1" i="1">
+                        <a:latin typeface="Cambria Math" panose="02040503050406030204" pitchFamily="18" charset="0"/>
+                      </a:rPr>
+                      <m:t> µ</m:t>
+                    </m:r>
+                    <m:r>
+                      <a:rPr lang="fr-CA" sz="1600" b="1" i="1">
+                        <a:latin typeface="Cambria Math" panose="02040503050406030204" pitchFamily="18" charset="0"/>
+                      </a:rPr>
+                      <m:t>𝒎</m:t>
+                    </m:r>
+                    <m:r>
+                      <a:rPr lang="fr-CA" sz="1600" b="1" i="1">
+                        <a:latin typeface="Cambria Math" panose="02040503050406030204" pitchFamily="18" charset="0"/>
+                      </a:rPr>
+                      <m:t>²</m:t>
+                    </m:r>
+                  </m:oMath>
+                </a14:m>
+                <a:endParaRPr lang="fr-CA" sz="1600" b="1" dirty="0"/>
+              </a:p>
+              <a:p>
+                <a:pPr marL="285750" indent="-285750">
+                  <a:buFont typeface="Arial" panose="020B0604020202020204" pitchFamily="34" charset="0"/>
+                  <a:buChar char="•"/>
+                </a:pPr>
+                <a:r>
+                  <a:rPr lang="fr-CA" sz="1600" dirty="0"/>
+                  <a:t>Les barres d’erreur présentés dans ce graphique peuvent être interprétées comme étant les incertitudes des données d’entrée, qui seront calculées prochainement.</a:t>
+                </a:r>
+              </a:p>
+            </p:txBody>
+          </p:sp>
+        </mc:Choice>
+        <mc:Fallback>
+          <p:sp>
+            <p:nvSpPr>
+              <p:cNvPr id="12" name="ZoneTexte 11">
+                <a:extLst>
+                  <a:ext uri="{FF2B5EF4-FFF2-40B4-BE49-F238E27FC236}">
+                    <a16:creationId xmlns:a16="http://schemas.microsoft.com/office/drawing/2014/main" id="{8AC6D6EA-7E9F-E1BB-3FC8-5AC2858539BB}"/>
+                  </a:ext>
+                </a:extLst>
+              </p:cNvPr>
+              <p:cNvSpPr txBox="1">
+                <a:spLocks noRot="1" noChangeAspect="1" noMove="1" noResize="1" noEditPoints="1" noAdjustHandles="1" noChangeArrowheads="1" noChangeShapeType="1" noTextEdit="1"/>
+              </p:cNvSpPr>
+              <p:nvPr/>
+            </p:nvSpPr>
+            <p:spPr>
+              <a:xfrm>
+                <a:off x="742384" y="1580884"/>
+                <a:ext cx="4001632" cy="4278094"/>
+              </a:xfrm>
+              <a:prstGeom prst="rect">
+                <a:avLst/>
+              </a:prstGeom>
+              <a:blipFill>
+                <a:blip r:embed="rId4"/>
+                <a:stretch>
+                  <a:fillRect l="-610" t="-427" r="-305" b="-855"/>
+                </a:stretch>
+              </a:blipFill>
+            </p:spPr>
+            <p:txBody>
+              <a:bodyPr/>
+              <a:lstStyle/>
+              <a:p>
+                <a:r>
+                  <a:rPr lang="fr-CA">
+                    <a:noFill/>
+                  </a:rPr>
+                  <a:t> </a:t>
+                </a:r>
+              </a:p>
+            </p:txBody>
+          </p:sp>
+        </mc:Fallback>
+      </mc:AlternateContent>
+      <mc:AlternateContent xmlns:mc="http://schemas.openxmlformats.org/markup-compatibility/2006">
+        <mc:Choice xmlns:a14="http://schemas.microsoft.com/office/drawing/2010/main" Requires="a14">
+          <p:sp>
+            <p:nvSpPr>
+              <p:cNvPr id="13" name="ZoneTexte 12">
+                <a:extLst>
+                  <a:ext uri="{FF2B5EF4-FFF2-40B4-BE49-F238E27FC236}">
+                    <a16:creationId xmlns:a16="http://schemas.microsoft.com/office/drawing/2014/main" id="{E731592B-FFEE-2191-A4DF-923F1D405983}"/>
+                  </a:ext>
+                </a:extLst>
+              </p:cNvPr>
+              <p:cNvSpPr txBox="1"/>
+              <p:nvPr/>
+            </p:nvSpPr>
+            <p:spPr>
+              <a:xfrm>
+                <a:off x="4176879" y="6356457"/>
+                <a:ext cx="8015121" cy="476477"/>
+              </a:xfrm>
+              <a:prstGeom prst="rect">
+                <a:avLst/>
+              </a:prstGeom>
+              <a:noFill/>
+            </p:spPr>
+            <p:txBody>
+              <a:bodyPr wrap="square" rtlCol="0">
+                <a:spAutoFit/>
+              </a:bodyPr>
+              <a:lstStyle/>
+              <a:p>
+                <a:r>
+                  <a:rPr lang="fr-CA" sz="1200" dirty="0"/>
+                  <a:t>¹À noter que les autres incertitudes numériques sont mises à l’écart puisque soit négligeable par rapport à l’ordre de </a:t>
+                </a:r>
+                <a14:m>
+                  <m:oMath xmlns:m="http://schemas.openxmlformats.org/officeDocument/2006/math">
+                    <m:sSub>
+                      <m:sSubPr>
+                        <m:ctrlPr>
+                          <a:rPr lang="fr-CA" sz="1200" b="0" i="1" smtClean="0">
+                            <a:latin typeface="Cambria Math" panose="02040503050406030204" pitchFamily="18" charset="0"/>
+                          </a:rPr>
+                        </m:ctrlPr>
+                      </m:sSubPr>
+                      <m:e>
+                        <m:r>
+                          <a:rPr lang="fr-CA" sz="1200" b="0" i="1" smtClean="0">
+                            <a:latin typeface="Cambria Math" panose="02040503050406030204" pitchFamily="18" charset="0"/>
+                          </a:rPr>
+                          <m:t>𝑢</m:t>
+                        </m:r>
+                      </m:e>
+                      <m:sub>
+                        <m:r>
+                          <a:rPr lang="fr-CA" sz="1200" b="0" i="1" smtClean="0">
+                            <a:latin typeface="Cambria Math" panose="02040503050406030204" pitchFamily="18" charset="0"/>
+                          </a:rPr>
+                          <m:t>𝑑𝑖𝑠𝑐𝑟𝑒𝑡𝑖𝑧𝑎𝑡𝑖𝑜𝑛</m:t>
+                        </m:r>
+                      </m:sub>
+                    </m:sSub>
+                  </m:oMath>
+                </a14:m>
+                <a:r>
+                  <a:rPr lang="fr-CA" sz="1200" dirty="0"/>
+                  <a:t> (</a:t>
+                </a:r>
+                <a14:m>
+                  <m:oMath xmlns:m="http://schemas.openxmlformats.org/officeDocument/2006/math">
+                    <m:sSub>
+                      <m:sSubPr>
+                        <m:ctrlPr>
+                          <a:rPr lang="fr-CA" sz="1200" b="0" i="1" dirty="0" smtClean="0">
+                            <a:latin typeface="Cambria Math" panose="02040503050406030204" pitchFamily="18" charset="0"/>
+                          </a:rPr>
+                        </m:ctrlPr>
+                      </m:sSubPr>
+                      <m:e>
+                        <m:r>
+                          <a:rPr lang="fr-CA" sz="1200" b="0" i="1" dirty="0" smtClean="0">
+                            <a:latin typeface="Cambria Math" panose="02040503050406030204" pitchFamily="18" charset="0"/>
+                          </a:rPr>
+                          <m:t>𝑢</m:t>
+                        </m:r>
+                      </m:e>
+                      <m:sub>
+                        <m:r>
+                          <a:rPr lang="fr-CA" sz="1200" b="0" i="1" dirty="0" smtClean="0">
+                            <a:latin typeface="Cambria Math" panose="02040503050406030204" pitchFamily="18" charset="0"/>
+                          </a:rPr>
+                          <m:t>𝑟𝑜𝑢𝑛𝑑𝑜𝑓𝑓</m:t>
+                        </m:r>
+                      </m:sub>
+                    </m:sSub>
+                    <m:r>
+                      <a:rPr lang="fr-CA" sz="1200" b="0" i="1" dirty="0" smtClean="0">
+                        <a:latin typeface="Cambria Math" panose="02040503050406030204" pitchFamily="18" charset="0"/>
+                      </a:rPr>
+                      <m:t>, </m:t>
+                    </m:r>
+                    <m:sSub>
+                      <m:sSubPr>
+                        <m:ctrlPr>
+                          <a:rPr lang="fr-CA" sz="1200" b="0" i="1" dirty="0" smtClean="0">
+                            <a:latin typeface="Cambria Math" panose="02040503050406030204" pitchFamily="18" charset="0"/>
+                          </a:rPr>
+                        </m:ctrlPr>
+                      </m:sSubPr>
+                      <m:e>
+                        <m:r>
+                          <a:rPr lang="fr-CA" sz="1200" b="0" i="1" dirty="0" smtClean="0">
+                            <a:latin typeface="Cambria Math" panose="02040503050406030204" pitchFamily="18" charset="0"/>
+                          </a:rPr>
+                          <m:t>𝑢</m:t>
+                        </m:r>
+                      </m:e>
+                      <m:sub>
+                        <m:r>
+                          <a:rPr lang="fr-CA" sz="1200" b="0" i="1" dirty="0" smtClean="0">
+                            <a:latin typeface="Cambria Math" panose="02040503050406030204" pitchFamily="18" charset="0"/>
+                          </a:rPr>
+                          <m:t>𝑠𝑎𝑚𝑝𝑙𝑖𝑛𝑔</m:t>
+                        </m:r>
+                      </m:sub>
+                    </m:sSub>
+                    <m:r>
+                      <a:rPr lang="fr-CA" sz="1200" b="0" i="1" dirty="0" smtClean="0">
+                        <a:latin typeface="Cambria Math" panose="02040503050406030204" pitchFamily="18" charset="0"/>
+                      </a:rPr>
+                      <m:t>, </m:t>
+                    </m:r>
+                    <m:sSub>
+                      <m:sSubPr>
+                        <m:ctrlPr>
+                          <a:rPr lang="fr-CA" sz="1200" b="0" i="1" dirty="0" smtClean="0">
+                            <a:latin typeface="Cambria Math" panose="02040503050406030204" pitchFamily="18" charset="0"/>
+                          </a:rPr>
+                        </m:ctrlPr>
+                      </m:sSubPr>
+                      <m:e>
+                        <m:r>
+                          <a:rPr lang="fr-CA" sz="1200" b="0" i="1" dirty="0" smtClean="0">
+                            <a:latin typeface="Cambria Math" panose="02040503050406030204" pitchFamily="18" charset="0"/>
+                          </a:rPr>
+                          <m:t>𝑢</m:t>
+                        </m:r>
+                      </m:e>
+                      <m:sub>
+                        <m:r>
+                          <a:rPr lang="fr-CA" sz="1200" b="0" i="1" dirty="0" smtClean="0">
+                            <a:latin typeface="Cambria Math" panose="02040503050406030204" pitchFamily="18" charset="0"/>
+                          </a:rPr>
+                          <m:t>𝑖𝑡𝑒𝑟𝑎𝑡𝑖𝑣𝑒</m:t>
+                        </m:r>
+                      </m:sub>
+                    </m:sSub>
+                    <m:r>
+                      <a:rPr lang="fr-CA" sz="1200" b="0" i="1" dirty="0" smtClean="0">
+                        <a:latin typeface="Cambria Math" panose="02040503050406030204" pitchFamily="18" charset="0"/>
+                      </a:rPr>
+                      <m:t>)</m:t>
+                    </m:r>
+                    <m:r>
+                      <a:rPr lang="fr-CA" sz="1200" b="0" i="0" dirty="0" smtClean="0">
+                        <a:latin typeface="Cambria Math" panose="02040503050406030204" pitchFamily="18" charset="0"/>
+                      </a:rPr>
+                      <m:t>.</m:t>
+                    </m:r>
+                  </m:oMath>
+                </a14:m>
+                <a:endParaRPr lang="fr-CA" sz="1200" dirty="0"/>
+              </a:p>
+            </p:txBody>
+          </p:sp>
+        </mc:Choice>
+        <mc:Fallback>
+          <p:sp>
+            <p:nvSpPr>
+              <p:cNvPr id="13" name="ZoneTexte 12">
+                <a:extLst>
+                  <a:ext uri="{FF2B5EF4-FFF2-40B4-BE49-F238E27FC236}">
+                    <a16:creationId xmlns:a16="http://schemas.microsoft.com/office/drawing/2014/main" id="{E731592B-FFEE-2191-A4DF-923F1D405983}"/>
+                  </a:ext>
+                </a:extLst>
+              </p:cNvPr>
+              <p:cNvSpPr txBox="1">
+                <a:spLocks noRot="1" noChangeAspect="1" noMove="1" noResize="1" noEditPoints="1" noAdjustHandles="1" noChangeArrowheads="1" noChangeShapeType="1" noTextEdit="1"/>
+              </p:cNvSpPr>
+              <p:nvPr/>
+            </p:nvSpPr>
+            <p:spPr>
+              <a:xfrm>
+                <a:off x="4176879" y="6356457"/>
+                <a:ext cx="8015121" cy="476477"/>
+              </a:xfrm>
+              <a:prstGeom prst="rect">
+                <a:avLst/>
+              </a:prstGeom>
+              <a:blipFill>
+                <a:blip r:embed="rId5"/>
+                <a:stretch>
+                  <a:fillRect t="-1282" b="-7692"/>
+                </a:stretch>
+              </a:blipFill>
+            </p:spPr>
+            <p:txBody>
+              <a:bodyPr/>
+              <a:lstStyle/>
+              <a:p>
+                <a:r>
+                  <a:rPr lang="fr-CA">
+                    <a:noFill/>
+                  </a:rPr>
+                  <a:t> </a:t>
+                </a:r>
+              </a:p>
+            </p:txBody>
+          </p:sp>
+        </mc:Fallback>
+      </mc:AlternateContent>
+    </p:spTree>
+    <p:extLst>
+      <p:ext uri="{BB962C8B-B14F-4D97-AF65-F5344CB8AC3E}">
+        <p14:creationId xmlns:p14="http://schemas.microsoft.com/office/powerpoint/2010/main" val="2709558708"/>
+      </p:ext>
+    </p:extLst>
+  </p:cSld>
+  <p:clrMapOvr>
+    <a:masterClrMapping/>
+  </p:clrMapOvr>
+</p:sld>
+</file>
+
+<file path=ppt/slides/slide4.xml><?xml version="1.0" encoding="utf-8"?>
+<p:sld xmlns:a="http://schemas.openxmlformats.org/drawingml/2006/main" xmlns:r="http://schemas.openxmlformats.org/officeDocument/2006/relationships" xmlns:p="http://schemas.openxmlformats.org/presentationml/2006/main">
+  <p:cSld>
+    <p:spTree>
+      <p:nvGrpSpPr>
         <p:cNvPr id="1" name=""/>
         <p:cNvGrpSpPr/>
         <p:nvPr/>
@@ -3684,8 +5145,8 @@
           <a:chExt cx="0" cy="0"/>
         </a:xfrm>
       </p:grpSpPr>
-      <mc:AlternateContent xmlns:mc="http://schemas.openxmlformats.org/markup-compatibility/2006">
-        <mc:Choice xmlns:a14="http://schemas.microsoft.com/office/drawing/2010/main" Requires="a14">
+      <mc:AlternateContent xmlns:mc="http://schemas.openxmlformats.org/markup-compatibility/2006" xmlns:a14="http://schemas.microsoft.com/office/drawing/2010/main">
+        <mc:Choice Requires="a14">
           <p:sp>
             <p:nvSpPr>
               <p:cNvPr id="2" name="Titre 1">
@@ -3745,7 +5206,7 @@
             </p:txBody>
           </p:sp>
         </mc:Choice>
-        <mc:Fallback>
+        <mc:Fallback xmlns="">
           <p:sp>
             <p:nvSpPr>
               <p:cNvPr id="2" name="Titre 1">
@@ -3951,7 +5412,7 @@
         </p:nvSpPr>
         <p:spPr>
           <a:xfrm>
-            <a:off x="838200" y="1778856"/>
+            <a:off x="838200" y="1582938"/>
             <a:ext cx="10515600" cy="1325563"/>
           </a:xfrm>
         </p:spPr>
@@ -4205,6 +5666,49 @@
           </a:p>
         </p:txBody>
       </p:sp>
+      <p:sp>
+        <p:nvSpPr>
+          <p:cNvPr id="3" name="ZoneTexte 2">
+            <a:extLst>
+              <a:ext uri="{FF2B5EF4-FFF2-40B4-BE49-F238E27FC236}">
+                <a16:creationId xmlns:a16="http://schemas.microsoft.com/office/drawing/2014/main" id="{8D8320ED-12F4-95A7-217E-CBC390EE103F}"/>
+              </a:ext>
+            </a:extLst>
+          </p:cNvPr>
+          <p:cNvSpPr txBox="1"/>
+          <p:nvPr/>
+        </p:nvSpPr>
+        <p:spPr>
+          <a:xfrm>
+            <a:off x="3427708" y="2931168"/>
+            <a:ext cx="5004591" cy="338554"/>
+          </a:xfrm>
+          <a:prstGeom prst="rect">
+            <a:avLst/>
+          </a:prstGeom>
+          <a:noFill/>
+        </p:spPr>
+        <p:txBody>
+          <a:bodyPr wrap="square" rtlCol="0">
+            <a:spAutoFit/>
+          </a:bodyPr>
+          <a:lstStyle/>
+          <a:p>
+            <a:r>
+              <a:rPr lang="fr-CA" sz="1600" i="1" dirty="0"/>
+              <a:t>Figure 3: Domaines générés en fonction du </a:t>
+            </a:r>
+            <a:r>
+              <a:rPr lang="fr-CA" sz="1600" i="1" dirty="0" err="1"/>
+              <a:t>seed</a:t>
+            </a:r>
+            <a:r>
+              <a:rPr lang="fr-CA" sz="1600" i="1" dirty="0"/>
+              <a:t> utilisé.</a:t>
+            </a:r>
+          </a:p>
+        </p:txBody>
+      </p:sp>
     </p:spTree>
     <p:extLst>
       <p:ext uri="{BB962C8B-B14F-4D97-AF65-F5344CB8AC3E}">
@@ -4218,7 +5722,7 @@
 </p:sld>
 </file>
 
-<file path=ppt/slides/slide4.xml><?xml version="1.0" encoding="utf-8"?>
+<file path=ppt/slides/slide5.xml><?xml version="1.0" encoding="utf-8"?>
 <p:sld xmlns:a="http://schemas.openxmlformats.org/drawingml/2006/main" xmlns:r="http://schemas.openxmlformats.org/officeDocument/2006/relationships" xmlns:p="http://schemas.openxmlformats.org/presentationml/2006/main">
   <p:cSld>
     <p:spTree>
@@ -4397,7 +5901,7 @@
 </p:sld>
 </file>
 
-<file path=ppt/slides/slide5.xml><?xml version="1.0" encoding="utf-8"?>
+<file path=ppt/slides/slide6.xml><?xml version="1.0" encoding="utf-8"?>
 <p:sld xmlns:a="http://schemas.openxmlformats.org/drawingml/2006/main" xmlns:r="http://schemas.openxmlformats.org/officeDocument/2006/relationships" xmlns:p="http://schemas.openxmlformats.org/presentationml/2006/main">
   <p:cSld>
     <p:spTree>
@@ -4535,8 +6039,8 @@
           </p:sp>
         </mc:Fallback>
       </mc:AlternateContent>
-      <mc:AlternateContent xmlns:mc="http://schemas.openxmlformats.org/markup-compatibility/2006">
-        <mc:Choice xmlns:a14="http://schemas.microsoft.com/office/drawing/2010/main" Requires="a14">
+      <mc:AlternateContent xmlns:mc="http://schemas.openxmlformats.org/markup-compatibility/2006" xmlns:a14="http://schemas.microsoft.com/office/drawing/2010/main">
+        <mc:Choice Requires="a14">
           <p:sp>
             <p:nvSpPr>
               <p:cNvPr id="3" name="Espace réservé du contenu 2">
@@ -4901,7 +6405,7 @@
             </p:txBody>
           </p:sp>
         </mc:Choice>
-        <mc:Fallback>
+        <mc:Fallback xmlns="">
           <p:sp>
             <p:nvSpPr>
               <p:cNvPr id="3" name="Espace réservé du contenu 2">
@@ -4954,7 +6458,7 @@
 </p:sld>
 </file>
 
-<file path=ppt/slides/slide6.xml><?xml version="1.0" encoding="utf-8"?>
+<file path=ppt/slides/slide7.xml><?xml version="1.0" encoding="utf-8"?>
 <p:sld xmlns:a="http://schemas.openxmlformats.org/drawingml/2006/main" xmlns:r="http://schemas.openxmlformats.org/officeDocument/2006/relationships" xmlns:p="http://schemas.openxmlformats.org/presentationml/2006/main">
   <p:cSld>
     <p:spTree>
@@ -5016,8 +6520,8 @@
           </a:p>
         </p:txBody>
       </p:sp>
-      <mc:AlternateContent xmlns:mc="http://schemas.openxmlformats.org/markup-compatibility/2006">
-        <mc:Choice xmlns:a14="http://schemas.microsoft.com/office/drawing/2010/main" Requires="a14">
+      <mc:AlternateContent xmlns:mc="http://schemas.openxmlformats.org/markup-compatibility/2006" xmlns:a14="http://schemas.microsoft.com/office/drawing/2010/main">
+        <mc:Choice Requires="a14">
           <p:sp>
             <p:nvSpPr>
               <p:cNvPr id="3" name="Espace réservé du contenu 2">
@@ -5182,7 +6686,7 @@
             </p:txBody>
           </p:sp>
         </mc:Choice>
-        <mc:Fallback>
+        <mc:Fallback xmlns="">
           <p:sp>
             <p:nvSpPr>
               <p:cNvPr id="3" name="Espace réservé du contenu 2">
@@ -5235,7 +6739,7 @@
 </p:sld>
 </file>
 
-<file path=ppt/slides/slide7.xml><?xml version="1.0" encoding="utf-8"?>
+<file path=ppt/slides/slide8.xml><?xml version="1.0" encoding="utf-8"?>
 <p:sld xmlns:a="http://schemas.openxmlformats.org/drawingml/2006/main" xmlns:r="http://schemas.openxmlformats.org/officeDocument/2006/relationships" xmlns:p="http://schemas.openxmlformats.org/presentationml/2006/main">
   <p:cSld>
     <p:spTree>
@@ -5373,8 +6877,8 @@
           </p:sp>
         </mc:Fallback>
       </mc:AlternateContent>
-      <mc:AlternateContent xmlns:mc="http://schemas.openxmlformats.org/markup-compatibility/2006">
-        <mc:Choice xmlns:a14="http://schemas.microsoft.com/office/drawing/2010/main" Requires="a14">
+      <mc:AlternateContent xmlns:mc="http://schemas.openxmlformats.org/markup-compatibility/2006" xmlns:a14="http://schemas.microsoft.com/office/drawing/2010/main">
+        <mc:Choice Requires="a14">
           <p:sp>
             <p:nvSpPr>
               <p:cNvPr id="3" name="Espace réservé du contenu 2">
@@ -5706,7 +7210,7 @@
             </p:txBody>
           </p:sp>
         </mc:Choice>
-        <mc:Fallback>
+        <mc:Fallback xmlns="">
           <p:sp>
             <p:nvSpPr>
               <p:cNvPr id="3" name="Espace réservé du contenu 2">
@@ -5759,7 +7263,7 @@
 </p:sld>
 </file>
 
-<file path=ppt/slides/slide8.xml><?xml version="1.0" encoding="utf-8"?>
+<file path=ppt/slides/slide9.xml><?xml version="1.0" encoding="utf-8"?>
 <p:sld xmlns:a="http://schemas.openxmlformats.org/drawingml/2006/main" xmlns:r="http://schemas.openxmlformats.org/officeDocument/2006/relationships" xmlns:p="http://schemas.openxmlformats.org/presentationml/2006/main">
   <p:cSld>
     <p:spTree>
@@ -5804,8 +7308,8 @@
           </a:p>
         </p:txBody>
       </p:sp>
-      <mc:AlternateContent xmlns:mc="http://schemas.openxmlformats.org/markup-compatibility/2006">
-        <mc:Choice xmlns:a14="http://schemas.microsoft.com/office/drawing/2010/main" Requires="a14">
+      <mc:AlternateContent xmlns:mc="http://schemas.openxmlformats.org/markup-compatibility/2006" xmlns:a14="http://schemas.microsoft.com/office/drawing/2010/main">
+        <mc:Choice Requires="a14">
           <p:sp>
             <p:nvSpPr>
               <p:cNvPr id="3" name="Espace réservé du contenu 2">
@@ -5896,7 +7400,7 @@
             </p:txBody>
           </p:sp>
         </mc:Choice>
-        <mc:Fallback>
+        <mc:Fallback xmlns="">
           <p:sp>
             <p:nvSpPr>
               <p:cNvPr id="3" name="Espace réservé du contenu 2">

</xml_diff>

<commit_message>
Ajout de la partie B; incertitude sur u_input. Manque les graphiques
</commit_message>
<xml_diff>
--- a/MEC8211-Devoir3.pptx
+++ b/MEC8211-Devoir3.pptx
@@ -4,16 +4,20 @@
   <p:sldMasterIdLst>
     <p:sldMasterId id="2147483648" r:id="rId1"/>
   </p:sldMasterIdLst>
+  <p:notesMasterIdLst>
+    <p:notesMasterId r:id="rId12"/>
+  </p:notesMasterIdLst>
   <p:sldIdLst>
     <p:sldId id="257" r:id="rId2"/>
     <p:sldId id="258" r:id="rId3"/>
     <p:sldId id="266" r:id="rId4"/>
     <p:sldId id="264" r:id="rId5"/>
     <p:sldId id="260" r:id="rId6"/>
-    <p:sldId id="261" r:id="rId7"/>
-    <p:sldId id="262" r:id="rId8"/>
-    <p:sldId id="263" r:id="rId9"/>
-    <p:sldId id="265" r:id="rId10"/>
+    <p:sldId id="267" r:id="rId7"/>
+    <p:sldId id="261" r:id="rId8"/>
+    <p:sldId id="262" r:id="rId9"/>
+    <p:sldId id="263" r:id="rId10"/>
+    <p:sldId id="265" r:id="rId11"/>
   </p:sldIdLst>
   <p:sldSz cx="12192000" cy="6858000"/>
   <p:notesSz cx="6858000" cy="9144000"/>
@@ -118,6 +122,548 @@
     </p:ext>
   </p:extLst>
 </p:presentation>
+</file>
+
+<file path=ppt/notesMasters/notesMaster1.xml><?xml version="1.0" encoding="utf-8"?>
+<p:notesMaster xmlns:a="http://schemas.openxmlformats.org/drawingml/2006/main" xmlns:r="http://schemas.openxmlformats.org/officeDocument/2006/relationships" xmlns:p="http://schemas.openxmlformats.org/presentationml/2006/main">
+  <p:cSld>
+    <p:bg>
+      <p:bgRef idx="1001">
+        <a:schemeClr val="bg1"/>
+      </p:bgRef>
+    </p:bg>
+    <p:spTree>
+      <p:nvGrpSpPr>
+        <p:cNvPr id="1" name=""/>
+        <p:cNvGrpSpPr/>
+        <p:nvPr/>
+      </p:nvGrpSpPr>
+      <p:grpSpPr>
+        <a:xfrm>
+          <a:off x="0" y="0"/>
+          <a:ext cx="0" cy="0"/>
+          <a:chOff x="0" y="0"/>
+          <a:chExt cx="0" cy="0"/>
+        </a:xfrm>
+      </p:grpSpPr>
+      <p:sp>
+        <p:nvSpPr>
+          <p:cNvPr id="2" name="Espace réservé de l'en-tête 1"/>
+          <p:cNvSpPr>
+            <a:spLocks noGrp="1"/>
+          </p:cNvSpPr>
+          <p:nvPr>
+            <p:ph type="hdr" sz="quarter"/>
+          </p:nvPr>
+        </p:nvSpPr>
+        <p:spPr>
+          <a:xfrm>
+            <a:off x="0" y="0"/>
+            <a:ext cx="2971800" cy="458788"/>
+          </a:xfrm>
+          <a:prstGeom prst="rect">
+            <a:avLst/>
+          </a:prstGeom>
+        </p:spPr>
+        <p:txBody>
+          <a:bodyPr vert="horz" lIns="91440" tIns="45720" rIns="91440" bIns="45720" rtlCol="0"/>
+          <a:lstStyle>
+            <a:lvl1pPr algn="l">
+              <a:defRPr sz="1200"/>
+            </a:lvl1pPr>
+          </a:lstStyle>
+          <a:p>
+            <a:endParaRPr lang="fr-CA"/>
+          </a:p>
+        </p:txBody>
+      </p:sp>
+      <p:sp>
+        <p:nvSpPr>
+          <p:cNvPr id="3" name="Espace réservé de la date 2"/>
+          <p:cNvSpPr>
+            <a:spLocks noGrp="1"/>
+          </p:cNvSpPr>
+          <p:nvPr>
+            <p:ph type="dt" idx="1"/>
+          </p:nvPr>
+        </p:nvSpPr>
+        <p:spPr>
+          <a:xfrm>
+            <a:off x="3884613" y="0"/>
+            <a:ext cx="2971800" cy="458788"/>
+          </a:xfrm>
+          <a:prstGeom prst="rect">
+            <a:avLst/>
+          </a:prstGeom>
+        </p:spPr>
+        <p:txBody>
+          <a:bodyPr vert="horz" lIns="91440" tIns="45720" rIns="91440" bIns="45720" rtlCol="0"/>
+          <a:lstStyle>
+            <a:lvl1pPr algn="r">
+              <a:defRPr sz="1200"/>
+            </a:lvl1pPr>
+          </a:lstStyle>
+          <a:p>
+            <a:fld id="{6BD447F1-453D-4945-8981-7B47F590C70C}" type="datetimeFigureOut">
+              <a:rPr lang="fr-CA" smtClean="0"/>
+              <a:t>2026-03-25</a:t>
+            </a:fld>
+            <a:endParaRPr lang="fr-CA"/>
+          </a:p>
+        </p:txBody>
+      </p:sp>
+      <p:sp>
+        <p:nvSpPr>
+          <p:cNvPr id="4" name="Espace réservé de l'image des diapositives 3"/>
+          <p:cNvSpPr>
+            <a:spLocks noGrp="1" noRot="1" noChangeAspect="1"/>
+          </p:cNvSpPr>
+          <p:nvPr>
+            <p:ph type="sldImg" idx="2"/>
+          </p:nvPr>
+        </p:nvSpPr>
+        <p:spPr>
+          <a:xfrm>
+            <a:off x="685800" y="1143000"/>
+            <a:ext cx="5486400" cy="3086100"/>
+          </a:xfrm>
+          <a:prstGeom prst="rect">
+            <a:avLst/>
+          </a:prstGeom>
+          <a:noFill/>
+          <a:ln w="12700">
+            <a:solidFill>
+              <a:prstClr val="black"/>
+            </a:solidFill>
+          </a:ln>
+        </p:spPr>
+        <p:txBody>
+          <a:bodyPr vert="horz" lIns="91440" tIns="45720" rIns="91440" bIns="45720" rtlCol="0" anchor="ctr"/>
+          <a:lstStyle/>
+          <a:p>
+            <a:endParaRPr lang="fr-CA"/>
+          </a:p>
+        </p:txBody>
+      </p:sp>
+      <p:sp>
+        <p:nvSpPr>
+          <p:cNvPr id="5" name="Espace réservé des notes 4"/>
+          <p:cNvSpPr>
+            <a:spLocks noGrp="1"/>
+          </p:cNvSpPr>
+          <p:nvPr>
+            <p:ph type="body" sz="quarter" idx="3"/>
+          </p:nvPr>
+        </p:nvSpPr>
+        <p:spPr>
+          <a:xfrm>
+            <a:off x="685800" y="4400550"/>
+            <a:ext cx="5486400" cy="3600450"/>
+          </a:xfrm>
+          <a:prstGeom prst="rect">
+            <a:avLst/>
+          </a:prstGeom>
+        </p:spPr>
+        <p:txBody>
+          <a:bodyPr vert="horz" lIns="91440" tIns="45720" rIns="91440" bIns="45720" rtlCol="0"/>
+          <a:lstStyle/>
+          <a:p>
+            <a:pPr lvl="0"/>
+            <a:r>
+              <a:rPr lang="fr-FR"/>
+              <a:t>Cliquez pour modifier les styles du texte du masque</a:t>
+            </a:r>
+          </a:p>
+          <a:p>
+            <a:pPr lvl="1"/>
+            <a:r>
+              <a:rPr lang="fr-FR"/>
+              <a:t>Deuxième niveau</a:t>
+            </a:r>
+          </a:p>
+          <a:p>
+            <a:pPr lvl="2"/>
+            <a:r>
+              <a:rPr lang="fr-FR"/>
+              <a:t>Troisième niveau</a:t>
+            </a:r>
+          </a:p>
+          <a:p>
+            <a:pPr lvl="3"/>
+            <a:r>
+              <a:rPr lang="fr-FR"/>
+              <a:t>Quatrième niveau</a:t>
+            </a:r>
+          </a:p>
+          <a:p>
+            <a:pPr lvl="4"/>
+            <a:r>
+              <a:rPr lang="fr-FR"/>
+              <a:t>Cinquième niveau</a:t>
+            </a:r>
+            <a:endParaRPr lang="fr-CA"/>
+          </a:p>
+        </p:txBody>
+      </p:sp>
+      <p:sp>
+        <p:nvSpPr>
+          <p:cNvPr id="6" name="Espace réservé du pied de page 5"/>
+          <p:cNvSpPr>
+            <a:spLocks noGrp="1"/>
+          </p:cNvSpPr>
+          <p:nvPr>
+            <p:ph type="ftr" sz="quarter" idx="4"/>
+          </p:nvPr>
+        </p:nvSpPr>
+        <p:spPr>
+          <a:xfrm>
+            <a:off x="0" y="8685213"/>
+            <a:ext cx="2971800" cy="458787"/>
+          </a:xfrm>
+          <a:prstGeom prst="rect">
+            <a:avLst/>
+          </a:prstGeom>
+        </p:spPr>
+        <p:txBody>
+          <a:bodyPr vert="horz" lIns="91440" tIns="45720" rIns="91440" bIns="45720" rtlCol="0" anchor="b"/>
+          <a:lstStyle>
+            <a:lvl1pPr algn="l">
+              <a:defRPr sz="1200"/>
+            </a:lvl1pPr>
+          </a:lstStyle>
+          <a:p>
+            <a:endParaRPr lang="fr-CA"/>
+          </a:p>
+        </p:txBody>
+      </p:sp>
+      <p:sp>
+        <p:nvSpPr>
+          <p:cNvPr id="7" name="Espace réservé du numéro de diapositive 6"/>
+          <p:cNvSpPr>
+            <a:spLocks noGrp="1"/>
+          </p:cNvSpPr>
+          <p:nvPr>
+            <p:ph type="sldNum" sz="quarter" idx="5"/>
+          </p:nvPr>
+        </p:nvSpPr>
+        <p:spPr>
+          <a:xfrm>
+            <a:off x="3884613" y="8685213"/>
+            <a:ext cx="2971800" cy="458787"/>
+          </a:xfrm>
+          <a:prstGeom prst="rect">
+            <a:avLst/>
+          </a:prstGeom>
+        </p:spPr>
+        <p:txBody>
+          <a:bodyPr vert="horz" lIns="91440" tIns="45720" rIns="91440" bIns="45720" rtlCol="0" anchor="b"/>
+          <a:lstStyle>
+            <a:lvl1pPr algn="r">
+              <a:defRPr sz="1200"/>
+            </a:lvl1pPr>
+          </a:lstStyle>
+          <a:p>
+            <a:fld id="{75A0F3B1-98BF-4430-AB0B-53D22E8A78C9}" type="slidenum">
+              <a:rPr lang="fr-CA" smtClean="0"/>
+              <a:t>‹N°›</a:t>
+            </a:fld>
+            <a:endParaRPr lang="fr-CA"/>
+          </a:p>
+        </p:txBody>
+      </p:sp>
+    </p:spTree>
+    <p:extLst>
+      <p:ext uri="{BB962C8B-B14F-4D97-AF65-F5344CB8AC3E}">
+        <p14:creationId xmlns:p14="http://schemas.microsoft.com/office/powerpoint/2010/main" val="3853204097"/>
+      </p:ext>
+    </p:extLst>
+  </p:cSld>
+  <p:clrMap bg1="lt1" tx1="dk1" bg2="lt2" tx2="dk2" accent1="accent1" accent2="accent2" accent3="accent3" accent4="accent4" accent5="accent5" accent6="accent6" hlink="hlink" folHlink="folHlink"/>
+  <p:notesStyle>
+    <a:lvl1pPr marL="0" algn="l" defTabSz="914400" rtl="0" eaLnBrk="1" latinLnBrk="0" hangingPunct="1">
+      <a:defRPr sz="1200" kern="1200">
+        <a:solidFill>
+          <a:schemeClr val="tx1"/>
+        </a:solidFill>
+        <a:latin typeface="+mn-lt"/>
+        <a:ea typeface="+mn-ea"/>
+        <a:cs typeface="+mn-cs"/>
+      </a:defRPr>
+    </a:lvl1pPr>
+    <a:lvl2pPr marL="457200" algn="l" defTabSz="914400" rtl="0" eaLnBrk="1" latinLnBrk="0" hangingPunct="1">
+      <a:defRPr sz="1200" kern="1200">
+        <a:solidFill>
+          <a:schemeClr val="tx1"/>
+        </a:solidFill>
+        <a:latin typeface="+mn-lt"/>
+        <a:ea typeface="+mn-ea"/>
+        <a:cs typeface="+mn-cs"/>
+      </a:defRPr>
+    </a:lvl2pPr>
+    <a:lvl3pPr marL="914400" algn="l" defTabSz="914400" rtl="0" eaLnBrk="1" latinLnBrk="0" hangingPunct="1">
+      <a:defRPr sz="1200" kern="1200">
+        <a:solidFill>
+          <a:schemeClr val="tx1"/>
+        </a:solidFill>
+        <a:latin typeface="+mn-lt"/>
+        <a:ea typeface="+mn-ea"/>
+        <a:cs typeface="+mn-cs"/>
+      </a:defRPr>
+    </a:lvl3pPr>
+    <a:lvl4pPr marL="1371600" algn="l" defTabSz="914400" rtl="0" eaLnBrk="1" latinLnBrk="0" hangingPunct="1">
+      <a:defRPr sz="1200" kern="1200">
+        <a:solidFill>
+          <a:schemeClr val="tx1"/>
+        </a:solidFill>
+        <a:latin typeface="+mn-lt"/>
+        <a:ea typeface="+mn-ea"/>
+        <a:cs typeface="+mn-cs"/>
+      </a:defRPr>
+    </a:lvl4pPr>
+    <a:lvl5pPr marL="1828800" algn="l" defTabSz="914400" rtl="0" eaLnBrk="1" latinLnBrk="0" hangingPunct="1">
+      <a:defRPr sz="1200" kern="1200">
+        <a:solidFill>
+          <a:schemeClr val="tx1"/>
+        </a:solidFill>
+        <a:latin typeface="+mn-lt"/>
+        <a:ea typeface="+mn-ea"/>
+        <a:cs typeface="+mn-cs"/>
+      </a:defRPr>
+    </a:lvl5pPr>
+    <a:lvl6pPr marL="2286000" algn="l" defTabSz="914400" rtl="0" eaLnBrk="1" latinLnBrk="0" hangingPunct="1">
+      <a:defRPr sz="1200" kern="1200">
+        <a:solidFill>
+          <a:schemeClr val="tx1"/>
+        </a:solidFill>
+        <a:latin typeface="+mn-lt"/>
+        <a:ea typeface="+mn-ea"/>
+        <a:cs typeface="+mn-cs"/>
+      </a:defRPr>
+    </a:lvl6pPr>
+    <a:lvl7pPr marL="2743200" algn="l" defTabSz="914400" rtl="0" eaLnBrk="1" latinLnBrk="0" hangingPunct="1">
+      <a:defRPr sz="1200" kern="1200">
+        <a:solidFill>
+          <a:schemeClr val="tx1"/>
+        </a:solidFill>
+        <a:latin typeface="+mn-lt"/>
+        <a:ea typeface="+mn-ea"/>
+        <a:cs typeface="+mn-cs"/>
+      </a:defRPr>
+    </a:lvl7pPr>
+    <a:lvl8pPr marL="3200400" algn="l" defTabSz="914400" rtl="0" eaLnBrk="1" latinLnBrk="0" hangingPunct="1">
+      <a:defRPr sz="1200" kern="1200">
+        <a:solidFill>
+          <a:schemeClr val="tx1"/>
+        </a:solidFill>
+        <a:latin typeface="+mn-lt"/>
+        <a:ea typeface="+mn-ea"/>
+        <a:cs typeface="+mn-cs"/>
+      </a:defRPr>
+    </a:lvl8pPr>
+    <a:lvl9pPr marL="3657600" algn="l" defTabSz="914400" rtl="0" eaLnBrk="1" latinLnBrk="0" hangingPunct="1">
+      <a:defRPr sz="1200" kern="1200">
+        <a:solidFill>
+          <a:schemeClr val="tx1"/>
+        </a:solidFill>
+        <a:latin typeface="+mn-lt"/>
+        <a:ea typeface="+mn-ea"/>
+        <a:cs typeface="+mn-cs"/>
+      </a:defRPr>
+    </a:lvl9pPr>
+  </p:notesStyle>
+</p:notesMaster>
+</file>
+
+<file path=ppt/notesSlides/notesSlide1.xml><?xml version="1.0" encoding="utf-8"?>
+<p:notes xmlns:a="http://schemas.openxmlformats.org/drawingml/2006/main" xmlns:r="http://schemas.openxmlformats.org/officeDocument/2006/relationships" xmlns:p="http://schemas.openxmlformats.org/presentationml/2006/main">
+  <p:cSld>
+    <p:spTree>
+      <p:nvGrpSpPr>
+        <p:cNvPr id="1" name=""/>
+        <p:cNvGrpSpPr/>
+        <p:nvPr/>
+      </p:nvGrpSpPr>
+      <p:grpSpPr>
+        <a:xfrm>
+          <a:off x="0" y="0"/>
+          <a:ext cx="0" cy="0"/>
+          <a:chOff x="0" y="0"/>
+          <a:chExt cx="0" cy="0"/>
+        </a:xfrm>
+      </p:grpSpPr>
+      <p:sp>
+        <p:nvSpPr>
+          <p:cNvPr id="2" name="Espace réservé de l'image des diapositives 1"/>
+          <p:cNvSpPr>
+            <a:spLocks noGrp="1" noRot="1" noChangeAspect="1"/>
+          </p:cNvSpPr>
+          <p:nvPr>
+            <p:ph type="sldImg"/>
+          </p:nvPr>
+        </p:nvSpPr>
+        <p:spPr/>
+      </p:sp>
+      <p:sp>
+        <p:nvSpPr>
+          <p:cNvPr id="3" name="Espace réservé des notes 2"/>
+          <p:cNvSpPr>
+            <a:spLocks noGrp="1"/>
+          </p:cNvSpPr>
+          <p:nvPr>
+            <p:ph type="body" idx="1"/>
+          </p:nvPr>
+        </p:nvSpPr>
+        <p:spPr/>
+        <p:txBody>
+          <a:bodyPr/>
+          <a:lstStyle/>
+          <a:p>
+            <a:endParaRPr lang="fr-CA" dirty="0"/>
+          </a:p>
+        </p:txBody>
+      </p:sp>
+      <p:sp>
+        <p:nvSpPr>
+          <p:cNvPr id="4" name="Espace réservé du numéro de diapositive 3"/>
+          <p:cNvSpPr>
+            <a:spLocks noGrp="1"/>
+          </p:cNvSpPr>
+          <p:nvPr>
+            <p:ph type="sldNum" sz="quarter" idx="5"/>
+          </p:nvPr>
+        </p:nvSpPr>
+        <p:spPr/>
+        <p:txBody>
+          <a:bodyPr/>
+          <a:lstStyle/>
+          <a:p>
+            <a:fld id="{75A0F3B1-98BF-4430-AB0B-53D22E8A78C9}" type="slidenum">
+              <a:rPr lang="fr-CA" smtClean="0"/>
+              <a:t>5</a:t>
+            </a:fld>
+            <a:endParaRPr lang="fr-CA"/>
+          </a:p>
+        </p:txBody>
+      </p:sp>
+    </p:spTree>
+    <p:extLst>
+      <p:ext uri="{BB962C8B-B14F-4D97-AF65-F5344CB8AC3E}">
+        <p14:creationId xmlns:p14="http://schemas.microsoft.com/office/powerpoint/2010/main" val="2299516035"/>
+      </p:ext>
+    </p:extLst>
+  </p:cSld>
+  <p:clrMapOvr>
+    <a:masterClrMapping/>
+  </p:clrMapOvr>
+</p:notes>
+</file>
+
+<file path=ppt/notesSlides/notesSlide2.xml><?xml version="1.0" encoding="utf-8"?>
+<p:notes xmlns:a="http://schemas.openxmlformats.org/drawingml/2006/main" xmlns:r="http://schemas.openxmlformats.org/officeDocument/2006/relationships" xmlns:p="http://schemas.openxmlformats.org/presentationml/2006/main">
+  <p:cSld>
+    <p:spTree>
+      <p:nvGrpSpPr>
+        <p:cNvPr id="1" name="">
+          <a:extLst>
+            <a:ext uri="{FF2B5EF4-FFF2-40B4-BE49-F238E27FC236}">
+              <a16:creationId xmlns:a16="http://schemas.microsoft.com/office/drawing/2014/main" id="{61D662C8-9F56-6A3F-7606-F5012E871565}"/>
+            </a:ext>
+          </a:extLst>
+        </p:cNvPr>
+        <p:cNvGrpSpPr/>
+        <p:nvPr/>
+      </p:nvGrpSpPr>
+      <p:grpSpPr>
+        <a:xfrm>
+          <a:off x="0" y="0"/>
+          <a:ext cx="0" cy="0"/>
+          <a:chOff x="0" y="0"/>
+          <a:chExt cx="0" cy="0"/>
+        </a:xfrm>
+      </p:grpSpPr>
+      <p:sp>
+        <p:nvSpPr>
+          <p:cNvPr id="2" name="Espace réservé de l'image des diapositives 1">
+            <a:extLst>
+              <a:ext uri="{FF2B5EF4-FFF2-40B4-BE49-F238E27FC236}">
+                <a16:creationId xmlns:a16="http://schemas.microsoft.com/office/drawing/2014/main" id="{79606C73-C25B-B502-BFD4-729AB1AC9BCD}"/>
+              </a:ext>
+            </a:extLst>
+          </p:cNvPr>
+          <p:cNvSpPr>
+            <a:spLocks noGrp="1" noRot="1" noChangeAspect="1"/>
+          </p:cNvSpPr>
+          <p:nvPr>
+            <p:ph type="sldImg"/>
+          </p:nvPr>
+        </p:nvSpPr>
+        <p:spPr/>
+      </p:sp>
+      <p:sp>
+        <p:nvSpPr>
+          <p:cNvPr id="3" name="Espace réservé des notes 2">
+            <a:extLst>
+              <a:ext uri="{FF2B5EF4-FFF2-40B4-BE49-F238E27FC236}">
+                <a16:creationId xmlns:a16="http://schemas.microsoft.com/office/drawing/2014/main" id="{23060132-D4D8-91EA-AAC4-E3943EB2CC5E}"/>
+              </a:ext>
+            </a:extLst>
+          </p:cNvPr>
+          <p:cNvSpPr>
+            <a:spLocks noGrp="1"/>
+          </p:cNvSpPr>
+          <p:nvPr>
+            <p:ph type="body" idx="1"/>
+          </p:nvPr>
+        </p:nvSpPr>
+        <p:spPr/>
+        <p:txBody>
+          <a:bodyPr/>
+          <a:lstStyle/>
+          <a:p>
+            <a:endParaRPr lang="fr-CA" dirty="0"/>
+          </a:p>
+        </p:txBody>
+      </p:sp>
+      <p:sp>
+        <p:nvSpPr>
+          <p:cNvPr id="4" name="Espace réservé du numéro de diapositive 3">
+            <a:extLst>
+              <a:ext uri="{FF2B5EF4-FFF2-40B4-BE49-F238E27FC236}">
+                <a16:creationId xmlns:a16="http://schemas.microsoft.com/office/drawing/2014/main" id="{400F20EB-06EC-198A-EC9A-6DDE888492AA}"/>
+              </a:ext>
+            </a:extLst>
+          </p:cNvPr>
+          <p:cNvSpPr>
+            <a:spLocks noGrp="1"/>
+          </p:cNvSpPr>
+          <p:nvPr>
+            <p:ph type="sldNum" sz="quarter" idx="5"/>
+          </p:nvPr>
+        </p:nvSpPr>
+        <p:spPr/>
+        <p:txBody>
+          <a:bodyPr/>
+          <a:lstStyle/>
+          <a:p>
+            <a:fld id="{75A0F3B1-98BF-4430-AB0B-53D22E8A78C9}" type="slidenum">
+              <a:rPr lang="fr-CA" smtClean="0"/>
+              <a:t>6</a:t>
+            </a:fld>
+            <a:endParaRPr lang="fr-CA"/>
+          </a:p>
+        </p:txBody>
+      </p:sp>
+    </p:spTree>
+    <p:extLst>
+      <p:ext uri="{BB962C8B-B14F-4D97-AF65-F5344CB8AC3E}">
+        <p14:creationId xmlns:p14="http://schemas.microsoft.com/office/powerpoint/2010/main" val="1039464604"/>
+      </p:ext>
+    </p:extLst>
+  </p:cSld>
+  <p:clrMapOvr>
+    <a:masterClrMapping/>
+  </p:clrMapOvr>
+</p:notes>
 </file>
 
 <file path=ppt/slideLayouts/slideLayout1.xml><?xml version="1.0" encoding="utf-8"?>
@@ -3481,6 +4027,196 @@
 </p:sld>
 </file>
 
+<file path=ppt/slides/slide10.xml><?xml version="1.0" encoding="utf-8"?>
+<p:sld xmlns:a="http://schemas.openxmlformats.org/drawingml/2006/main" xmlns:r="http://schemas.openxmlformats.org/officeDocument/2006/relationships" xmlns:p="http://schemas.openxmlformats.org/presentationml/2006/main">
+  <p:cSld>
+    <p:spTree>
+      <p:nvGrpSpPr>
+        <p:cNvPr id="1" name=""/>
+        <p:cNvGrpSpPr/>
+        <p:nvPr/>
+      </p:nvGrpSpPr>
+      <p:grpSpPr>
+        <a:xfrm>
+          <a:off x="0" y="0"/>
+          <a:ext cx="0" cy="0"/>
+          <a:chOff x="0" y="0"/>
+          <a:chExt cx="0" cy="0"/>
+        </a:xfrm>
+      </p:grpSpPr>
+      <p:sp>
+        <p:nvSpPr>
+          <p:cNvPr id="2" name="Titre 1">
+            <a:extLst>
+              <a:ext uri="{FF2B5EF4-FFF2-40B4-BE49-F238E27FC236}">
+                <a16:creationId xmlns:a16="http://schemas.microsoft.com/office/drawing/2014/main" id="{952FD1E7-D507-F3B9-06EA-C4D755151F65}"/>
+              </a:ext>
+            </a:extLst>
+          </p:cNvPr>
+          <p:cNvSpPr>
+            <a:spLocks noGrp="1"/>
+          </p:cNvSpPr>
+          <p:nvPr>
+            <p:ph type="title"/>
+          </p:nvPr>
+        </p:nvSpPr>
+        <p:spPr/>
+        <p:txBody>
+          <a:bodyPr/>
+          <a:lstStyle/>
+          <a:p>
+            <a:r>
+              <a:rPr lang="fr-FR" dirty="0"/>
+              <a:t>Interprétation de l’intervalle de confiance </a:t>
+            </a:r>
+          </a:p>
+        </p:txBody>
+      </p:sp>
+      <mc:AlternateContent xmlns:mc="http://schemas.openxmlformats.org/markup-compatibility/2006" xmlns:a14="http://schemas.microsoft.com/office/drawing/2010/main">
+        <mc:Choice Requires="a14">
+          <p:sp>
+            <p:nvSpPr>
+              <p:cNvPr id="3" name="Espace réservé du contenu 2">
+                <a:extLst>
+                  <a:ext uri="{FF2B5EF4-FFF2-40B4-BE49-F238E27FC236}">
+                    <a16:creationId xmlns:a16="http://schemas.microsoft.com/office/drawing/2014/main" id="{5F231FAE-DF1D-EF42-B4E7-03EBF13AC650}"/>
+                  </a:ext>
+                </a:extLst>
+              </p:cNvPr>
+              <p:cNvSpPr>
+                <a:spLocks noGrp="1"/>
+              </p:cNvSpPr>
+              <p:nvPr>
+                <p:ph idx="1"/>
+              </p:nvPr>
+            </p:nvSpPr>
+            <p:spPr/>
+            <p:txBody>
+              <a:bodyPr/>
+              <a:lstStyle/>
+              <a:p>
+                <a:r>
+                  <a:rPr lang="fr-FR" b="0" dirty="0">
+                    <a:latin typeface="Cambria Math" panose="02040503050406030204" pitchFamily="18" charset="0"/>
+                  </a:rPr>
+                  <a:t>E par rapport à </a:t>
+                </a:r>
+                <a:r>
+                  <a:rPr lang="fr-FR" b="0" dirty="0" err="1">
+                    <a:latin typeface="Cambria Math" panose="02040503050406030204" pitchFamily="18" charset="0"/>
+                  </a:rPr>
+                  <a:t>u_val</a:t>
+                </a:r>
+                <a:r>
+                  <a:rPr lang="fr-FR" b="0" dirty="0">
+                    <a:latin typeface="Cambria Math" panose="02040503050406030204" pitchFamily="18" charset="0"/>
+                  </a:rPr>
+                  <a:t> ?</a:t>
+                </a:r>
+              </a:p>
+              <a:p>
+                <a:endParaRPr lang="fr-FR" b="0" i="1" dirty="0">
+                  <a:latin typeface="Cambria Math" panose="02040503050406030204" pitchFamily="18" charset="0"/>
+                </a:endParaRPr>
+              </a:p>
+              <a:p>
+                <a14:m>
+                  <m:oMath xmlns:m="http://schemas.openxmlformats.org/officeDocument/2006/math">
+                    <m:sSub>
+                      <m:sSubPr>
+                        <m:ctrlPr>
+                          <a:rPr lang="fr-FR" b="0" i="1" smtClean="0">
+                            <a:latin typeface="Cambria Math" panose="02040503050406030204" pitchFamily="18" charset="0"/>
+                          </a:rPr>
+                        </m:ctrlPr>
+                      </m:sSubPr>
+                      <m:e>
+                        <m:r>
+                          <a:rPr lang="fr-FR" b="0" i="1" smtClean="0">
+                            <a:latin typeface="Cambria Math" panose="02040503050406030204" pitchFamily="18" charset="0"/>
+                          </a:rPr>
+                          <m:t>𝑢</m:t>
+                        </m:r>
+                      </m:e>
+                      <m:sub>
+                        <m:r>
+                          <a:rPr lang="fr-FR" b="0" i="1" smtClean="0">
+                            <a:latin typeface="Cambria Math" panose="02040503050406030204" pitchFamily="18" charset="0"/>
+                          </a:rPr>
+                          <m:t>𝐷</m:t>
+                        </m:r>
+                      </m:sub>
+                    </m:sSub>
+                  </m:oMath>
+                </a14:m>
+                <a:r>
+                  <a:rPr lang="fr-FR" dirty="0"/>
+                  <a:t> semble être l’erreur prédominante dans la validation </a:t>
+                </a:r>
+                <a:r>
+                  <a:rPr lang="fr-FR" dirty="0">
+                    <a:sym typeface="Wingdings" panose="05000000000000000000" pitchFamily="2" charset="2"/>
+                  </a:rPr>
+                  <a:t> être plus précis sur les expériences  </a:t>
+                </a:r>
+                <a:endParaRPr lang="fr-FR" dirty="0"/>
+              </a:p>
+            </p:txBody>
+          </p:sp>
+        </mc:Choice>
+        <mc:Fallback xmlns="">
+          <p:sp>
+            <p:nvSpPr>
+              <p:cNvPr id="3" name="Espace réservé du contenu 2">
+                <a:extLst>
+                  <a:ext uri="{FF2B5EF4-FFF2-40B4-BE49-F238E27FC236}">
+                    <a16:creationId xmlns:a16="http://schemas.microsoft.com/office/drawing/2014/main" id="{5F231FAE-DF1D-EF42-B4E7-03EBF13AC650}"/>
+                  </a:ext>
+                </a:extLst>
+              </p:cNvPr>
+              <p:cNvSpPr>
+                <a:spLocks noGrp="1" noRot="1" noChangeAspect="1" noMove="1" noResize="1" noEditPoints="1" noAdjustHandles="1" noChangeArrowheads="1" noChangeShapeType="1" noTextEdit="1"/>
+              </p:cNvSpPr>
+              <p:nvPr>
+                <p:ph idx="1"/>
+              </p:nvPr>
+            </p:nvSpPr>
+            <p:spPr>
+              <a:blipFill>
+                <a:blip r:embed="rId2"/>
+                <a:stretch>
+                  <a:fillRect l="-1043" t="-2381"/>
+                </a:stretch>
+              </a:blipFill>
+            </p:spPr>
+            <p:txBody>
+              <a:bodyPr/>
+              <a:lstStyle/>
+              <a:p>
+                <a:r>
+                  <a:rPr lang="fr-FR">
+                    <a:noFill/>
+                  </a:rPr>
+                  <a:t> </a:t>
+                </a:r>
+              </a:p>
+            </p:txBody>
+          </p:sp>
+        </mc:Fallback>
+      </mc:AlternateContent>
+    </p:spTree>
+    <p:extLst>
+      <p:ext uri="{BB962C8B-B14F-4D97-AF65-F5344CB8AC3E}">
+        <p14:creationId xmlns:p14="http://schemas.microsoft.com/office/powerpoint/2010/main" val="1935114118"/>
+      </p:ext>
+    </p:extLst>
+  </p:cSld>
+  <p:clrMapOvr>
+    <a:masterClrMapping/>
+  </p:clrMapOvr>
+</p:sld>
+</file>
+
 <file path=ppt/slides/slide2.xml><?xml version="1.0" encoding="utf-8"?>
 <p:sld xmlns:a="http://schemas.openxmlformats.org/drawingml/2006/main" xmlns:r="http://schemas.openxmlformats.org/officeDocument/2006/relationships" xmlns:p="http://schemas.openxmlformats.org/presentationml/2006/main">
   <p:cSld>
@@ -3613,8 +4349,8 @@
           </p:sp>
         </mc:Fallback>
       </mc:AlternateContent>
-      <mc:AlternateContent xmlns:mc="http://schemas.openxmlformats.org/markup-compatibility/2006">
-        <mc:Choice xmlns:a14="http://schemas.microsoft.com/office/drawing/2010/main" Requires="a14">
+      <mc:AlternateContent xmlns:mc="http://schemas.openxmlformats.org/markup-compatibility/2006" xmlns:a14="http://schemas.microsoft.com/office/drawing/2010/main">
+        <mc:Choice Requires="a14">
           <p:sp>
             <p:nvSpPr>
               <p:cNvPr id="3" name="Espace réservé du contenu 2">
@@ -4172,7 +4908,7 @@
             </p:txBody>
           </p:sp>
         </mc:Choice>
-        <mc:Fallback>
+        <mc:Fallback xmlns="">
           <p:sp>
             <p:nvSpPr>
               <p:cNvPr id="3" name="Espace réservé du contenu 2">
@@ -4580,8 +5316,8 @@
           </a:p>
         </p:txBody>
       </p:sp>
-      <mc:AlternateContent xmlns:mc="http://schemas.openxmlformats.org/markup-compatibility/2006">
-        <mc:Choice xmlns:a14="http://schemas.microsoft.com/office/drawing/2010/main" Requires="a14">
+      <mc:AlternateContent xmlns:mc="http://schemas.openxmlformats.org/markup-compatibility/2006" xmlns:a14="http://schemas.microsoft.com/office/drawing/2010/main">
+        <mc:Choice Requires="a14">
           <p:sp>
             <p:nvSpPr>
               <p:cNvPr id="12" name="ZoneTexte 11">
@@ -4716,7 +5452,7 @@
                       <a:rPr lang="fr-CA" sz="1600" i="1">
                         <a:latin typeface="Cambria Math" panose="02040503050406030204" pitchFamily="18" charset="0"/>
                       </a:rPr>
-                      <m:t>-02 µ</m:t>
+                      <m:t>−02 µ</m:t>
                     </m:r>
                     <m:r>
                       <a:rPr lang="fr-CA" sz="1600" i="1">
@@ -4807,7 +5543,7 @@
                       <a:rPr lang="fr-CA" sz="1600" b="1" i="1">
                         <a:latin typeface="Cambria Math" panose="02040503050406030204" pitchFamily="18" charset="0"/>
                       </a:rPr>
-                      <m:t>-</m:t>
+                      <m:t>−</m:t>
                     </m:r>
                     <m:r>
                       <a:rPr lang="fr-CA" sz="1600" b="1" i="1">
@@ -4850,7 +5586,7 @@
             </p:txBody>
           </p:sp>
         </mc:Choice>
-        <mc:Fallback>
+        <mc:Fallback xmlns="">
           <p:sp>
             <p:nvSpPr>
               <p:cNvPr id="12" name="ZoneTexte 11">
@@ -4895,8 +5631,8 @@
           </p:sp>
         </mc:Fallback>
       </mc:AlternateContent>
-      <mc:AlternateContent xmlns:mc="http://schemas.openxmlformats.org/markup-compatibility/2006">
-        <mc:Choice xmlns:a14="http://schemas.microsoft.com/office/drawing/2010/main" Requires="a14">
+      <mc:AlternateContent xmlns:mc="http://schemas.openxmlformats.org/markup-compatibility/2006" xmlns:a14="http://schemas.microsoft.com/office/drawing/2010/main">
+        <mc:Choice Requires="a14">
           <p:sp>
             <p:nvSpPr>
               <p:cNvPr id="13" name="ZoneTexte 12">
@@ -5070,7 +5806,7 @@
             </p:txBody>
           </p:sp>
         </mc:Choice>
-        <mc:Fallback>
+        <mc:Fallback xmlns="">
           <p:sp>
             <p:nvSpPr>
               <p:cNvPr id="13" name="ZoneTexte 12">
@@ -5839,7 +6575,7 @@
                 <a:ext cx="10515600" cy="1325563"/>
               </a:xfrm>
               <a:blipFill>
-                <a:blip r:embed="rId2"/>
+                <a:blip r:embed="rId3"/>
                 <a:stretch>
                   <a:fillRect l="-2087" t="-7834"/>
                 </a:stretch>
@@ -5860,34 +6596,494 @@
           </p:sp>
         </mc:Fallback>
       </mc:AlternateContent>
-      <p:sp>
-        <p:nvSpPr>
-          <p:cNvPr id="3" name="Espace réservé du contenu 2">
-            <a:extLst>
-              <a:ext uri="{FF2B5EF4-FFF2-40B4-BE49-F238E27FC236}">
-                <a16:creationId xmlns:a16="http://schemas.microsoft.com/office/drawing/2014/main" id="{A6CA13C1-0552-592F-8A56-718E46BDA011}"/>
-              </a:ext>
-            </a:extLst>
-          </p:cNvPr>
-          <p:cNvSpPr>
-            <a:spLocks noGrp="1"/>
-          </p:cNvSpPr>
-          <p:nvPr>
-            <p:ph idx="1"/>
-          </p:nvPr>
-        </p:nvSpPr>
-        <p:spPr/>
-        <p:txBody>
-          <a:bodyPr/>
-          <a:lstStyle/>
-          <a:p>
-            <a:r>
-              <a:rPr lang="fr-FR" dirty="0"/>
-              <a:t>Méthode de Monte Carlo pour la propagation des incertitudes </a:t>
-            </a:r>
-          </a:p>
-        </p:txBody>
-      </p:sp>
+      <mc:AlternateContent xmlns:mc="http://schemas.openxmlformats.org/markup-compatibility/2006">
+        <mc:Choice xmlns:a14="http://schemas.microsoft.com/office/drawing/2010/main" Requires="a14">
+          <p:sp>
+            <p:nvSpPr>
+              <p:cNvPr id="3" name="Espace réservé du contenu 2">
+                <a:extLst>
+                  <a:ext uri="{FF2B5EF4-FFF2-40B4-BE49-F238E27FC236}">
+                    <a16:creationId xmlns:a16="http://schemas.microsoft.com/office/drawing/2014/main" id="{A6CA13C1-0552-592F-8A56-718E46BDA011}"/>
+                  </a:ext>
+                </a:extLst>
+              </p:cNvPr>
+              <p:cNvSpPr>
+                <a:spLocks noGrp="1"/>
+              </p:cNvSpPr>
+              <p:nvPr>
+                <p:ph idx="1"/>
+              </p:nvPr>
+            </p:nvSpPr>
+            <p:spPr>
+              <a:xfrm>
+                <a:off x="838200" y="1580884"/>
+                <a:ext cx="10515600" cy="4351338"/>
+              </a:xfrm>
+            </p:spPr>
+            <p:txBody>
+              <a:bodyPr>
+                <a:normAutofit fontScale="62500" lnSpcReduction="20000"/>
+              </a:bodyPr>
+              <a:lstStyle/>
+              <a:p>
+                <a:r>
+                  <a:rPr lang="fr-FR" dirty="0"/>
+                  <a:t>On mesure </a:t>
+                </a:r>
+                <a14:m>
+                  <m:oMath xmlns:m="http://schemas.openxmlformats.org/officeDocument/2006/math">
+                    <m:sSub>
+                      <m:sSubPr>
+                        <m:ctrlPr>
+                          <a:rPr lang="fr-CA" b="0" i="1" smtClean="0">
+                            <a:latin typeface="Cambria Math" panose="02040503050406030204" pitchFamily="18" charset="0"/>
+                          </a:rPr>
+                        </m:ctrlPr>
+                      </m:sSubPr>
+                      <m:e>
+                        <m:r>
+                          <a:rPr lang="fr-CA" b="0" i="1" smtClean="0">
+                            <a:latin typeface="Cambria Math" panose="02040503050406030204" pitchFamily="18" charset="0"/>
+                          </a:rPr>
+                          <m:t>𝑢</m:t>
+                        </m:r>
+                      </m:e>
+                      <m:sub>
+                        <m:r>
+                          <a:rPr lang="fr-CA" b="0" i="1" smtClean="0">
+                            <a:latin typeface="Cambria Math" panose="02040503050406030204" pitchFamily="18" charset="0"/>
+                          </a:rPr>
+                          <m:t>𝑖𝑛𝑝𝑢𝑡</m:t>
+                        </m:r>
+                      </m:sub>
+                    </m:sSub>
+                  </m:oMath>
+                </a14:m>
+                <a:r>
+                  <a:rPr lang="fr-FR" dirty="0"/>
+                  <a:t> à l’aide de la propagation des incertitudes par la méthode de Monte-Carlo.</a:t>
+                </a:r>
+              </a:p>
+              <a:p>
+                <a:r>
+                  <a:rPr lang="fr-FR" dirty="0"/>
+                  <a:t>Ici, les paramètres d’entrés affectant la SRQ (</a:t>
+                </a:r>
+                <a14:m>
+                  <m:oMath xmlns:m="http://schemas.openxmlformats.org/officeDocument/2006/math">
+                    <m:r>
+                      <a:rPr lang="fr-CA" i="1">
+                        <a:latin typeface="Cambria Math" panose="02040503050406030204" pitchFamily="18" charset="0"/>
+                      </a:rPr>
+                      <m:t>𝑘</m:t>
+                    </m:r>
+                  </m:oMath>
+                </a14:m>
+                <a:r>
+                  <a:rPr lang="fr-FR" dirty="0"/>
+                  <a:t>, perméabilité) sont la porosité et le diamètre des fibres.</a:t>
+                </a:r>
+              </a:p>
+              <a:p>
+                <a:r>
+                  <a:rPr lang="fr-FR" dirty="0"/>
+                  <a:t>L’impact de la propagation de l’incertitude de la taille des fibres est déjà pris en compte du fait qu’on génère un grand nombre de fibres de manière aléatoire suivant une distribution normale pour générer le matériau (en posant </a:t>
+                </a:r>
+                <a14:m>
+                  <m:oMath xmlns:m="http://schemas.openxmlformats.org/officeDocument/2006/math">
+                    <m:r>
+                      <a:rPr lang="fr-CA" b="0" i="1" smtClean="0">
+                        <a:latin typeface="Cambria Math" panose="02040503050406030204" pitchFamily="18" charset="0"/>
+                      </a:rPr>
+                      <m:t>𝑠𝑒𝑒𝑑</m:t>
+                    </m:r>
+                    <m:r>
+                      <a:rPr lang="fr-CA" b="0" i="1" smtClean="0">
+                        <a:latin typeface="Cambria Math" panose="02040503050406030204" pitchFamily="18" charset="0"/>
+                      </a:rPr>
+                      <m:t>=0</m:t>
+                    </m:r>
+                  </m:oMath>
+                </a14:m>
+                <a:r>
+                  <a:rPr lang="fr-FR" dirty="0"/>
+                  <a:t>, distribution aléatoire).</a:t>
+                </a:r>
+              </a:p>
+              <a:p>
+                <a:r>
+                  <a:rPr lang="fr-FR" dirty="0"/>
+                  <a:t>Donc, pour mesurer la propagation, on évalue la propagation pour un échantillon représentatif de la fonction de distribution des probabilités (PDF) de la porosité.</a:t>
+                </a:r>
+              </a:p>
+              <a:p>
+                <a:r>
+                  <a:rPr lang="fr-FR" dirty="0"/>
+                  <a:t>Méthodologie : </a:t>
+                </a:r>
+              </a:p>
+              <a:p>
+                <a:pPr marL="914400" lvl="1" indent="-457200">
+                  <a:buFont typeface="+mj-lt"/>
+                  <a:buAutoNum type="arabicPeriod"/>
+                </a:pPr>
+                <a:r>
+                  <a:rPr lang="fr-FR" dirty="0"/>
+                  <a:t>Générer un échantillon représentatif suivant la PDF de la porosité.</a:t>
+                </a:r>
+              </a:p>
+              <a:p>
+                <a:pPr marL="914400" lvl="1" indent="-457200">
+                  <a:buFont typeface="+mj-lt"/>
+                  <a:buAutoNum type="arabicPeriod"/>
+                </a:pPr>
+                <a:r>
+                  <a:rPr lang="fr-FR" dirty="0"/>
+                  <a:t>Calculer la perméabilité pour l’ensemble des points de l’échantillon.</a:t>
+                </a:r>
+              </a:p>
+              <a:p>
+                <a:pPr marL="914400" lvl="1" indent="-457200">
+                  <a:buFont typeface="+mj-lt"/>
+                  <a:buAutoNum type="arabicPeriod"/>
+                </a:pPr>
+                <a:r>
+                  <a:rPr lang="fr-FR" dirty="0"/>
+                  <a:t>Calculer la distribution de la SRQ (</a:t>
+                </a:r>
+                <a14:m>
+                  <m:oMath xmlns:m="http://schemas.openxmlformats.org/officeDocument/2006/math">
+                    <m:r>
+                      <a:rPr lang="fr-CA" i="1">
+                        <a:latin typeface="Cambria Math" panose="02040503050406030204" pitchFamily="18" charset="0"/>
+                      </a:rPr>
+                      <m:t>𝑘</m:t>
+                    </m:r>
+                  </m:oMath>
+                </a14:m>
+                <a:r>
+                  <a:rPr lang="fr-FR" dirty="0"/>
+                  <a:t>, perméabilité).</a:t>
+                </a:r>
+              </a:p>
+              <a:p>
+                <a:pPr lvl="2"/>
+                <a:r>
+                  <a:rPr lang="fr-FR" dirty="0"/>
+                  <a:t>On se retrouve avec une distribution log-normale.</a:t>
+                </a:r>
+              </a:p>
+              <a:p>
+                <a:pPr lvl="2"/>
+                <a:r>
+                  <a:rPr lang="fr-FR" dirty="0"/>
+                  <a:t>On utilise le facteur de variation géométrique (FVG) qui permet d’interpréter les résultats dans le domaine normal. Le FVG correspond à l’exponentielle de l’écart type mesuré dans l’espace log.</a:t>
+                </a:r>
+              </a:p>
+              <a:p>
+                <a:pPr lvl="2"/>
+                <a:r>
+                  <a:rPr lang="fr-FR" dirty="0"/>
+                  <a:t>À l’aide tu FVG et de la médiane, on peut calculer l’intervalle dans lequel se trouvent  68.3% des données, basé sur </a:t>
+                </a:r>
+                <a14:m>
+                  <m:oMath xmlns:m="http://schemas.openxmlformats.org/officeDocument/2006/math">
+                    <m:r>
+                      <a:rPr lang="fr-FR" i="1" smtClean="0">
+                        <a:latin typeface="Cambria Math" panose="02040503050406030204" pitchFamily="18" charset="0"/>
+                        <a:ea typeface="Cambria Math" panose="02040503050406030204" pitchFamily="18" charset="0"/>
+                      </a:rPr>
+                      <m:t>𝜇</m:t>
+                    </m:r>
+                    <m:r>
+                      <a:rPr lang="fr-FR" i="1" smtClean="0">
+                        <a:latin typeface="Cambria Math" panose="02040503050406030204" pitchFamily="18" charset="0"/>
+                        <a:ea typeface="Cambria Math" panose="02040503050406030204" pitchFamily="18" charset="0"/>
+                      </a:rPr>
+                      <m:t>±</m:t>
+                    </m:r>
+                    <m:r>
+                      <a:rPr lang="fr-FR" i="1" smtClean="0">
+                        <a:latin typeface="Cambria Math" panose="02040503050406030204" pitchFamily="18" charset="0"/>
+                        <a:ea typeface="Cambria Math" panose="02040503050406030204" pitchFamily="18" charset="0"/>
+                      </a:rPr>
+                      <m:t>𝜎</m:t>
+                    </m:r>
+                  </m:oMath>
+                </a14:m>
+                <a:r>
+                  <a:rPr lang="fr-FR" dirty="0"/>
+                  <a:t> dans l’espace logarithmique.</a:t>
+                </a:r>
+              </a:p>
+              <a:p>
+                <a:pPr marL="914400" lvl="1" indent="-457200">
+                  <a:buFont typeface="+mj-lt"/>
+                  <a:buAutoNum type="arabicPeriod"/>
+                </a:pPr>
+                <a:r>
+                  <a:rPr lang="fr-FR" dirty="0"/>
+                  <a:t>On pose </a:t>
+                </a:r>
+                <a14:m>
+                  <m:oMath xmlns:m="http://schemas.openxmlformats.org/officeDocument/2006/math">
+                    <m:sSub>
+                      <m:sSubPr>
+                        <m:ctrlPr>
+                          <a:rPr lang="fr-CA" b="0" i="1" smtClean="0">
+                            <a:latin typeface="Cambria Math" panose="02040503050406030204" pitchFamily="18" charset="0"/>
+                          </a:rPr>
+                        </m:ctrlPr>
+                      </m:sSubPr>
+                      <m:e>
+                        <m:r>
+                          <a:rPr lang="fr-CA" b="0" i="1" smtClean="0">
+                            <a:latin typeface="Cambria Math" panose="02040503050406030204" pitchFamily="18" charset="0"/>
+                          </a:rPr>
+                          <m:t>𝑢</m:t>
+                        </m:r>
+                      </m:e>
+                      <m:sub>
+                        <m:r>
+                          <a:rPr lang="fr-CA" b="0" i="1" smtClean="0">
+                            <a:latin typeface="Cambria Math" panose="02040503050406030204" pitchFamily="18" charset="0"/>
+                          </a:rPr>
+                          <m:t>𝑖𝑛𝑝𝑢𝑡</m:t>
+                        </m:r>
+                      </m:sub>
+                    </m:sSub>
+                  </m:oMath>
+                </a14:m>
+                <a:r>
+                  <a:rPr lang="fr-FR" dirty="0"/>
+                  <a:t> égal au plus grand écart ; en log-normal, les écarts sont asymétriques :</a:t>
+                </a:r>
+                <a:br>
+                  <a:rPr lang="fr-FR" dirty="0"/>
+                </a:br>
+                <a14:m>
+                  <m:oMath xmlns:m="http://schemas.openxmlformats.org/officeDocument/2006/math">
+                    <m:sSub>
+                      <m:sSubPr>
+                        <m:ctrlPr>
+                          <a:rPr lang="fr-CA" b="0" i="1" smtClean="0">
+                            <a:latin typeface="Cambria Math" panose="02040503050406030204" pitchFamily="18" charset="0"/>
+                          </a:rPr>
+                        </m:ctrlPr>
+                      </m:sSubPr>
+                      <m:e>
+                        <m:r>
+                          <a:rPr lang="fr-CA" b="0" i="1" smtClean="0">
+                            <a:latin typeface="Cambria Math" panose="02040503050406030204" pitchFamily="18" charset="0"/>
+                          </a:rPr>
+                          <m:t>𝑢</m:t>
+                        </m:r>
+                      </m:e>
+                      <m:sub>
+                        <m:r>
+                          <a:rPr lang="fr-CA" b="0" i="1" smtClean="0">
+                            <a:latin typeface="Cambria Math" panose="02040503050406030204" pitchFamily="18" charset="0"/>
+                          </a:rPr>
+                          <m:t>𝑖𝑛𝑝𝑢𝑡</m:t>
+                        </m:r>
+                      </m:sub>
+                    </m:sSub>
+                    <m:r>
+                      <a:rPr lang="fr-CA" b="0" i="1" smtClean="0">
+                        <a:latin typeface="Cambria Math" panose="02040503050406030204" pitchFamily="18" charset="0"/>
+                      </a:rPr>
+                      <m:t>=</m:t>
+                    </m:r>
+                    <m:r>
+                      <m:rPr>
+                        <m:sty m:val="p"/>
+                      </m:rPr>
+                      <a:rPr lang="fr-CA" b="0" i="0" smtClean="0">
+                        <a:latin typeface="Cambria Math" panose="02040503050406030204" pitchFamily="18" charset="0"/>
+                      </a:rPr>
+                      <m:t>max</m:t>
+                    </m:r>
+                    <m:r>
+                      <a:rPr lang="fr-CA" b="0" i="1" smtClean="0">
+                        <a:latin typeface="Cambria Math" panose="02040503050406030204" pitchFamily="18" charset="0"/>
+                      </a:rPr>
+                      <m:t>⁡(</m:t>
+                    </m:r>
+                    <m:sSub>
+                      <m:sSubPr>
+                        <m:ctrlPr>
+                          <a:rPr lang="fr-CA" b="0" i="1" smtClean="0">
+                            <a:latin typeface="Cambria Math" panose="02040503050406030204" pitchFamily="18" charset="0"/>
+                          </a:rPr>
+                        </m:ctrlPr>
+                      </m:sSubPr>
+                      <m:e>
+                        <m:r>
+                          <a:rPr lang="fr-CA" b="0" i="1" smtClean="0">
+                            <a:latin typeface="Cambria Math" panose="02040503050406030204" pitchFamily="18" charset="0"/>
+                          </a:rPr>
+                          <m:t>𝑘</m:t>
+                        </m:r>
+                      </m:e>
+                      <m:sub>
+                        <m:r>
+                          <a:rPr lang="fr-CA" b="0" i="1" smtClean="0">
+                            <a:latin typeface="Cambria Math" panose="02040503050406030204" pitchFamily="18" charset="0"/>
+                          </a:rPr>
+                          <m:t>𝑚𝑒𝑑𝑖𝑎𝑛𝑒</m:t>
+                        </m:r>
+                      </m:sub>
+                    </m:sSub>
+                    <m:r>
+                      <a:rPr lang="fr-CA" b="0" i="1" smtClean="0">
+                        <a:latin typeface="Cambria Math" panose="02040503050406030204" pitchFamily="18" charset="0"/>
+                      </a:rPr>
+                      <m:t>−</m:t>
+                    </m:r>
+                    <m:sSub>
+                      <m:sSubPr>
+                        <m:ctrlPr>
+                          <a:rPr lang="fr-CA" b="0" i="1" smtClean="0">
+                            <a:latin typeface="Cambria Math" panose="02040503050406030204" pitchFamily="18" charset="0"/>
+                          </a:rPr>
+                        </m:ctrlPr>
+                      </m:sSubPr>
+                      <m:e>
+                        <m:r>
+                          <a:rPr lang="fr-CA" b="0" i="1" smtClean="0">
+                            <a:latin typeface="Cambria Math" panose="02040503050406030204" pitchFamily="18" charset="0"/>
+                          </a:rPr>
+                          <m:t>𝑘</m:t>
+                        </m:r>
+                      </m:e>
+                      <m:sub>
+                        <m:r>
+                          <a:rPr lang="fr-CA" b="0" i="1" smtClean="0">
+                            <a:latin typeface="Cambria Math" panose="02040503050406030204" pitchFamily="18" charset="0"/>
+                          </a:rPr>
+                          <m:t>𝑚𝑖𝑛</m:t>
+                        </m:r>
+                      </m:sub>
+                    </m:sSub>
+                    <m:r>
+                      <a:rPr lang="fr-CA" b="0" i="1" smtClean="0">
+                        <a:latin typeface="Cambria Math" panose="02040503050406030204" pitchFamily="18" charset="0"/>
+                      </a:rPr>
+                      <m:t>, </m:t>
+                    </m:r>
+                    <m:sSub>
+                      <m:sSubPr>
+                        <m:ctrlPr>
+                          <a:rPr lang="fr-CA" b="0" i="1" smtClean="0">
+                            <a:latin typeface="Cambria Math" panose="02040503050406030204" pitchFamily="18" charset="0"/>
+                          </a:rPr>
+                        </m:ctrlPr>
+                      </m:sSubPr>
+                      <m:e>
+                        <m:r>
+                          <a:rPr lang="fr-CA" b="0" i="1" smtClean="0">
+                            <a:latin typeface="Cambria Math" panose="02040503050406030204" pitchFamily="18" charset="0"/>
+                          </a:rPr>
+                          <m:t>𝑘</m:t>
+                        </m:r>
+                      </m:e>
+                      <m:sub>
+                        <m:r>
+                          <a:rPr lang="fr-CA" b="0" i="1" smtClean="0">
+                            <a:latin typeface="Cambria Math" panose="02040503050406030204" pitchFamily="18" charset="0"/>
+                          </a:rPr>
+                          <m:t>𝑚𝑎𝑥</m:t>
+                        </m:r>
+                      </m:sub>
+                    </m:sSub>
+                    <m:r>
+                      <a:rPr lang="fr-CA" b="0" i="1" smtClean="0">
+                        <a:latin typeface="Cambria Math" panose="02040503050406030204" pitchFamily="18" charset="0"/>
+                      </a:rPr>
+                      <m:t>−</m:t>
+                    </m:r>
+                    <m:sSub>
+                      <m:sSubPr>
+                        <m:ctrlPr>
+                          <a:rPr lang="fr-CA" b="0" i="1" smtClean="0">
+                            <a:latin typeface="Cambria Math" panose="02040503050406030204" pitchFamily="18" charset="0"/>
+                          </a:rPr>
+                        </m:ctrlPr>
+                      </m:sSubPr>
+                      <m:e>
+                        <m:r>
+                          <a:rPr lang="fr-CA" b="0" i="1" smtClean="0">
+                            <a:latin typeface="Cambria Math" panose="02040503050406030204" pitchFamily="18" charset="0"/>
+                          </a:rPr>
+                          <m:t>𝑘</m:t>
+                        </m:r>
+                      </m:e>
+                      <m:sub>
+                        <m:r>
+                          <a:rPr lang="fr-CA" b="0" i="1" smtClean="0">
+                            <a:latin typeface="Cambria Math" panose="02040503050406030204" pitchFamily="18" charset="0"/>
+                          </a:rPr>
+                          <m:t>𝑚𝑒𝑑𝑖𝑎𝑛𝑒</m:t>
+                        </m:r>
+                      </m:sub>
+                    </m:sSub>
+                    <m:r>
+                      <a:rPr lang="fr-CA" b="0" i="0" smtClean="0">
+                        <a:latin typeface="Cambria Math" panose="02040503050406030204" pitchFamily="18" charset="0"/>
+                      </a:rPr>
+                      <m:t>)</m:t>
+                    </m:r>
+                  </m:oMath>
+                </a14:m>
+                <a:endParaRPr lang="fr-FR" dirty="0"/>
+              </a:p>
+            </p:txBody>
+          </p:sp>
+        </mc:Choice>
+        <mc:Fallback>
+          <p:sp>
+            <p:nvSpPr>
+              <p:cNvPr id="3" name="Espace réservé du contenu 2">
+                <a:extLst>
+                  <a:ext uri="{FF2B5EF4-FFF2-40B4-BE49-F238E27FC236}">
+                    <a16:creationId xmlns:a16="http://schemas.microsoft.com/office/drawing/2014/main" id="{A6CA13C1-0552-592F-8A56-718E46BDA011}"/>
+                  </a:ext>
+                </a:extLst>
+              </p:cNvPr>
+              <p:cNvSpPr>
+                <a:spLocks noGrp="1" noRot="1" noChangeAspect="1" noMove="1" noResize="1" noEditPoints="1" noAdjustHandles="1" noChangeArrowheads="1" noChangeShapeType="1" noTextEdit="1"/>
+              </p:cNvSpPr>
+              <p:nvPr>
+                <p:ph idx="1"/>
+              </p:nvPr>
+            </p:nvSpPr>
+            <p:spPr>
+              <a:xfrm>
+                <a:off x="838200" y="1580884"/>
+                <a:ext cx="10515600" cy="4351338"/>
+              </a:xfrm>
+              <a:blipFill>
+                <a:blip r:embed="rId4"/>
+                <a:stretch>
+                  <a:fillRect l="-406" t="-1961" r="-870"/>
+                </a:stretch>
+              </a:blipFill>
+            </p:spPr>
+            <p:txBody>
+              <a:bodyPr/>
+              <a:lstStyle/>
+              <a:p>
+                <a:r>
+                  <a:rPr lang="fr-CA">
+                    <a:noFill/>
+                  </a:rPr>
+                  <a:t> </a:t>
+                </a:r>
+              </a:p>
+            </p:txBody>
+          </p:sp>
+        </mc:Fallback>
+      </mc:AlternateContent>
     </p:spTree>
     <p:extLst>
       <p:ext uri="{BB962C8B-B14F-4D97-AF65-F5344CB8AC3E}">
@@ -5902,6 +7098,293 @@
 </file>
 
 <file path=ppt/slides/slide6.xml><?xml version="1.0" encoding="utf-8"?>
+<p:sld xmlns:a="http://schemas.openxmlformats.org/drawingml/2006/main" xmlns:r="http://schemas.openxmlformats.org/officeDocument/2006/relationships" xmlns:p="http://schemas.openxmlformats.org/presentationml/2006/main">
+  <p:cSld>
+    <p:spTree>
+      <p:nvGrpSpPr>
+        <p:cNvPr id="1" name="">
+          <a:extLst>
+            <a:ext uri="{FF2B5EF4-FFF2-40B4-BE49-F238E27FC236}">
+              <a16:creationId xmlns:a16="http://schemas.microsoft.com/office/drawing/2014/main" id="{4C7F3900-E8F2-B59F-8037-8B8AD280B857}"/>
+            </a:ext>
+          </a:extLst>
+        </p:cNvPr>
+        <p:cNvGrpSpPr/>
+        <p:nvPr/>
+      </p:nvGrpSpPr>
+      <p:grpSpPr>
+        <a:xfrm>
+          <a:off x="0" y="0"/>
+          <a:ext cx="0" cy="0"/>
+          <a:chOff x="0" y="0"/>
+          <a:chExt cx="0" cy="0"/>
+        </a:xfrm>
+      </p:grpSpPr>
+      <mc:AlternateContent xmlns:mc="http://schemas.openxmlformats.org/markup-compatibility/2006" xmlns:a14="http://schemas.microsoft.com/office/drawing/2010/main">
+        <mc:Choice Requires="a14">
+          <p:sp>
+            <p:nvSpPr>
+              <p:cNvPr id="2" name="Titre 1">
+                <a:extLst>
+                  <a:ext uri="{FF2B5EF4-FFF2-40B4-BE49-F238E27FC236}">
+                    <a16:creationId xmlns:a16="http://schemas.microsoft.com/office/drawing/2014/main" id="{DF82B067-B537-3E0F-96D6-2FFA9E4B2202}"/>
+                  </a:ext>
+                </a:extLst>
+              </p:cNvPr>
+              <p:cNvSpPr>
+                <a:spLocks noGrp="1"/>
+              </p:cNvSpPr>
+              <p:nvPr>
+                <p:ph type="title"/>
+              </p:nvPr>
+            </p:nvSpPr>
+            <p:spPr>
+              <a:xfrm>
+                <a:off x="838200" y="255321"/>
+                <a:ext cx="10515600" cy="1325563"/>
+              </a:xfrm>
+            </p:spPr>
+            <p:txBody>
+              <a:bodyPr>
+                <a:normAutofit fontScale="90000"/>
+              </a:bodyPr>
+              <a:lstStyle/>
+              <a:p>
+                <a:r>
+                  <a:rPr lang="fr-FR" dirty="0"/>
+                  <a:t>B) Incertitude sur les données d’entrée </a:t>
+                </a:r>
+                <a14:m>
+                  <m:oMath xmlns:m="http://schemas.openxmlformats.org/officeDocument/2006/math">
+                    <m:sSub>
+                      <m:sSubPr>
+                        <m:ctrlPr>
+                          <a:rPr lang="fr-FR" b="0" i="1" smtClean="0">
+                            <a:latin typeface="Cambria Math" panose="02040503050406030204" pitchFamily="18" charset="0"/>
+                          </a:rPr>
+                        </m:ctrlPr>
+                      </m:sSubPr>
+                      <m:e>
+                        <m:r>
+                          <a:rPr lang="fr-FR" b="0" i="1" smtClean="0">
+                            <a:latin typeface="Cambria Math" panose="02040503050406030204" pitchFamily="18" charset="0"/>
+                          </a:rPr>
+                          <m:t>𝑢</m:t>
+                        </m:r>
+                      </m:e>
+                      <m:sub>
+                        <m:r>
+                          <a:rPr lang="fr-FR" b="0" i="1" smtClean="0">
+                            <a:latin typeface="Cambria Math" panose="02040503050406030204" pitchFamily="18" charset="0"/>
+                          </a:rPr>
+                          <m:t>𝑖𝑛𝑝𝑢𝑡</m:t>
+                        </m:r>
+                      </m:sub>
+                    </m:sSub>
+                  </m:oMath>
+                </a14:m>
+                <a:br>
+                  <a:rPr lang="fr-FR" b="0" dirty="0"/>
+                </a:br>
+                <a:endParaRPr lang="fr-FR" dirty="0"/>
+              </a:p>
+            </p:txBody>
+          </p:sp>
+        </mc:Choice>
+        <mc:Fallback xmlns="">
+          <p:sp>
+            <p:nvSpPr>
+              <p:cNvPr id="2" name="Titre 1">
+                <a:extLst>
+                  <a:ext uri="{FF2B5EF4-FFF2-40B4-BE49-F238E27FC236}">
+                    <a16:creationId xmlns:a16="http://schemas.microsoft.com/office/drawing/2014/main" id="{E42DB292-C1C7-B7A1-2983-182756BDF140}"/>
+                  </a:ext>
+                </a:extLst>
+              </p:cNvPr>
+              <p:cNvSpPr>
+                <a:spLocks noGrp="1" noRot="1" noChangeAspect="1" noMove="1" noResize="1" noEditPoints="1" noAdjustHandles="1" noChangeArrowheads="1" noChangeShapeType="1" noTextEdit="1"/>
+              </p:cNvSpPr>
+              <p:nvPr>
+                <p:ph type="title"/>
+              </p:nvPr>
+            </p:nvSpPr>
+            <p:spPr>
+              <a:xfrm>
+                <a:off x="838200" y="255321"/>
+                <a:ext cx="10515600" cy="1325563"/>
+              </a:xfrm>
+              <a:blipFill>
+                <a:blip r:embed="rId3"/>
+                <a:stretch>
+                  <a:fillRect l="-2087" t="-7834"/>
+                </a:stretch>
+              </a:blipFill>
+            </p:spPr>
+            <p:txBody>
+              <a:bodyPr/>
+              <a:lstStyle/>
+              <a:p>
+                <a:r>
+                  <a:rPr lang="fr-FR">
+                    <a:noFill/>
+                  </a:rPr>
+                  <a:t> </a:t>
+                </a:r>
+              </a:p>
+            </p:txBody>
+          </p:sp>
+        </mc:Fallback>
+      </mc:AlternateContent>
+      <mc:AlternateContent xmlns:mc="http://schemas.openxmlformats.org/markup-compatibility/2006">
+        <mc:Choice xmlns:a14="http://schemas.microsoft.com/office/drawing/2010/main" Requires="a14">
+          <p:sp>
+            <p:nvSpPr>
+              <p:cNvPr id="3" name="Espace réservé du contenu 2">
+                <a:extLst>
+                  <a:ext uri="{FF2B5EF4-FFF2-40B4-BE49-F238E27FC236}">
+                    <a16:creationId xmlns:a16="http://schemas.microsoft.com/office/drawing/2014/main" id="{6B684BD0-48B3-023C-548F-8DC561A6A601}"/>
+                  </a:ext>
+                </a:extLst>
+              </p:cNvPr>
+              <p:cNvSpPr>
+                <a:spLocks noGrp="1"/>
+              </p:cNvSpPr>
+              <p:nvPr>
+                <p:ph idx="1"/>
+              </p:nvPr>
+            </p:nvSpPr>
+            <p:spPr>
+              <a:xfrm>
+                <a:off x="838199" y="1580884"/>
+                <a:ext cx="4080309" cy="3597508"/>
+              </a:xfrm>
+            </p:spPr>
+            <p:txBody>
+              <a:bodyPr>
+                <a:normAutofit/>
+              </a:bodyPr>
+              <a:lstStyle/>
+              <a:p>
+                <a:r>
+                  <a:rPr lang="fr-FR" sz="2000" dirty="0"/>
+                  <a:t>Les graphiques suivants présentent la fonction de probabilité ainsi que la fonction de probabilité cumulative de la SRQ.</a:t>
+                </a:r>
+              </a:p>
+              <a:p>
+                <a:r>
+                  <a:rPr lang="fr-FR" sz="2000" dirty="0"/>
+                  <a:t>On observe un résultat assez satisfaisant.</a:t>
+                </a:r>
+              </a:p>
+              <a:p>
+                <a:r>
+                  <a:rPr lang="fr-FR" sz="2000" dirty="0"/>
+                  <a:t>L’intervalle maximal est calculé :</a:t>
+                </a:r>
+                <a:br>
+                  <a:rPr lang="fr-FR" sz="2000" dirty="0"/>
+                </a:br>
+                <a14:m>
+                  <m:oMath xmlns:m="http://schemas.openxmlformats.org/officeDocument/2006/math">
+                    <m:sSub>
+                      <m:sSubPr>
+                        <m:ctrlPr>
+                          <a:rPr lang="fr-CA" sz="2000" b="1" i="1" smtClean="0">
+                            <a:latin typeface="Cambria Math" panose="02040503050406030204" pitchFamily="18" charset="0"/>
+                          </a:rPr>
+                        </m:ctrlPr>
+                      </m:sSubPr>
+                      <m:e>
+                        <m:r>
+                          <a:rPr lang="fr-CA" sz="2000" b="1" i="1" smtClean="0">
+                            <a:latin typeface="Cambria Math" panose="02040503050406030204" pitchFamily="18" charset="0"/>
+                          </a:rPr>
+                          <m:t>𝒖</m:t>
+                        </m:r>
+                      </m:e>
+                      <m:sub>
+                        <m:r>
+                          <a:rPr lang="fr-CA" sz="2000" b="1" i="1" smtClean="0">
+                            <a:latin typeface="Cambria Math" panose="02040503050406030204" pitchFamily="18" charset="0"/>
+                          </a:rPr>
+                          <m:t>𝒊𝒏𝒑𝒖𝒕</m:t>
+                        </m:r>
+                      </m:sub>
+                    </m:sSub>
+                    <m:r>
+                      <a:rPr lang="fr-CA" sz="2000" b="1" i="1" smtClean="0">
+                        <a:latin typeface="Cambria Math" panose="02040503050406030204" pitchFamily="18" charset="0"/>
+                      </a:rPr>
+                      <m:t>= </m:t>
+                    </m:r>
+                  </m:oMath>
+                </a14:m>
+                <a:endParaRPr lang="fr-FR" sz="2000" b="1" dirty="0"/>
+              </a:p>
+              <a:p>
+                <a:endParaRPr lang="fr-FR" b="1" dirty="0"/>
+              </a:p>
+            </p:txBody>
+          </p:sp>
+        </mc:Choice>
+        <mc:Fallback>
+          <p:sp>
+            <p:nvSpPr>
+              <p:cNvPr id="3" name="Espace réservé du contenu 2">
+                <a:extLst>
+                  <a:ext uri="{FF2B5EF4-FFF2-40B4-BE49-F238E27FC236}">
+                    <a16:creationId xmlns:a16="http://schemas.microsoft.com/office/drawing/2014/main" id="{6B684BD0-48B3-023C-548F-8DC561A6A601}"/>
+                  </a:ext>
+                </a:extLst>
+              </p:cNvPr>
+              <p:cNvSpPr>
+                <a:spLocks noGrp="1" noRot="1" noChangeAspect="1" noMove="1" noResize="1" noEditPoints="1" noAdjustHandles="1" noChangeArrowheads="1" noChangeShapeType="1" noTextEdit="1"/>
+              </p:cNvSpPr>
+              <p:nvPr>
+                <p:ph idx="1"/>
+              </p:nvPr>
+            </p:nvSpPr>
+            <p:spPr>
+              <a:xfrm>
+                <a:off x="838199" y="1580884"/>
+                <a:ext cx="4080309" cy="3597508"/>
+              </a:xfrm>
+              <a:blipFill>
+                <a:blip r:embed="rId4"/>
+                <a:stretch>
+                  <a:fillRect l="-1194" t="-1525"/>
+                </a:stretch>
+              </a:blipFill>
+            </p:spPr>
+            <p:txBody>
+              <a:bodyPr/>
+              <a:lstStyle/>
+              <a:p>
+                <a:r>
+                  <a:rPr lang="fr-CA">
+                    <a:noFill/>
+                  </a:rPr>
+                  <a:t> </a:t>
+                </a:r>
+              </a:p>
+            </p:txBody>
+          </p:sp>
+        </mc:Fallback>
+      </mc:AlternateContent>
+    </p:spTree>
+    <p:extLst>
+      <p:ext uri="{BB962C8B-B14F-4D97-AF65-F5344CB8AC3E}">
+        <p14:creationId xmlns:p14="http://schemas.microsoft.com/office/powerpoint/2010/main" val="135364426"/>
+      </p:ext>
+    </p:extLst>
+  </p:cSld>
+  <p:clrMapOvr>
+    <a:masterClrMapping/>
+  </p:clrMapOvr>
+</p:sld>
+</file>
+
+<file path=ppt/slides/slide7.xml><?xml version="1.0" encoding="utf-8"?>
 <p:sld xmlns:a="http://schemas.openxmlformats.org/drawingml/2006/main" xmlns:r="http://schemas.openxmlformats.org/officeDocument/2006/relationships" xmlns:p="http://schemas.openxmlformats.org/presentationml/2006/main">
   <p:cSld>
     <p:spTree>
@@ -6039,8 +7522,8 @@
           </p:sp>
         </mc:Fallback>
       </mc:AlternateContent>
-      <mc:AlternateContent xmlns:mc="http://schemas.openxmlformats.org/markup-compatibility/2006" xmlns:a14="http://schemas.microsoft.com/office/drawing/2010/main">
-        <mc:Choice Requires="a14">
+      <mc:AlternateContent xmlns:mc="http://schemas.openxmlformats.org/markup-compatibility/2006">
+        <mc:Choice xmlns:a14="http://schemas.microsoft.com/office/drawing/2010/main" Requires="a14">
           <p:sp>
             <p:nvSpPr>
               <p:cNvPr id="3" name="Espace réservé du contenu 2">
@@ -6173,30 +7656,30 @@
                     <m:sSub>
                       <m:sSubPr>
                         <m:ctrlPr>
-                          <a:rPr lang="fr-FR" b="0" i="1" smtClean="0">
+                          <a:rPr lang="fr-FR" b="1" i="1" smtClean="0">
                             <a:latin typeface="Cambria Math" panose="02040503050406030204" pitchFamily="18" charset="0"/>
                           </a:rPr>
                         </m:ctrlPr>
                       </m:sSubPr>
                       <m:e>
                         <m:r>
-                          <a:rPr lang="fr-FR" b="0" i="1" smtClean="0">
-                            <a:latin typeface="Cambria Math" panose="02040503050406030204" pitchFamily="18" charset="0"/>
-                          </a:rPr>
-                          <m:t>𝑢</m:t>
+                          <a:rPr lang="fr-FR" b="1" i="1" smtClean="0">
+                            <a:latin typeface="Cambria Math" panose="02040503050406030204" pitchFamily="18" charset="0"/>
+                          </a:rPr>
+                          <m:t>𝒖</m:t>
                         </m:r>
                       </m:e>
                       <m:sub>
                         <m:r>
-                          <a:rPr lang="fr-FR" b="0" i="1" smtClean="0">
-                            <a:latin typeface="Cambria Math" panose="02040503050406030204" pitchFamily="18" charset="0"/>
-                          </a:rPr>
-                          <m:t>𝐷</m:t>
+                          <a:rPr lang="fr-FR" b="1" i="1" smtClean="0">
+                            <a:latin typeface="Cambria Math" panose="02040503050406030204" pitchFamily="18" charset="0"/>
+                          </a:rPr>
+                          <m:t>𝑫</m:t>
                         </m:r>
                       </m:sub>
                     </m:sSub>
                     <m:r>
-                      <a:rPr lang="fr-FR" b="0" i="1" smtClean="0">
+                      <a:rPr lang="fr-FR" b="1" i="1" smtClean="0">
                         <a:latin typeface="Cambria Math" panose="02040503050406030204" pitchFamily="18" charset="0"/>
                       </a:rPr>
                       <m:t>=</m:t>
@@ -6205,7 +7688,7 @@
                       <m:radPr>
                         <m:degHide m:val="on"/>
                         <m:ctrlPr>
-                          <a:rPr lang="fr-FR" b="0" i="1" smtClean="0">
+                          <a:rPr lang="fr-FR" b="1" i="1" smtClean="0">
                             <a:latin typeface="Cambria Math" panose="02040503050406030204" pitchFamily="18" charset="0"/>
                           </a:rPr>
                         </m:ctrlPr>
@@ -6215,79 +7698,79 @@
                         <m:sSubSup>
                           <m:sSubSupPr>
                             <m:ctrlPr>
-                              <a:rPr lang="fr-FR" b="0" i="1" smtClean="0">
+                              <a:rPr lang="fr-FR" b="1" i="1" smtClean="0">
                                 <a:latin typeface="Cambria Math" panose="02040503050406030204" pitchFamily="18" charset="0"/>
                               </a:rPr>
                             </m:ctrlPr>
                           </m:sSubSupPr>
                           <m:e>
                             <m:r>
-                              <a:rPr lang="fr-FR" b="0" i="1" smtClean="0">
+                              <a:rPr lang="fr-FR" b="1" i="1" smtClean="0">
                                 <a:latin typeface="Cambria Math" panose="02040503050406030204" pitchFamily="18" charset="0"/>
                               </a:rPr>
-                              <m:t>𝑆</m:t>
+                              <m:t>𝑺</m:t>
                             </m:r>
                           </m:e>
                           <m:sub>
                             <m:r>
-                              <a:rPr lang="fr-FR" b="0" i="1" smtClean="0">
+                              <a:rPr lang="fr-FR" b="1" i="1" smtClean="0">
                                 <a:latin typeface="Cambria Math" panose="02040503050406030204" pitchFamily="18" charset="0"/>
                               </a:rPr>
-                              <m:t>𝑟</m:t>
+                              <m:t>𝒓</m:t>
                             </m:r>
                           </m:sub>
                           <m:sup>
                             <m:r>
-                              <a:rPr lang="fr-FR" b="0" i="1" smtClean="0">
+                              <a:rPr lang="fr-FR" b="1" i="1" smtClean="0">
                                 <a:latin typeface="Cambria Math" panose="02040503050406030204" pitchFamily="18" charset="0"/>
                               </a:rPr>
-                              <m:t>2</m:t>
+                              <m:t>𝟐</m:t>
+                            </m:r>
+                          </m:sup>
+                        </m:sSubSup>
+                        <m:r>
+                          <a:rPr lang="fr-FR" b="1" i="1">
+                            <a:latin typeface="Cambria Math" panose="02040503050406030204" pitchFamily="18" charset="0"/>
+                          </a:rPr>
+                          <m:t>+</m:t>
+                        </m:r>
+                        <m:sSubSup>
+                          <m:sSubSupPr>
+                            <m:ctrlPr>
+                              <a:rPr lang="fr-FR" b="1" i="1">
+                                <a:latin typeface="Cambria Math" panose="02040503050406030204" pitchFamily="18" charset="0"/>
+                              </a:rPr>
+                            </m:ctrlPr>
+                          </m:sSubSupPr>
+                          <m:e>
+                            <m:r>
+                              <a:rPr lang="fr-FR" b="1" i="1">
+                                <a:latin typeface="Cambria Math" panose="02040503050406030204" pitchFamily="18" charset="0"/>
+                              </a:rPr>
+                              <m:t>𝑩</m:t>
+                            </m:r>
+                          </m:e>
+                          <m:sub>
+                            <m:r>
+                              <a:rPr lang="fr-FR" b="1" i="1">
+                                <a:latin typeface="Cambria Math" panose="02040503050406030204" pitchFamily="18" charset="0"/>
+                              </a:rPr>
+                              <m:t>𝒓</m:t>
+                            </m:r>
+                          </m:sub>
+                          <m:sup>
+                            <m:r>
+                              <a:rPr lang="fr-FR" b="1" i="1">
+                                <a:latin typeface="Cambria Math" panose="02040503050406030204" pitchFamily="18" charset="0"/>
+                              </a:rPr>
+                              <m:t>𝟐</m:t>
                             </m:r>
                           </m:sup>
                         </m:sSubSup>
                       </m:e>
                     </m:rad>
                     <m:r>
-                      <a:rPr lang="fr-FR" b="0" i="1" smtClean="0">
-                        <a:latin typeface="Cambria Math" panose="02040503050406030204" pitchFamily="18" charset="0"/>
-                      </a:rPr>
-                      <m:t>+</m:t>
-                    </m:r>
-                    <m:sSubSup>
-                      <m:sSubSupPr>
-                        <m:ctrlPr>
-                          <a:rPr lang="fr-FR" b="0" i="1" smtClean="0">
-                            <a:latin typeface="Cambria Math" panose="02040503050406030204" pitchFamily="18" charset="0"/>
-                          </a:rPr>
-                        </m:ctrlPr>
-                      </m:sSubSupPr>
-                      <m:e>
-                        <m:r>
-                          <a:rPr lang="fr-FR" b="0" i="1" smtClean="0">
-                            <a:latin typeface="Cambria Math" panose="02040503050406030204" pitchFamily="18" charset="0"/>
-                          </a:rPr>
-                          <m:t>𝐵</m:t>
-                        </m:r>
-                      </m:e>
-                      <m:sub>
-                        <m:r>
-                          <a:rPr lang="fr-FR" b="0" i="1" smtClean="0">
-                            <a:latin typeface="Cambria Math" panose="02040503050406030204" pitchFamily="18" charset="0"/>
-                          </a:rPr>
-                          <m:t>𝑟</m:t>
-                        </m:r>
-                      </m:sub>
-                      <m:sup>
-                        <m:r>
-                          <a:rPr lang="fr-FR" b="0" i="1" smtClean="0">
-                            <a:latin typeface="Cambria Math" panose="02040503050406030204" pitchFamily="18" charset="0"/>
-                          </a:rPr>
-                          <m:t>2</m:t>
-                        </m:r>
-                      </m:sup>
-                    </m:sSubSup>
-                    <m:r>
-                      <a:rPr lang="fr-FR" b="0" i="1" smtClean="0">
+                      <a:rPr lang="fr-FR" b="1" i="1" smtClean="0">
                         <a:latin typeface="Cambria Math" panose="02040503050406030204" pitchFamily="18" charset="0"/>
                       </a:rPr>
                       <m:t>=</m:t>
@@ -6296,7 +7779,7 @@
                       <m:radPr>
                         <m:degHide m:val="on"/>
                         <m:ctrlPr>
-                          <a:rPr lang="fr-FR" b="0" i="1" smtClean="0">
+                          <a:rPr lang="fr-FR" b="1" i="1" smtClean="0">
                             <a:latin typeface="Cambria Math" panose="02040503050406030204" pitchFamily="18" charset="0"/>
                           </a:rPr>
                         </m:ctrlPr>
@@ -6306,30 +7789,42 @@
                         <m:sSup>
                           <m:sSupPr>
                             <m:ctrlPr>
-                              <a:rPr lang="fr-FR" b="0" i="1" smtClean="0">
+                              <a:rPr lang="fr-FR" b="1" i="1" smtClean="0">
                                 <a:latin typeface="Cambria Math" panose="02040503050406030204" pitchFamily="18" charset="0"/>
                               </a:rPr>
                             </m:ctrlPr>
                           </m:sSupPr>
                           <m:e>
                             <m:r>
-                              <a:rPr lang="fr-FR" b="0" i="1" smtClean="0">
+                              <a:rPr lang="fr-FR" b="1" i="1" smtClean="0">
                                 <a:latin typeface="Cambria Math" panose="02040503050406030204" pitchFamily="18" charset="0"/>
                               </a:rPr>
-                              <m:t>10.0</m:t>
+                              <m:t>𝟏𝟎</m:t>
+                            </m:r>
+                            <m:r>
+                              <a:rPr lang="fr-FR" b="1" i="1" smtClean="0">
+                                <a:latin typeface="Cambria Math" panose="02040503050406030204" pitchFamily="18" charset="0"/>
+                              </a:rPr>
+                              <m:t>.</m:t>
+                            </m:r>
+                            <m:r>
+                              <a:rPr lang="fr-FR" b="1" i="1" smtClean="0">
+                                <a:latin typeface="Cambria Math" panose="02040503050406030204" pitchFamily="18" charset="0"/>
+                              </a:rPr>
+                              <m:t>𝟎</m:t>
                             </m:r>
                           </m:e>
                           <m:sup>
                             <m:r>
-                              <a:rPr lang="fr-FR" b="0" i="1" smtClean="0">
+                              <a:rPr lang="fr-FR" b="1" i="1" smtClean="0">
                                 <a:latin typeface="Cambria Math" panose="02040503050406030204" pitchFamily="18" charset="0"/>
                               </a:rPr>
-                              <m:t>2</m:t>
+                              <m:t>𝟐</m:t>
                             </m:r>
                           </m:sup>
                         </m:sSup>
                         <m:r>
-                          <a:rPr lang="fr-FR" b="0" i="1" smtClean="0">
+                          <a:rPr lang="fr-FR" b="1" i="1" smtClean="0">
                             <a:latin typeface="Cambria Math" panose="02040503050406030204" pitchFamily="18" charset="0"/>
                           </a:rPr>
                           <m:t>+</m:t>
@@ -6337,75 +7832,111 @@
                         <m:sSup>
                           <m:sSupPr>
                             <m:ctrlPr>
-                              <a:rPr lang="fr-FR" b="0" i="1" smtClean="0">
+                              <a:rPr lang="fr-FR" b="1" i="1" smtClean="0">
                                 <a:latin typeface="Cambria Math" panose="02040503050406030204" pitchFamily="18" charset="0"/>
                               </a:rPr>
                             </m:ctrlPr>
                           </m:sSupPr>
                           <m:e>
                             <m:r>
-                              <a:rPr lang="fr-FR" b="0" i="1" smtClean="0">
+                              <a:rPr lang="fr-FR" b="1" i="1" smtClean="0">
                                 <a:latin typeface="Cambria Math" panose="02040503050406030204" pitchFamily="18" charset="0"/>
                               </a:rPr>
-                              <m:t>14.7</m:t>
+                              <m:t>𝟏𝟒</m:t>
+                            </m:r>
+                            <m:r>
+                              <a:rPr lang="fr-FR" b="1" i="1" smtClean="0">
+                                <a:latin typeface="Cambria Math" panose="02040503050406030204" pitchFamily="18" charset="0"/>
+                              </a:rPr>
+                              <m:t>.</m:t>
+                            </m:r>
+                            <m:r>
+                              <a:rPr lang="fr-FR" b="1" i="1" smtClean="0">
+                                <a:latin typeface="Cambria Math" panose="02040503050406030204" pitchFamily="18" charset="0"/>
+                              </a:rPr>
+                              <m:t>𝟕</m:t>
                             </m:r>
                           </m:e>
                           <m:sup>
                             <m:r>
-                              <a:rPr lang="fr-FR" b="0" i="1" smtClean="0">
+                              <a:rPr lang="fr-FR" b="1" i="1" smtClean="0">
                                 <a:latin typeface="Cambria Math" panose="02040503050406030204" pitchFamily="18" charset="0"/>
                               </a:rPr>
-                              <m:t>2</m:t>
+                              <m:t>𝟐</m:t>
                             </m:r>
                           </m:sup>
                         </m:sSup>
                       </m:e>
                     </m:rad>
                     <m:r>
-                      <a:rPr lang="fr-FR" b="0" i="1" smtClean="0">
+                      <a:rPr lang="fr-FR" b="1" i="1" smtClean="0">
                         <a:latin typeface="Cambria Math" panose="02040503050406030204" pitchFamily="18" charset="0"/>
                       </a:rPr>
-                      <m:t>=17.8 </m:t>
+                      <m:t>=</m:t>
                     </m:r>
                     <m:r>
-                      <a:rPr lang="fr-FR" b="0" i="1" smtClean="0">
+                      <a:rPr lang="fr-FR" b="1" i="1" smtClean="0">
                         <a:latin typeface="Cambria Math" panose="02040503050406030204" pitchFamily="18" charset="0"/>
                       </a:rPr>
-                      <m:t>𝜇</m:t>
+                      <m:t>𝟏𝟕</m:t>
+                    </m:r>
+                    <m:r>
+                      <a:rPr lang="fr-FR" b="1" i="1" smtClean="0">
+                        <a:latin typeface="Cambria Math" panose="02040503050406030204" pitchFamily="18" charset="0"/>
+                      </a:rPr>
+                      <m:t>.</m:t>
+                    </m:r>
+                    <m:r>
+                      <a:rPr lang="fr-FR" b="1" i="1" smtClean="0">
+                        <a:latin typeface="Cambria Math" panose="02040503050406030204" pitchFamily="18" charset="0"/>
+                      </a:rPr>
+                      <m:t>𝟖</m:t>
+                    </m:r>
+                    <m:r>
+                      <a:rPr lang="fr-FR" b="1" i="1" smtClean="0">
+                        <a:latin typeface="Cambria Math" panose="02040503050406030204" pitchFamily="18" charset="0"/>
+                      </a:rPr>
+                      <m:t> </m:t>
+                    </m:r>
+                    <m:r>
+                      <a:rPr lang="fr-FR" b="1" i="1" smtClean="0">
+                        <a:latin typeface="Cambria Math" panose="02040503050406030204" pitchFamily="18" charset="0"/>
+                      </a:rPr>
+                      <m:t>𝝁</m:t>
                     </m:r>
                     <m:sSup>
                       <m:sSupPr>
                         <m:ctrlPr>
-                          <a:rPr lang="fr-FR" b="0" i="1" smtClean="0">
+                          <a:rPr lang="fr-FR" b="1" i="1" smtClean="0">
                             <a:latin typeface="Cambria Math" panose="02040503050406030204" pitchFamily="18" charset="0"/>
                           </a:rPr>
                         </m:ctrlPr>
                       </m:sSupPr>
                       <m:e>
                         <m:r>
-                          <a:rPr lang="fr-FR" b="0" i="1" smtClean="0">
-                            <a:latin typeface="Cambria Math" panose="02040503050406030204" pitchFamily="18" charset="0"/>
-                          </a:rPr>
-                          <m:t>𝑚</m:t>
+                          <a:rPr lang="fr-FR" b="1" i="1" smtClean="0">
+                            <a:latin typeface="Cambria Math" panose="02040503050406030204" pitchFamily="18" charset="0"/>
+                          </a:rPr>
+                          <m:t>𝒎</m:t>
                         </m:r>
                       </m:e>
                       <m:sup>
                         <m:r>
-                          <a:rPr lang="fr-FR" b="0" i="1" smtClean="0">
-                            <a:latin typeface="Cambria Math" panose="02040503050406030204" pitchFamily="18" charset="0"/>
-                          </a:rPr>
-                          <m:t>2</m:t>
+                          <a:rPr lang="fr-FR" b="1" i="1" smtClean="0">
+                            <a:latin typeface="Cambria Math" panose="02040503050406030204" pitchFamily="18" charset="0"/>
+                          </a:rPr>
+                          <m:t>𝟐</m:t>
                         </m:r>
                       </m:sup>
                     </m:sSup>
                   </m:oMath>
                 </a14:m>
-                <a:endParaRPr lang="fr-FR" dirty="0"/>
+                <a:endParaRPr lang="fr-FR" b="1" dirty="0"/>
               </a:p>
             </p:txBody>
           </p:sp>
         </mc:Choice>
-        <mc:Fallback xmlns="">
+        <mc:Fallback>
           <p:sp>
             <p:nvSpPr>
               <p:cNvPr id="3" name="Espace réservé du contenu 2">
@@ -6435,7 +7966,7 @@
               <a:lstStyle/>
               <a:p>
                 <a:r>
-                  <a:rPr lang="fr-FR">
+                  <a:rPr lang="fr-CA">
                     <a:noFill/>
                   </a:rPr>
                   <a:t> </a:t>
@@ -6458,7 +7989,7 @@
 </p:sld>
 </file>
 
-<file path=ppt/slides/slide7.xml><?xml version="1.0" encoding="utf-8"?>
+<file path=ppt/slides/slide8.xml><?xml version="1.0" encoding="utf-8"?>
 <p:sld xmlns:a="http://schemas.openxmlformats.org/drawingml/2006/main" xmlns:r="http://schemas.openxmlformats.org/officeDocument/2006/relationships" xmlns:p="http://schemas.openxmlformats.org/presentationml/2006/main">
   <p:cSld>
     <p:spTree>
@@ -6739,7 +8270,7 @@
 </p:sld>
 </file>
 
-<file path=ppt/slides/slide8.xml><?xml version="1.0" encoding="utf-8"?>
+<file path=ppt/slides/slide9.xml><?xml version="1.0" encoding="utf-8"?>
 <p:sld xmlns:a="http://schemas.openxmlformats.org/drawingml/2006/main" xmlns:r="http://schemas.openxmlformats.org/officeDocument/2006/relationships" xmlns:p="http://schemas.openxmlformats.org/presentationml/2006/main">
   <p:cSld>
     <p:spTree>
@@ -7254,196 +8785,6 @@
     <p:extLst>
       <p:ext uri="{BB962C8B-B14F-4D97-AF65-F5344CB8AC3E}">
         <p14:creationId xmlns:p14="http://schemas.microsoft.com/office/powerpoint/2010/main" val="848531350"/>
-      </p:ext>
-    </p:extLst>
-  </p:cSld>
-  <p:clrMapOvr>
-    <a:masterClrMapping/>
-  </p:clrMapOvr>
-</p:sld>
-</file>
-
-<file path=ppt/slides/slide9.xml><?xml version="1.0" encoding="utf-8"?>
-<p:sld xmlns:a="http://schemas.openxmlformats.org/drawingml/2006/main" xmlns:r="http://schemas.openxmlformats.org/officeDocument/2006/relationships" xmlns:p="http://schemas.openxmlformats.org/presentationml/2006/main">
-  <p:cSld>
-    <p:spTree>
-      <p:nvGrpSpPr>
-        <p:cNvPr id="1" name=""/>
-        <p:cNvGrpSpPr/>
-        <p:nvPr/>
-      </p:nvGrpSpPr>
-      <p:grpSpPr>
-        <a:xfrm>
-          <a:off x="0" y="0"/>
-          <a:ext cx="0" cy="0"/>
-          <a:chOff x="0" y="0"/>
-          <a:chExt cx="0" cy="0"/>
-        </a:xfrm>
-      </p:grpSpPr>
-      <p:sp>
-        <p:nvSpPr>
-          <p:cNvPr id="2" name="Titre 1">
-            <a:extLst>
-              <a:ext uri="{FF2B5EF4-FFF2-40B4-BE49-F238E27FC236}">
-                <a16:creationId xmlns:a16="http://schemas.microsoft.com/office/drawing/2014/main" id="{952FD1E7-D507-F3B9-06EA-C4D755151F65}"/>
-              </a:ext>
-            </a:extLst>
-          </p:cNvPr>
-          <p:cNvSpPr>
-            <a:spLocks noGrp="1"/>
-          </p:cNvSpPr>
-          <p:nvPr>
-            <p:ph type="title"/>
-          </p:nvPr>
-        </p:nvSpPr>
-        <p:spPr/>
-        <p:txBody>
-          <a:bodyPr/>
-          <a:lstStyle/>
-          <a:p>
-            <a:r>
-              <a:rPr lang="fr-FR" dirty="0"/>
-              <a:t>Interprétation de l’intervalle de confiance </a:t>
-            </a:r>
-          </a:p>
-        </p:txBody>
-      </p:sp>
-      <mc:AlternateContent xmlns:mc="http://schemas.openxmlformats.org/markup-compatibility/2006" xmlns:a14="http://schemas.microsoft.com/office/drawing/2010/main">
-        <mc:Choice Requires="a14">
-          <p:sp>
-            <p:nvSpPr>
-              <p:cNvPr id="3" name="Espace réservé du contenu 2">
-                <a:extLst>
-                  <a:ext uri="{FF2B5EF4-FFF2-40B4-BE49-F238E27FC236}">
-                    <a16:creationId xmlns:a16="http://schemas.microsoft.com/office/drawing/2014/main" id="{5F231FAE-DF1D-EF42-B4E7-03EBF13AC650}"/>
-                  </a:ext>
-                </a:extLst>
-              </p:cNvPr>
-              <p:cNvSpPr>
-                <a:spLocks noGrp="1"/>
-              </p:cNvSpPr>
-              <p:nvPr>
-                <p:ph idx="1"/>
-              </p:nvPr>
-            </p:nvSpPr>
-            <p:spPr/>
-            <p:txBody>
-              <a:bodyPr/>
-              <a:lstStyle/>
-              <a:p>
-                <a:r>
-                  <a:rPr lang="fr-FR" b="0" dirty="0">
-                    <a:latin typeface="Cambria Math" panose="02040503050406030204" pitchFamily="18" charset="0"/>
-                  </a:rPr>
-                  <a:t>E par rapport à </a:t>
-                </a:r>
-                <a:r>
-                  <a:rPr lang="fr-FR" b="0" dirty="0" err="1">
-                    <a:latin typeface="Cambria Math" panose="02040503050406030204" pitchFamily="18" charset="0"/>
-                  </a:rPr>
-                  <a:t>u_val</a:t>
-                </a:r>
-                <a:r>
-                  <a:rPr lang="fr-FR" b="0" dirty="0">
-                    <a:latin typeface="Cambria Math" panose="02040503050406030204" pitchFamily="18" charset="0"/>
-                  </a:rPr>
-                  <a:t> ?</a:t>
-                </a:r>
-              </a:p>
-              <a:p>
-                <a:endParaRPr lang="fr-FR" b="0" i="1" dirty="0">
-                  <a:latin typeface="Cambria Math" panose="02040503050406030204" pitchFamily="18" charset="0"/>
-                </a:endParaRPr>
-              </a:p>
-              <a:p>
-                <a14:m>
-                  <m:oMath xmlns:m="http://schemas.openxmlformats.org/officeDocument/2006/math">
-                    <m:sSub>
-                      <m:sSubPr>
-                        <m:ctrlPr>
-                          <a:rPr lang="fr-FR" b="0" i="1" smtClean="0">
-                            <a:latin typeface="Cambria Math" panose="02040503050406030204" pitchFamily="18" charset="0"/>
-                          </a:rPr>
-                        </m:ctrlPr>
-                      </m:sSubPr>
-                      <m:e>
-                        <m:r>
-                          <a:rPr lang="fr-FR" b="0" i="1" smtClean="0">
-                            <a:latin typeface="Cambria Math" panose="02040503050406030204" pitchFamily="18" charset="0"/>
-                          </a:rPr>
-                          <m:t>𝑢</m:t>
-                        </m:r>
-                      </m:e>
-                      <m:sub>
-                        <m:r>
-                          <a:rPr lang="fr-FR" b="0" i="1" smtClean="0">
-                            <a:latin typeface="Cambria Math" panose="02040503050406030204" pitchFamily="18" charset="0"/>
-                          </a:rPr>
-                          <m:t>𝐷</m:t>
-                        </m:r>
-                      </m:sub>
-                    </m:sSub>
-                  </m:oMath>
-                </a14:m>
-                <a:r>
-                  <a:rPr lang="fr-FR" dirty="0"/>
-                  <a:t> semble être l’erreur prédominante dans la validation </a:t>
-                </a:r>
-                <a:r>
-                  <a:rPr lang="fr-FR" dirty="0">
-                    <a:sym typeface="Wingdings" panose="05000000000000000000" pitchFamily="2" charset="2"/>
-                  </a:rPr>
-                  <a:t> être plus précis sur les expériences  </a:t>
-                </a:r>
-                <a:endParaRPr lang="fr-FR" dirty="0"/>
-              </a:p>
-            </p:txBody>
-          </p:sp>
-        </mc:Choice>
-        <mc:Fallback xmlns="">
-          <p:sp>
-            <p:nvSpPr>
-              <p:cNvPr id="3" name="Espace réservé du contenu 2">
-                <a:extLst>
-                  <a:ext uri="{FF2B5EF4-FFF2-40B4-BE49-F238E27FC236}">
-                    <a16:creationId xmlns:a16="http://schemas.microsoft.com/office/drawing/2014/main" id="{5F231FAE-DF1D-EF42-B4E7-03EBF13AC650}"/>
-                  </a:ext>
-                </a:extLst>
-              </p:cNvPr>
-              <p:cNvSpPr>
-                <a:spLocks noGrp="1" noRot="1" noChangeAspect="1" noMove="1" noResize="1" noEditPoints="1" noAdjustHandles="1" noChangeArrowheads="1" noChangeShapeType="1" noTextEdit="1"/>
-              </p:cNvSpPr>
-              <p:nvPr>
-                <p:ph idx="1"/>
-              </p:nvPr>
-            </p:nvSpPr>
-            <p:spPr>
-              <a:blipFill>
-                <a:blip r:embed="rId2"/>
-                <a:stretch>
-                  <a:fillRect l="-1043" t="-2381"/>
-                </a:stretch>
-              </a:blipFill>
-            </p:spPr>
-            <p:txBody>
-              <a:bodyPr/>
-              <a:lstStyle/>
-              <a:p>
-                <a:r>
-                  <a:rPr lang="fr-FR">
-                    <a:noFill/>
-                  </a:rPr>
-                  <a:t> </a:t>
-                </a:r>
-              </a:p>
-            </p:txBody>
-          </p:sp>
-        </mc:Fallback>
-      </mc:AlternateContent>
-    </p:spTree>
-    <p:extLst>
-      <p:ext uri="{BB962C8B-B14F-4D97-AF65-F5344CB8AC3E}">
-        <p14:creationId xmlns:p14="http://schemas.microsoft.com/office/powerpoint/2010/main" val="1935114118"/>
       </p:ext>
     </p:extLst>
   </p:cSld>
@@ -7766,4 +9107,319 @@
     </a:ext>
   </a:extLst>
 </a:theme>
+</file>
+
+<file path=ppt/theme/theme2.xml><?xml version="1.0" encoding="utf-8"?>
+<a:theme xmlns:a="http://schemas.openxmlformats.org/drawingml/2006/main" name="Thème Office">
+  <a:themeElements>
+    <a:clrScheme name="Office">
+      <a:dk1>
+        <a:sysClr val="windowText" lastClr="000000"/>
+      </a:dk1>
+      <a:lt1>
+        <a:sysClr val="window" lastClr="FFFFFF"/>
+      </a:lt1>
+      <a:dk2>
+        <a:srgbClr val="0E2841"/>
+      </a:dk2>
+      <a:lt2>
+        <a:srgbClr val="E8E8E8"/>
+      </a:lt2>
+      <a:accent1>
+        <a:srgbClr val="156082"/>
+      </a:accent1>
+      <a:accent2>
+        <a:srgbClr val="E97132"/>
+      </a:accent2>
+      <a:accent3>
+        <a:srgbClr val="196B24"/>
+      </a:accent3>
+      <a:accent4>
+        <a:srgbClr val="0F9ED5"/>
+      </a:accent4>
+      <a:accent5>
+        <a:srgbClr val="A02B93"/>
+      </a:accent5>
+      <a:accent6>
+        <a:srgbClr val="4EA72E"/>
+      </a:accent6>
+      <a:hlink>
+        <a:srgbClr val="467886"/>
+      </a:hlink>
+      <a:folHlink>
+        <a:srgbClr val="96607D"/>
+      </a:folHlink>
+    </a:clrScheme>
+    <a:fontScheme name="Office">
+      <a:majorFont>
+        <a:latin typeface="Aptos Display" panose="02110004020202020204"/>
+        <a:ea typeface=""/>
+        <a:cs typeface=""/>
+        <a:font script="Jpan" typeface="游ゴシック Light"/>
+        <a:font script="Hang" typeface="맑은 고딕"/>
+        <a:font script="Hans" typeface="等线 Light"/>
+        <a:font script="Hant" typeface="新細明體"/>
+        <a:font script="Arab" typeface="Times New Roman"/>
+        <a:font script="Hebr" typeface="Times New Roman"/>
+        <a:font script="Thai" typeface="Angsana New"/>
+        <a:font script="Ethi" typeface="Nyala"/>
+        <a:font script="Beng" typeface="Vrinda"/>
+        <a:font script="Gujr" typeface="Shruti"/>
+        <a:font script="Khmr" typeface="MoolBoran"/>
+        <a:font script="Knda" typeface="Tunga"/>
+        <a:font script="Guru" typeface="Raavi"/>
+        <a:font script="Cans" typeface="Euphemia"/>
+        <a:font script="Cher" typeface="Plantagenet Cherokee"/>
+        <a:font script="Yiii" typeface="Microsoft Yi Baiti"/>
+        <a:font script="Tibt" typeface="Microsoft Himalaya"/>
+        <a:font script="Thaa" typeface="MV Boli"/>
+        <a:font script="Deva" typeface="Mangal"/>
+        <a:font script="Telu" typeface="Gautami"/>
+        <a:font script="Taml" typeface="Latha"/>
+        <a:font script="Syrc" typeface="Estrangelo Edessa"/>
+        <a:font script="Orya" typeface="Kalinga"/>
+        <a:font script="Mlym" typeface="Kartika"/>
+        <a:font script="Laoo" typeface="DokChampa"/>
+        <a:font script="Sinh" typeface="Iskoola Pota"/>
+        <a:font script="Mong" typeface="Mongolian Baiti"/>
+        <a:font script="Viet" typeface="Times New Roman"/>
+        <a:font script="Uigh" typeface="Microsoft Uighur"/>
+        <a:font script="Geor" typeface="Sylfaen"/>
+        <a:font script="Armn" typeface="Arial"/>
+        <a:font script="Bugi" typeface="Leelawadee UI"/>
+        <a:font script="Bopo" typeface="Microsoft JhengHei"/>
+        <a:font script="Java" typeface="Javanese Text"/>
+        <a:font script="Lisu" typeface="Segoe UI"/>
+        <a:font script="Mymr" typeface="Myanmar Text"/>
+        <a:font script="Nkoo" typeface="Ebrima"/>
+        <a:font script="Olck" typeface="Nirmala UI"/>
+        <a:font script="Osma" typeface="Ebrima"/>
+        <a:font script="Phag" typeface="Phagspa"/>
+        <a:font script="Syrn" typeface="Estrangelo Edessa"/>
+        <a:font script="Syrj" typeface="Estrangelo Edessa"/>
+        <a:font script="Syre" typeface="Estrangelo Edessa"/>
+        <a:font script="Sora" typeface="Nirmala UI"/>
+        <a:font script="Tale" typeface="Microsoft Tai Le"/>
+        <a:font script="Talu" typeface="Microsoft New Tai Lue"/>
+        <a:font script="Tfng" typeface="Ebrima"/>
+      </a:majorFont>
+      <a:minorFont>
+        <a:latin typeface="Aptos" panose="02110004020202020204"/>
+        <a:ea typeface=""/>
+        <a:cs typeface=""/>
+        <a:font script="Jpan" typeface="游ゴシック"/>
+        <a:font script="Hang" typeface="맑은 고딕"/>
+        <a:font script="Hans" typeface="等线"/>
+        <a:font script="Hant" typeface="新細明體"/>
+        <a:font script="Arab" typeface="Arial"/>
+        <a:font script="Hebr" typeface="Arial"/>
+        <a:font script="Thai" typeface="Cordia New"/>
+        <a:font script="Ethi" typeface="Nyala"/>
+        <a:font script="Beng" typeface="Vrinda"/>
+        <a:font script="Gujr" typeface="Shruti"/>
+        <a:font script="Khmr" typeface="DaunPenh"/>
+        <a:font script="Knda" typeface="Tunga"/>
+        <a:font script="Guru" typeface="Raavi"/>
+        <a:font script="Cans" typeface="Euphemia"/>
+        <a:font script="Cher" typeface="Plantagenet Cherokee"/>
+        <a:font script="Yiii" typeface="Microsoft Yi Baiti"/>
+        <a:font script="Tibt" typeface="Microsoft Himalaya"/>
+        <a:font script="Thaa" typeface="MV Boli"/>
+        <a:font script="Deva" typeface="Mangal"/>
+        <a:font script="Telu" typeface="Gautami"/>
+        <a:font script="Taml" typeface="Latha"/>
+        <a:font script="Syrc" typeface="Estrangelo Edessa"/>
+        <a:font script="Orya" typeface="Kalinga"/>
+        <a:font script="Mlym" typeface="Kartika"/>
+        <a:font script="Laoo" typeface="DokChampa"/>
+        <a:font script="Sinh" typeface="Iskoola Pota"/>
+        <a:font script="Mong" typeface="Mongolian Baiti"/>
+        <a:font script="Viet" typeface="Arial"/>
+        <a:font script="Uigh" typeface="Microsoft Uighur"/>
+        <a:font script="Geor" typeface="Sylfaen"/>
+        <a:font script="Armn" typeface="Arial"/>
+        <a:font script="Bugi" typeface="Leelawadee UI"/>
+        <a:font script="Bopo" typeface="Microsoft JhengHei"/>
+        <a:font script="Java" typeface="Javanese Text"/>
+        <a:font script="Lisu" typeface="Segoe UI"/>
+        <a:font script="Mymr" typeface="Myanmar Text"/>
+        <a:font script="Nkoo" typeface="Ebrima"/>
+        <a:font script="Olck" typeface="Nirmala UI"/>
+        <a:font script="Osma" typeface="Ebrima"/>
+        <a:font script="Phag" typeface="Phagspa"/>
+        <a:font script="Syrn" typeface="Estrangelo Edessa"/>
+        <a:font script="Syrj" typeface="Estrangelo Edessa"/>
+        <a:font script="Syre" typeface="Estrangelo Edessa"/>
+        <a:font script="Sora" typeface="Nirmala UI"/>
+        <a:font script="Tale" typeface="Microsoft Tai Le"/>
+        <a:font script="Talu" typeface="Microsoft New Tai Lue"/>
+        <a:font script="Tfng" typeface="Ebrima"/>
+      </a:minorFont>
+    </a:fontScheme>
+    <a:fmtScheme name="Office">
+      <a:fillStyleLst>
+        <a:solidFill>
+          <a:schemeClr val="phClr"/>
+        </a:solidFill>
+        <a:gradFill rotWithShape="1">
+          <a:gsLst>
+            <a:gs pos="0">
+              <a:schemeClr val="phClr">
+                <a:lumMod val="110000"/>
+                <a:satMod val="105000"/>
+                <a:tint val="67000"/>
+              </a:schemeClr>
+            </a:gs>
+            <a:gs pos="50000">
+              <a:schemeClr val="phClr">
+                <a:lumMod val="105000"/>
+                <a:satMod val="103000"/>
+                <a:tint val="73000"/>
+              </a:schemeClr>
+            </a:gs>
+            <a:gs pos="100000">
+              <a:schemeClr val="phClr">
+                <a:lumMod val="105000"/>
+                <a:satMod val="109000"/>
+                <a:tint val="81000"/>
+              </a:schemeClr>
+            </a:gs>
+          </a:gsLst>
+          <a:lin ang="5400000" scaled="0"/>
+        </a:gradFill>
+        <a:gradFill rotWithShape="1">
+          <a:gsLst>
+            <a:gs pos="0">
+              <a:schemeClr val="phClr">
+                <a:satMod val="103000"/>
+                <a:lumMod val="102000"/>
+                <a:tint val="94000"/>
+              </a:schemeClr>
+            </a:gs>
+            <a:gs pos="50000">
+              <a:schemeClr val="phClr">
+                <a:satMod val="110000"/>
+                <a:lumMod val="100000"/>
+                <a:shade val="100000"/>
+              </a:schemeClr>
+            </a:gs>
+            <a:gs pos="100000">
+              <a:schemeClr val="phClr">
+                <a:lumMod val="99000"/>
+                <a:satMod val="120000"/>
+                <a:shade val="78000"/>
+              </a:schemeClr>
+            </a:gs>
+          </a:gsLst>
+          <a:lin ang="5400000" scaled="0"/>
+        </a:gradFill>
+      </a:fillStyleLst>
+      <a:lnStyleLst>
+        <a:ln w="12700" cap="flat" cmpd="sng" algn="ctr">
+          <a:solidFill>
+            <a:schemeClr val="phClr"/>
+          </a:solidFill>
+          <a:prstDash val="solid"/>
+          <a:miter lim="800000"/>
+        </a:ln>
+        <a:ln w="19050" cap="flat" cmpd="sng" algn="ctr">
+          <a:solidFill>
+            <a:schemeClr val="phClr"/>
+          </a:solidFill>
+          <a:prstDash val="solid"/>
+          <a:miter lim="800000"/>
+        </a:ln>
+        <a:ln w="25400" cap="flat" cmpd="sng" algn="ctr">
+          <a:solidFill>
+            <a:schemeClr val="phClr"/>
+          </a:solidFill>
+          <a:prstDash val="solid"/>
+          <a:miter lim="800000"/>
+        </a:ln>
+      </a:lnStyleLst>
+      <a:effectStyleLst>
+        <a:effectStyle>
+          <a:effectLst/>
+        </a:effectStyle>
+        <a:effectStyle>
+          <a:effectLst/>
+        </a:effectStyle>
+        <a:effectStyle>
+          <a:effectLst>
+            <a:outerShdw blurRad="57150" dist="19050" dir="5400000" algn="ctr" rotWithShape="0">
+              <a:srgbClr val="000000">
+                <a:alpha val="63000"/>
+              </a:srgbClr>
+            </a:outerShdw>
+          </a:effectLst>
+        </a:effectStyle>
+      </a:effectStyleLst>
+      <a:bgFillStyleLst>
+        <a:solidFill>
+          <a:schemeClr val="phClr"/>
+        </a:solidFill>
+        <a:solidFill>
+          <a:schemeClr val="phClr">
+            <a:tint val="95000"/>
+            <a:satMod val="170000"/>
+          </a:schemeClr>
+        </a:solidFill>
+        <a:gradFill rotWithShape="1">
+          <a:gsLst>
+            <a:gs pos="0">
+              <a:schemeClr val="phClr">
+                <a:tint val="93000"/>
+                <a:satMod val="150000"/>
+                <a:shade val="98000"/>
+                <a:lumMod val="102000"/>
+              </a:schemeClr>
+            </a:gs>
+            <a:gs pos="50000">
+              <a:schemeClr val="phClr">
+                <a:tint val="98000"/>
+                <a:satMod val="130000"/>
+                <a:shade val="90000"/>
+                <a:lumMod val="103000"/>
+              </a:schemeClr>
+            </a:gs>
+            <a:gs pos="100000">
+              <a:schemeClr val="phClr">
+                <a:shade val="63000"/>
+                <a:satMod val="120000"/>
+              </a:schemeClr>
+            </a:gs>
+          </a:gsLst>
+          <a:lin ang="5400000" scaled="0"/>
+        </a:gradFill>
+      </a:bgFillStyleLst>
+    </a:fmtScheme>
+  </a:themeElements>
+  <a:objectDefaults>
+    <a:lnDef>
+      <a:spPr/>
+      <a:bodyPr/>
+      <a:lstStyle/>
+      <a:style>
+        <a:lnRef idx="2">
+          <a:schemeClr val="accent1"/>
+        </a:lnRef>
+        <a:fillRef idx="0">
+          <a:schemeClr val="accent1"/>
+        </a:fillRef>
+        <a:effectRef idx="1">
+          <a:schemeClr val="accent1"/>
+        </a:effectRef>
+        <a:fontRef idx="minor">
+          <a:schemeClr val="tx1"/>
+        </a:fontRef>
+      </a:style>
+    </a:lnDef>
+  </a:objectDefaults>
+  <a:extraClrSchemeLst/>
+  <a:extLst>
+    <a:ext uri="{05A4C25C-085E-4340-85A3-A5531E510DB2}">
+      <thm15:themeFamily xmlns:thm15="http://schemas.microsoft.com/office/thememl/2012/main" name="Office Theme" id="{2E142A2C-CD16-42D6-873A-C26D2A0506FA}" vid="{1BDDFF52-6CD6-40A5-AB3C-68EB2F1E4D0A}"/>
+    </a:ext>
+  </a:extLst>
+</a:theme>
 </file>
</xml_diff>

<commit_message>
Correction Section A : explication de la valeur abérante
</commit_message>
<xml_diff>
--- a/MEC8211-Devoir3.pptx
+++ b/MEC8211-Devoir3.pptx
@@ -5316,8 +5316,8 @@
           </a:p>
         </p:txBody>
       </p:sp>
-      <mc:AlternateContent xmlns:mc="http://schemas.openxmlformats.org/markup-compatibility/2006" xmlns:a14="http://schemas.microsoft.com/office/drawing/2010/main">
-        <mc:Choice Requires="a14">
+      <mc:AlternateContent xmlns:mc="http://schemas.openxmlformats.org/markup-compatibility/2006">
+        <mc:Choice xmlns:a14="http://schemas.microsoft.com/office/drawing/2010/main" Requires="a14">
           <p:sp>
             <p:nvSpPr>
               <p:cNvPr id="12" name="ZoneTexte 11">
@@ -5332,8 +5332,8 @@
             </p:nvSpPr>
             <p:spPr>
               <a:xfrm>
-                <a:off x="742384" y="1580884"/>
-                <a:ext cx="4001632" cy="4278094"/>
+                <a:off x="688063" y="1180652"/>
+                <a:ext cx="4001632" cy="5262979"/>
               </a:xfrm>
               <a:prstGeom prst="rect">
                 <a:avLst/>
@@ -5374,7 +5374,17 @@
                 </a:pPr>
                 <a:r>
                   <a:rPr lang="fr-CA" sz="1600" dirty="0"/>
-                  <a:t>La valeur la plus fine n’est pas dans la région asymptotique et donc n’est pas considérée dans le calcul de l’ordre observé.</a:t>
+                  <a:t>La valeur la plus fine n’est pas dans la région asymptotique et donc n’est pas considérée dans le calcul de l’ordre observé. Cela peut s’expliquer notamment par le fait que les données sont bruitées par la génération aléatoire des fibres et de l’incertitude sur la porosité.</a:t>
+                </a:r>
+              </a:p>
+              <a:p>
+                <a:pPr marL="285750" indent="-285750">
+                  <a:buFont typeface="Arial" panose="020B0604020202020204" pitchFamily="34" charset="0"/>
+                  <a:buChar char="•"/>
+                </a:pPr>
+                <a:r>
+                  <a:rPr lang="fr-CA" sz="1600" dirty="0"/>
+                  <a:t>Les barres d’erreur présentés dans ce graphique peuvent être interprétées comme étant les incertitudes des données d’entrée, qui seront calculées prochainement.</a:t>
                 </a:r>
               </a:p>
               <a:p>
@@ -5573,20 +5583,10 @@
                 </a14:m>
                 <a:endParaRPr lang="fr-CA" sz="1600" b="1" dirty="0"/>
               </a:p>
-              <a:p>
-                <a:pPr marL="285750" indent="-285750">
-                  <a:buFont typeface="Arial" panose="020B0604020202020204" pitchFamily="34" charset="0"/>
-                  <a:buChar char="•"/>
-                </a:pPr>
-                <a:r>
-                  <a:rPr lang="fr-CA" sz="1600" dirty="0"/>
-                  <a:t>Les barres d’erreur présentés dans ce graphique peuvent être interprétées comme étant les incertitudes des données d’entrée, qui seront calculées prochainement.</a:t>
-                </a:r>
-              </a:p>
             </p:txBody>
           </p:sp>
         </mc:Choice>
-        <mc:Fallback xmlns="">
+        <mc:Fallback>
           <p:sp>
             <p:nvSpPr>
               <p:cNvPr id="12" name="ZoneTexte 11">
@@ -5603,8 +5603,8 @@
             </p:nvSpPr>
             <p:spPr>
               <a:xfrm>
-                <a:off x="742384" y="1580884"/>
-                <a:ext cx="4001632" cy="4278094"/>
+                <a:off x="688063" y="1180652"/>
+                <a:ext cx="4001632" cy="5262979"/>
               </a:xfrm>
               <a:prstGeom prst="rect">
                 <a:avLst/>
@@ -5612,7 +5612,7 @@
               <a:blipFill>
                 <a:blip r:embed="rId4"/>
                 <a:stretch>
-                  <a:fillRect l="-610" t="-427" r="-305" b="-855"/>
+                  <a:fillRect l="-610" t="-348" r="-305"/>
                 </a:stretch>
               </a:blipFill>
             </p:spPr>
@@ -6596,8 +6596,8 @@
           </p:sp>
         </mc:Fallback>
       </mc:AlternateContent>
-      <mc:AlternateContent xmlns:mc="http://schemas.openxmlformats.org/markup-compatibility/2006">
-        <mc:Choice xmlns:a14="http://schemas.microsoft.com/office/drawing/2010/main" Requires="a14">
+      <mc:AlternateContent xmlns:mc="http://schemas.openxmlformats.org/markup-compatibility/2006" xmlns:a14="http://schemas.microsoft.com/office/drawing/2010/main">
+        <mc:Choice Requires="a14">
           <p:sp>
             <p:nvSpPr>
               <p:cNvPr id="3" name="Espace réservé du contenu 2">
@@ -7040,7 +7040,7 @@
             </p:txBody>
           </p:sp>
         </mc:Choice>
-        <mc:Fallback>
+        <mc:Fallback xmlns="">
           <p:sp>
             <p:nvSpPr>
               <p:cNvPr id="3" name="Espace réservé du contenu 2">
@@ -7235,8 +7235,8 @@
           </p:sp>
         </mc:Fallback>
       </mc:AlternateContent>
-      <mc:AlternateContent xmlns:mc="http://schemas.openxmlformats.org/markup-compatibility/2006">
-        <mc:Choice xmlns:a14="http://schemas.microsoft.com/office/drawing/2010/main" Requires="a14">
+      <mc:AlternateContent xmlns:mc="http://schemas.openxmlformats.org/markup-compatibility/2006" xmlns:a14="http://schemas.microsoft.com/office/drawing/2010/main">
+        <mc:Choice Requires="a14">
           <p:sp>
             <p:nvSpPr>
               <p:cNvPr id="3" name="Espace réservé du contenu 2">
@@ -7327,7 +7327,7 @@
             </p:txBody>
           </p:sp>
         </mc:Choice>
-        <mc:Fallback>
+        <mc:Fallback xmlns="">
           <p:sp>
             <p:nvSpPr>
               <p:cNvPr id="3" name="Espace réservé du contenu 2">
@@ -7522,8 +7522,8 @@
           </p:sp>
         </mc:Fallback>
       </mc:AlternateContent>
-      <mc:AlternateContent xmlns:mc="http://schemas.openxmlformats.org/markup-compatibility/2006">
-        <mc:Choice xmlns:a14="http://schemas.microsoft.com/office/drawing/2010/main" Requires="a14">
+      <mc:AlternateContent xmlns:mc="http://schemas.openxmlformats.org/markup-compatibility/2006" xmlns:a14="http://schemas.microsoft.com/office/drawing/2010/main">
+        <mc:Choice Requires="a14">
           <p:sp>
             <p:nvSpPr>
               <p:cNvPr id="3" name="Espace réservé du contenu 2">
@@ -7936,7 +7936,7 @@
             </p:txBody>
           </p:sp>
         </mc:Choice>
-        <mc:Fallback>
+        <mc:Fallback xmlns="">
           <p:sp>
             <p:nvSpPr>
               <p:cNvPr id="3" name="Espace réservé du contenu 2">

</xml_diff>